<commit_message>
Polish the public release and complete the Firebase submission kit
</commit_message>
<xml_diff>
--- a/docs/deliverables/KindHandoff-Pitch.pptx
+++ b/docs/deliverables/KindHandoff-Pitch.pptx
@@ -2,20 +2,20 @@
 <file path=ppt/presentation.xml><?xml version="1.0" encoding="utf-8"?>
 <p:presentation xmlns:p="http://schemas.openxmlformats.org/presentationml/2006/main">
   <p:sldMasterIdLst>
-    <p:sldMasterId xmlns:r="http://schemas.openxmlformats.org/officeDocument/2006/relationships" id="2147483648" r:id="R7373a57611f74250"/>
+    <p:sldMasterId xmlns:r="http://schemas.openxmlformats.org/officeDocument/2006/relationships" id="2147483648" r:id="R84e28a3d1abc401c"/>
   </p:sldMasterIdLst>
   <p:notesMasterIdLst>
-    <p:notesMasterId xmlns:r="http://schemas.openxmlformats.org/officeDocument/2006/relationships" r:id="R5650085b477b40bb"/>
+    <p:notesMasterId xmlns:r="http://schemas.openxmlformats.org/officeDocument/2006/relationships" r:id="Rb276a4d8c6d1469a"/>
   </p:notesMasterIdLst>
   <p:sldIdLst>
-    <p:sldId xmlns:r="http://schemas.openxmlformats.org/officeDocument/2006/relationships" id="256" r:id="Rd527091ffde44689"/>
-    <p:sldId xmlns:r="http://schemas.openxmlformats.org/officeDocument/2006/relationships" id="257" r:id="R4ba55b0609994550"/>
-    <p:sldId xmlns:r="http://schemas.openxmlformats.org/officeDocument/2006/relationships" id="258" r:id="Rf1569ac8362f4e8d"/>
-    <p:sldId xmlns:r="http://schemas.openxmlformats.org/officeDocument/2006/relationships" id="259" r:id="R234f5c32637a4bdc"/>
-    <p:sldId xmlns:r="http://schemas.openxmlformats.org/officeDocument/2006/relationships" id="260" r:id="Rad3a15878c344a5a"/>
-    <p:sldId xmlns:r="http://schemas.openxmlformats.org/officeDocument/2006/relationships" id="261" r:id="Rcaa943afc61a4717"/>
-    <p:sldId xmlns:r="http://schemas.openxmlformats.org/officeDocument/2006/relationships" id="262" r:id="R3b939e14508b4ead"/>
-    <p:sldId xmlns:r="http://schemas.openxmlformats.org/officeDocument/2006/relationships" id="263" r:id="R6309a4cf08154a24"/>
+    <p:sldId xmlns:r="http://schemas.openxmlformats.org/officeDocument/2006/relationships" id="256" r:id="Rfd1c4e9a30f74066"/>
+    <p:sldId xmlns:r="http://schemas.openxmlformats.org/officeDocument/2006/relationships" id="257" r:id="R370d6d3e6ad44298"/>
+    <p:sldId xmlns:r="http://schemas.openxmlformats.org/officeDocument/2006/relationships" id="258" r:id="Ree353d33b88b4e29"/>
+    <p:sldId xmlns:r="http://schemas.openxmlformats.org/officeDocument/2006/relationships" id="259" r:id="R82029e7d3f2f464e"/>
+    <p:sldId xmlns:r="http://schemas.openxmlformats.org/officeDocument/2006/relationships" id="260" r:id="R88175944537b4924"/>
+    <p:sldId xmlns:r="http://schemas.openxmlformats.org/officeDocument/2006/relationships" id="261" r:id="R32ce1de393e44e26"/>
+    <p:sldId xmlns:r="http://schemas.openxmlformats.org/officeDocument/2006/relationships" id="262" r:id="Rddf417b101a14c96"/>
+    <p:sldId xmlns:r="http://schemas.openxmlformats.org/officeDocument/2006/relationships" id="263" r:id="Rb41b1d7ded2141fc"/>
   </p:sldIdLst>
   <p:sldSz cx="12192000" cy="6858000"/>
   <p:notesSz cx="6858000" cy="9144000"/>
@@ -659,7 +659,7 @@
           <a:lstStyle xmlns:a="http://schemas.openxmlformats.org/drawingml/2006/main"/>
           <a:p xmlns:a="http://schemas.openxmlformats.org/drawingml/2006/main">
             <a:r>
-              <a:t>Architecture supplied by the implementation team. MCP server uses @modelcontextprotocol/sdk 1.30.0, Web Standard Streamable HTTP, and protocol 2025-11-25 on a Cloudflare Worker. Authenticated tools validate inputs and membership, use deterministic planning and @kindhandoff/guard, and write household-scoped data to D1 with optimistic version checks / compare-and-swap. Owner identity uses ChatGPT sign-in and helpers use secure one-time invitations. The guard library provides state transitions, coverage accounting, and candidate ranking. App code owns dependency readiness, exact identity authorization, and contentVersion brief acknowledgments. The deterministic browser language simulator uses Client and StreamableHTTPClientTransport to make real HTTP MCP initialize and tools/call requests. External MCP clients use the same server. No test pass count, load-test result, native Alexa connection, or cloud LLM use is asserted. Amazon documentation: https://developer.amazon.com/docs/alexaplus/add-ons/mcp-toolkit-overview.html and https://www.developer.amazon.com/docs/alexaplus/add-ons/mcp-toolkit-quickstart.html.</a:t>
+              <a:t>Architecture supplied by the implementation team. React 19.3 and Vite 8.3 frontend on Firebase Hosting. MCP server uses @modelcontextprotocol/sdk 1.30.0, Streamable HTTP, and protocol 2025-11-25 in Cloud Functions v2 on Node 22. Authenticated tools validate inputs and membership, use deterministic planning and @kindhandoff/guard, and write household-scoped Firestore Standard records with version-aware transactions. Firebase Authentication email/password establishes account identity and the app uses a secure __session cookie plus one-time helper invitations. Firestore and Functions run in us-central1. Runtime settings: 256 MiB, 1 CPU, concurrency 40, minInstances 0, maxInstances 2, timeout 30 seconds. Seven-day artifact cleanup is configured. The guard library provides state transitions, coverage accounting, and candidate ranking. App code owns dependency readiness, exact identity authorization, and contentVersion brief acknowledgments. The deterministic browser language simulator uses Client and StreamableHTTPClientTransport to make real HTTP MCP initialize and tools/call requests. External MCP clients use the same server. No load-test result, native Alexa connection, cloud LLM, or AWS use is asserted. The implementation lead confirmed the public Firebase release at kindhandoff.web.app. Signed-out browser entry and the reviewed cancellation-to-Jo/Dev-plan-to-offers flow passed at desktop width 1365 and mobile width 390 without horizontal overflow. Against production, 15 HTTP MCP calls passed using protocol 2025-11-25, 13 multi-user checks passed across four sessions, and 11 real Firebase Authentication checks passed, including new-account verification, secure cookie, private-circle persistence, sign-in, export, sign-out, and deletion. Root unit tests (29) and Firestore integration checks (17) passed; main CI passed for source e3e8c5f. The separate browser authentication and invitation walkthrough was still in progress when this confirmation was recorded. No customer, load-test, live Alexa, cloud LLM, or AWS outcome is claimed. Amazon documentation: https://developer.amazon.com/docs/alexaplus/add-ons/mcp-toolkit-overview.html and https://www.developer.amazon.com/docs/alexaplus/add-ons/mcp-toolkit-quickstart.html.</a:t>
             </a:r>
           </a:p>
         </p:txBody>
@@ -799,7 +799,7 @@
           <a:lstStyle xmlns:a="http://schemas.openxmlformats.org/drawingml/2006/main"/>
           <a:p xmlns:a="http://schemas.openxmlformats.org/drawingml/2006/main">
             <a:r>
-              <a:t>The $12 per household per month price is an unvalidated hypothesis. The market-and-business.md brief proposes testing a $9–15 range after real use. All helpers are included to avoid a seat-pricing incentive against participation. No traction or financial results exist in the materials provided. The cost brief is arithmetic from declared Workers/D1 assumptions, not an observed cost of operating KindHandoff. Runtime costs exclude managed hosting, identity-provider charges, support, acquisition, and optional model calls. Related category price reference: https://caringvillage.com/pricing/ .</a:t>
+              <a:t>The $12 per household per month price is an unvalidated hypothesis. The market-and-business.md brief proposes testing a $9–15 range after real use. All helpers are included to avoid a seat-pricing incentive against participation. No traction or financial results exist in the materials provided. The Firebase cost brief is arithmetic from declared visible-page polling, query, retention, and allocated-time assumptions. Four 15-minute visible sessions yield 304 refreshes per household/day, with one GET /api/session each. Five document reads per refresh and 20 per MCP action remain conservative budgets. With the other model assumptions, selected serving charges at five households fit unused allowances, or are about $0.39/month if the shared Cloud Run compute allowance is already consumed. The proposed $10 pilot operating allowance also anticipates deployment resources and uncertainty; it is neither an invoice forecast nor a cap. Billing is enabled. Builds, images, support, acquisition, and optional model calls are separate. Source rates: https://cloud.google.com/run/pricing , https://cloud.google.com/firestore/pricing , https://firebase.google.com/docs/hosting/usage-quotas-pricing . Related category price reference: https://caringvillage.com/pricing/ .</a:t>
             </a:r>
           </a:p>
         </p:txBody>
@@ -939,7 +939,7 @@
           <a:lstStyle xmlns:a="http://schemas.openxmlformats.org/drawingml/2006/main"/>
           <a:p xmlns:a="http://schemas.openxmlformats.org/drawingml/2006/main">
             <a:r>
-              <a:t>Creator: Shivam Gupta. Main repository: https://github.com/shi1720/Amazon-Developer-Hackathon. Preview target: https://shivam-amazon-hackathon.sg127977958.chatgpt.site. At authoring time deployment is pending, so this deck labels the URL as preview only. No public video URL has been claimed. The additional Open Source contribution is @kindhandoff/guard with an MIT license; verify the published separate repository and contribution link before final submission. Next steps include recording a public English video under three minutes, household research, and live Alexa+ onboarding where access permits.</a:t>
+              <a:t>Creator: Shivam Gupta. Public MIT main repository: https://github.com/shi1720/Amazon-Developer-Hackathon. Firebase application: https://kindhandoff.web.app. The implementation lead confirmed the public Firebase release at kindhandoff.web.app. Signed-out browser entry and the reviewed cancellation-to-Jo/Dev-plan-to-offers flow passed at desktop width 1365 and mobile width 390 without horizontal overflow. Against production, 15 HTTP MCP calls passed using protocol 2025-11-25, 13 multi-user checks passed across four sessions, and 11 real Firebase Authentication checks passed, including new-account verification, secure cookie, private-circle persistence, sign-in, export, sign-out, and deletion. Root unit tests (29) and Firestore integration checks (17) passed; main CI passed for source e3e8c5f. The separate browser authentication and invitation walkthrough was still in progress when this confirmation was recorded. No customer, load-test, live Alexa, cloud LLM, or AWS outcome is claimed. No public video URL has been claimed. The additional Open Source contribution is @kindhandoff/guard, public and MIT licensed: https://github.com/shi1720/kindhandoff-guard. Contribution: https://github.com/shi1720/kindhandoff-guard/commit/04a15ea016e552e3c031b9ec371af2df6a1de105. The library covers state transitions, coverage accounting, and candidate ranking. App code owns dependency readiness, exact identity authorization, and content-version acknowledgments. Next steps include recording a public English video under three minutes, household research, and live Alexa+ onboarding where access permits.</a:t>
             </a:r>
           </a:p>
         </p:txBody>
@@ -1007,7 +1007,7 @@
   </p:cSld>
   <p:clrMap bg1="lt1" tx1="dk1" bg2="lt2" tx2="dk2" accent1="accent1" accent2="accent2" accent3="accent3" accent4="accent4" accent5="accent5" accent6="accent6" hlink="hlink" folHlink="folHlink"/>
   <p:sldLayoutIdLst>
-    <p:sldLayoutId xmlns:r="http://schemas.openxmlformats.org/officeDocument/2006/relationships" id="2147483649" r:id="R39dce28a57b24d17"/>
+    <p:sldLayoutId xmlns:r="http://schemas.openxmlformats.org/officeDocument/2006/relationships" id="2147483649" r:id="R61e3de921ec24ac7"/>
   </p:sldLayoutIdLst>
   <p:txStyles>
     <p:titleStyle>
@@ -1558,7 +1558,7 @@
           <p:cNvPr id="15" name="wordmark">
             <a:extLst xmlns:a="http://schemas.openxmlformats.org/drawingml/2006/main">
               <a:ext uri="{FF2B5EF4-FFF2-40B4-BE49-F238E27FC236}">
-                <a16:creationId xmlns:a16="http://schemas.microsoft.com/office/drawing/2014/main" id="{1938B4F6-FC78-48E2-8306-8D32B197F313}"/>
+                <a16:creationId xmlns:a16="http://schemas.microsoft.com/office/drawing/2014/main" id="{892A923C-E32E-4E9C-AA8B-0A3B0B809552}"/>
               </a:ext>
             </a:extLst>
           </p:cNvPr>
@@ -1615,7 +1615,7 @@
           <p:cNvPr id="2" name="page">
             <a:extLst xmlns:a="http://schemas.openxmlformats.org/drawingml/2006/main">
               <a:ext uri="{FF2B5EF4-FFF2-40B4-BE49-F238E27FC236}">
-                <a16:creationId xmlns:a16="http://schemas.microsoft.com/office/drawing/2014/main" id="{8413B591-4D46-47FA-9D7B-3285939DB6F1}"/>
+                <a16:creationId xmlns:a16="http://schemas.microsoft.com/office/drawing/2014/main" id="{7F381C78-17E8-4FBC-B489-3CF092ABF8F9}"/>
               </a:ext>
             </a:extLst>
           </p:cNvPr>
@@ -1672,7 +1672,7 @@
           <p:cNvPr id="3" name="cover-title">
             <a:extLst xmlns:a="http://schemas.openxmlformats.org/drawingml/2006/main">
               <a:ext uri="{FF2B5EF4-FFF2-40B4-BE49-F238E27FC236}">
-                <a16:creationId xmlns:a16="http://schemas.microsoft.com/office/drawing/2014/main" id="{6AB76B3C-9FE7-4A9E-A473-25FB2BD2D616}"/>
+                <a16:creationId xmlns:a16="http://schemas.microsoft.com/office/drawing/2014/main" id="{DEA8E1B4-000B-49BA-BD38-47785A5805BA}"/>
               </a:ext>
             </a:extLst>
           </p:cNvPr>
@@ -1752,7 +1752,7 @@
           <p:cNvPr id="4" name="cover-problem">
             <a:extLst xmlns:a="http://schemas.openxmlformats.org/drawingml/2006/main">
               <a:ext uri="{FF2B5EF4-FFF2-40B4-BE49-F238E27FC236}">
-                <a16:creationId xmlns:a16="http://schemas.microsoft.com/office/drawing/2014/main" id="{CF3CC5E8-7FDA-45E0-95ED-1D474502FEE6}"/>
+                <a16:creationId xmlns:a16="http://schemas.microsoft.com/office/drawing/2014/main" id="{E13DD999-8E39-4092-A75D-B5FB98BD1FF0}"/>
               </a:ext>
             </a:extLst>
           </p:cNvPr>
@@ -1832,7 +1832,7 @@
           <p:cNvPr id="5" name="creator">
             <a:extLst xmlns:a="http://schemas.openxmlformats.org/drawingml/2006/main">
               <a:ext uri="{FF2B5EF4-FFF2-40B4-BE49-F238E27FC236}">
-                <a16:creationId xmlns:a16="http://schemas.microsoft.com/office/drawing/2014/main" id="{333F0F9C-D278-4044-886F-22344F1B625D}"/>
+                <a16:creationId xmlns:a16="http://schemas.microsoft.com/office/drawing/2014/main" id="{F33EDB6A-029B-4B04-AB23-C354F820BF35}"/>
               </a:ext>
             </a:extLst>
           </p:cNvPr>
@@ -1889,7 +1889,7 @@
           <p:cNvPr id="6" name="bag-node">
             <a:extLst xmlns:a="http://schemas.openxmlformats.org/drawingml/2006/main">
               <a:ext uri="{FF2B5EF4-FFF2-40B4-BE49-F238E27FC236}">
-                <a16:creationId xmlns:a16="http://schemas.microsoft.com/office/drawing/2014/main" id="{CE11B707-58E1-4638-8B22-24F4B0F96C72}"/>
+                <a16:creationId xmlns:a16="http://schemas.microsoft.com/office/drawing/2014/main" id="{67822C24-B3E5-4CD2-8646-F1C0C61BC319}"/>
               </a:ext>
             </a:extLst>
           </p:cNvPr>
@@ -1920,7 +1920,7 @@
           <p:cNvPr id="7" name="bag-time">
             <a:extLst xmlns:a="http://schemas.openxmlformats.org/drawingml/2006/main">
               <a:ext uri="{FF2B5EF4-FFF2-40B4-BE49-F238E27FC236}">
-                <a16:creationId xmlns:a16="http://schemas.microsoft.com/office/drawing/2014/main" id="{454F79AB-79C7-44BB-947E-821D04CD5497}"/>
+                <a16:creationId xmlns:a16="http://schemas.microsoft.com/office/drawing/2014/main" id="{148B5D20-A612-4BB3-A0D3-5B84710B3F0A}"/>
               </a:ext>
             </a:extLst>
           </p:cNvPr>
@@ -1977,7 +1977,7 @@
           <p:cNvPr id="8" name="bag-task">
             <a:extLst xmlns:a="http://schemas.openxmlformats.org/drawingml/2006/main">
               <a:ext uri="{FF2B5EF4-FFF2-40B4-BE49-F238E27FC236}">
-                <a16:creationId xmlns:a16="http://schemas.microsoft.com/office/drawing/2014/main" id="{0AE57E39-2949-4211-9915-E57D7EC79576}"/>
+                <a16:creationId xmlns:a16="http://schemas.microsoft.com/office/drawing/2014/main" id="{71F58339-814F-4395-BEC3-CE62C36BD16D}"/>
               </a:ext>
             </a:extLst>
           </p:cNvPr>
@@ -2034,7 +2034,7 @@
           <p:cNvPr id="9" name="ride-node">
             <a:extLst xmlns:a="http://schemas.openxmlformats.org/drawingml/2006/main">
               <a:ext uri="{FF2B5EF4-FFF2-40B4-BE49-F238E27FC236}">
-                <a16:creationId xmlns:a16="http://schemas.microsoft.com/office/drawing/2014/main" id="{B1E07D74-7A54-4631-AB90-24A838F797B8}"/>
+                <a16:creationId xmlns:a16="http://schemas.microsoft.com/office/drawing/2014/main" id="{85D9831D-F11B-4EBE-97B8-7CD95E9966A4}"/>
               </a:ext>
             </a:extLst>
           </p:cNvPr>
@@ -2065,7 +2065,7 @@
           <p:cNvPr id="10" name="ride-time">
             <a:extLst xmlns:a="http://schemas.openxmlformats.org/drawingml/2006/main">
               <a:ext uri="{FF2B5EF4-FFF2-40B4-BE49-F238E27FC236}">
-                <a16:creationId xmlns:a16="http://schemas.microsoft.com/office/drawing/2014/main" id="{E451D95D-9E8E-41B4-B097-E3803C1D9BC9}"/>
+                <a16:creationId xmlns:a16="http://schemas.microsoft.com/office/drawing/2014/main" id="{90B88914-18DB-43FA-9DF3-A4E712E18784}"/>
               </a:ext>
             </a:extLst>
           </p:cNvPr>
@@ -2122,7 +2122,7 @@
           <p:cNvPr id="11" name="ride-task">
             <a:extLst xmlns:a="http://schemas.openxmlformats.org/drawingml/2006/main">
               <a:ext uri="{FF2B5EF4-FFF2-40B4-BE49-F238E27FC236}">
-                <a16:creationId xmlns:a16="http://schemas.microsoft.com/office/drawing/2014/main" id="{90660B62-851C-4EC2-867D-DF2A4416293D}"/>
+                <a16:creationId xmlns:a16="http://schemas.microsoft.com/office/drawing/2014/main" id="{F36C1875-FE78-479D-8C91-E01BE4FF8859}"/>
               </a:ext>
             </a:extLst>
           </p:cNvPr>
@@ -2205,7 +2205,7 @@
           <p:cNvPr id="13" name="prerequisite-label">
             <a:extLst xmlns:a="http://schemas.openxmlformats.org/drawingml/2006/main">
               <a:ext uri="{FF2B5EF4-FFF2-40B4-BE49-F238E27FC236}">
-                <a16:creationId xmlns:a16="http://schemas.microsoft.com/office/drawing/2014/main" id="{8B87F89B-29E8-4FED-999F-A6190F693BC3}"/>
+                <a16:creationId xmlns:a16="http://schemas.microsoft.com/office/drawing/2014/main" id="{2A2B9376-6CF0-4AE0-AD66-510A38B07B87}"/>
               </a:ext>
             </a:extLst>
           </p:cNvPr>
@@ -2262,7 +2262,7 @@
           <p:cNvPr id="14" name="footer">
             <a:extLst xmlns:a="http://schemas.openxmlformats.org/drawingml/2006/main">
               <a:ext uri="{FF2B5EF4-FFF2-40B4-BE49-F238E27FC236}">
-                <a16:creationId xmlns:a16="http://schemas.microsoft.com/office/drawing/2014/main" id="{F2CC567A-07B0-4D2A-AA63-3116C464A9E2}"/>
+                <a16:creationId xmlns:a16="http://schemas.microsoft.com/office/drawing/2014/main" id="{1CC35F60-E268-45AF-8CB0-85D1246EC988}"/>
               </a:ext>
             </a:extLst>
           </p:cNvPr>
@@ -2317,7 +2317,7 @@
     </p:spTree>
     <p:extLst>
       <p:ext uri="{BB962C8B-B14F-4D97-AF65-F5344CB8AC3E}">
-        <p14:creationId xmlns:p14="http://schemas.microsoft.com/office/powerpoint/2010/main" val="1099373363"/>
+        <p14:creationId xmlns:p14="http://schemas.microsoft.com/office/powerpoint/2010/main" val="1919861995"/>
       </p:ext>
     </p:extLst>
   </p:cSld>
@@ -2348,7 +2348,7 @@
           <p:cNvPr id="7" name="wordmark">
             <a:extLst xmlns:a="http://schemas.openxmlformats.org/drawingml/2006/main">
               <a:ext uri="{FF2B5EF4-FFF2-40B4-BE49-F238E27FC236}">
-                <a16:creationId xmlns:a16="http://schemas.microsoft.com/office/drawing/2014/main" id="{BB42394C-ACBC-4343-BC75-4E01D55EF9FC}"/>
+                <a16:creationId xmlns:a16="http://schemas.microsoft.com/office/drawing/2014/main" id="{81B3D72F-894E-408F-8E85-9016722D6B62}"/>
               </a:ext>
             </a:extLst>
           </p:cNvPr>
@@ -2405,7 +2405,7 @@
           <p:cNvPr id="2" name="page">
             <a:extLst xmlns:a="http://schemas.openxmlformats.org/drawingml/2006/main">
               <a:ext uri="{FF2B5EF4-FFF2-40B4-BE49-F238E27FC236}">
-                <a16:creationId xmlns:a16="http://schemas.microsoft.com/office/drawing/2014/main" id="{40B82117-F904-410F-81CB-584E04019698}"/>
+                <a16:creationId xmlns:a16="http://schemas.microsoft.com/office/drawing/2014/main" id="{3728E3D0-1043-4771-8243-B8EDE81D7AFB}"/>
               </a:ext>
             </a:extLst>
           </p:cNvPr>
@@ -2462,7 +2462,7 @@
           <p:cNvPr id="3" name="title">
             <a:extLst xmlns:a="http://schemas.openxmlformats.org/drawingml/2006/main">
               <a:ext uri="{FF2B5EF4-FFF2-40B4-BE49-F238E27FC236}">
-                <a16:creationId xmlns:a16="http://schemas.microsoft.com/office/drawing/2014/main" id="{CEC542BF-33A5-424D-8E51-4CA44E355B97}"/>
+                <a16:creationId xmlns:a16="http://schemas.microsoft.com/office/drawing/2014/main" id="{58949647-7E21-4E67-A37C-B8855F06AC45}"/>
               </a:ext>
             </a:extLst>
           </p:cNvPr>
@@ -2519,7 +2519,7 @@
           <p:cNvPr id="4" name="subtitle">
             <a:extLst xmlns:a="http://schemas.openxmlformats.org/drawingml/2006/main">
               <a:ext uri="{FF2B5EF4-FFF2-40B4-BE49-F238E27FC236}">
-                <a16:creationId xmlns:a16="http://schemas.microsoft.com/office/drawing/2014/main" id="{0121A5DD-315B-46C0-823E-CBC021BA6D2C}"/>
+                <a16:creationId xmlns:a16="http://schemas.microsoft.com/office/drawing/2014/main" id="{29BCC57B-57A0-4F1A-9E5C-EA03D503DD5C}"/>
               </a:ext>
             </a:extLst>
           </p:cNvPr>
@@ -2945,7 +2945,7 @@
           <p:cNvPr id="6" name="footer">
             <a:extLst xmlns:a="http://schemas.openxmlformats.org/drawingml/2006/main">
               <a:ext uri="{FF2B5EF4-FFF2-40B4-BE49-F238E27FC236}">
-                <a16:creationId xmlns:a16="http://schemas.microsoft.com/office/drawing/2014/main" id="{895B4CCC-7A0A-4978-906A-78D889449332}"/>
+                <a16:creationId xmlns:a16="http://schemas.microsoft.com/office/drawing/2014/main" id="{4D882A3A-A18C-4387-A202-8C60075A6941}"/>
               </a:ext>
             </a:extLst>
           </p:cNvPr>
@@ -3000,7 +3000,7 @@
     </p:spTree>
     <p:extLst>
       <p:ext uri="{BB962C8B-B14F-4D97-AF65-F5344CB8AC3E}">
-        <p14:creationId xmlns:p14="http://schemas.microsoft.com/office/powerpoint/2010/main" val="1369356434"/>
+        <p14:creationId xmlns:p14="http://schemas.microsoft.com/office/powerpoint/2010/main" val="696775243"/>
       </p:ext>
     </p:extLst>
   </p:cSld>
@@ -3031,7 +3031,7 @@
           <p:cNvPr id="26" name="wordmark">
             <a:extLst xmlns:a="http://schemas.openxmlformats.org/drawingml/2006/main">
               <a:ext uri="{FF2B5EF4-FFF2-40B4-BE49-F238E27FC236}">
-                <a16:creationId xmlns:a16="http://schemas.microsoft.com/office/drawing/2014/main" id="{C0587760-D2EC-419F-A34B-96E2A0DA62EF}"/>
+                <a16:creationId xmlns:a16="http://schemas.microsoft.com/office/drawing/2014/main" id="{7DCF2176-3FF8-476C-A7D1-83AF92D7BA42}"/>
               </a:ext>
             </a:extLst>
           </p:cNvPr>
@@ -3088,7 +3088,7 @@
           <p:cNvPr id="2" name="page">
             <a:extLst xmlns:a="http://schemas.openxmlformats.org/drawingml/2006/main">
               <a:ext uri="{FF2B5EF4-FFF2-40B4-BE49-F238E27FC236}">
-                <a16:creationId xmlns:a16="http://schemas.microsoft.com/office/drawing/2014/main" id="{D225EAF7-DC71-4454-8B53-2CE34AEA74E6}"/>
+                <a16:creationId xmlns:a16="http://schemas.microsoft.com/office/drawing/2014/main" id="{422E1C72-9EBF-443B-91C1-E0075B6566F1}"/>
               </a:ext>
             </a:extLst>
           </p:cNvPr>
@@ -3145,7 +3145,7 @@
           <p:cNvPr id="3" name="title">
             <a:extLst xmlns:a="http://schemas.openxmlformats.org/drawingml/2006/main">
               <a:ext uri="{FF2B5EF4-FFF2-40B4-BE49-F238E27FC236}">
-                <a16:creationId xmlns:a16="http://schemas.microsoft.com/office/drawing/2014/main" id="{7746955A-4AF5-4A66-A7AF-9A398BE46CCA}"/>
+                <a16:creationId xmlns:a16="http://schemas.microsoft.com/office/drawing/2014/main" id="{1FCD8565-93C1-4D3C-BD79-F2BA2394F1D8}"/>
               </a:ext>
             </a:extLst>
           </p:cNvPr>
@@ -3202,7 +3202,7 @@
           <p:cNvPr id="4" name="subtitle">
             <a:extLst xmlns:a="http://schemas.openxmlformats.org/drawingml/2006/main">
               <a:ext uri="{FF2B5EF4-FFF2-40B4-BE49-F238E27FC236}">
-                <a16:creationId xmlns:a16="http://schemas.microsoft.com/office/drawing/2014/main" id="{A0C43014-2BD8-4774-AFD1-0AA877B4CC12}"/>
+                <a16:creationId xmlns:a16="http://schemas.microsoft.com/office/drawing/2014/main" id="{33BFBF60-AF43-4CC2-8672-1823785409AB}"/>
               </a:ext>
             </a:extLst>
           </p:cNvPr>
@@ -3259,7 +3259,7 @@
           <p:cNvPr id="5" name="state-0">
             <a:extLst xmlns:a="http://schemas.openxmlformats.org/drawingml/2006/main">
               <a:ext uri="{FF2B5EF4-FFF2-40B4-BE49-F238E27FC236}">
-                <a16:creationId xmlns:a16="http://schemas.microsoft.com/office/drawing/2014/main" id="{D82DB04B-161D-47D8-8546-D4225F11C85A}"/>
+                <a16:creationId xmlns:a16="http://schemas.microsoft.com/office/drawing/2014/main" id="{84A921AE-F274-44B9-8A78-4562913B88A1}"/>
               </a:ext>
             </a:extLst>
           </p:cNvPr>
@@ -3290,7 +3290,7 @@
           <p:cNvPr id="6" name="step-0">
             <a:extLst xmlns:a="http://schemas.openxmlformats.org/drawingml/2006/main">
               <a:ext uri="{FF2B5EF4-FFF2-40B4-BE49-F238E27FC236}">
-                <a16:creationId xmlns:a16="http://schemas.microsoft.com/office/drawing/2014/main" id="{36101927-5E3A-43F8-AC55-178DFE1F59BA}"/>
+                <a16:creationId xmlns:a16="http://schemas.microsoft.com/office/drawing/2014/main" id="{91199349-81CC-4FE6-A0E9-C6D3EF1E6FF0}"/>
               </a:ext>
             </a:extLst>
           </p:cNvPr>
@@ -3347,7 +3347,7 @@
           <p:cNvPr id="7" name="state-name-0">
             <a:extLst xmlns:a="http://schemas.openxmlformats.org/drawingml/2006/main">
               <a:ext uri="{FF2B5EF4-FFF2-40B4-BE49-F238E27FC236}">
-                <a16:creationId xmlns:a16="http://schemas.microsoft.com/office/drawing/2014/main" id="{32DC219E-D4E4-40BA-898A-EFA12AA8AB83}"/>
+                <a16:creationId xmlns:a16="http://schemas.microsoft.com/office/drawing/2014/main" id="{52650A3B-2BE6-4B81-94B2-B0E6D82BA828}"/>
               </a:ext>
             </a:extLst>
           </p:cNvPr>
@@ -3404,7 +3404,7 @@
           <p:cNvPr id="8" name="state-detail-0">
             <a:extLst xmlns:a="http://schemas.openxmlformats.org/drawingml/2006/main">
               <a:ext uri="{FF2B5EF4-FFF2-40B4-BE49-F238E27FC236}">
-                <a16:creationId xmlns:a16="http://schemas.microsoft.com/office/drawing/2014/main" id="{7D77F8EF-19FD-46C4-A4AA-26FE994300B3}"/>
+                <a16:creationId xmlns:a16="http://schemas.microsoft.com/office/drawing/2014/main" id="{3E751D93-A278-48C0-A173-B48116216890}"/>
               </a:ext>
             </a:extLst>
           </p:cNvPr>
@@ -3461,7 +3461,7 @@
           <p:cNvPr id="9" name="state-1">
             <a:extLst xmlns:a="http://schemas.openxmlformats.org/drawingml/2006/main">
               <a:ext uri="{FF2B5EF4-FFF2-40B4-BE49-F238E27FC236}">
-                <a16:creationId xmlns:a16="http://schemas.microsoft.com/office/drawing/2014/main" id="{9B31EA7A-497B-4E76-9FD0-A849688B7DA2}"/>
+                <a16:creationId xmlns:a16="http://schemas.microsoft.com/office/drawing/2014/main" id="{3791A4DD-2693-4987-A5F2-A8DB91110074}"/>
               </a:ext>
             </a:extLst>
           </p:cNvPr>
@@ -3492,7 +3492,7 @@
           <p:cNvPr id="10" name="step-1">
             <a:extLst xmlns:a="http://schemas.openxmlformats.org/drawingml/2006/main">
               <a:ext uri="{FF2B5EF4-FFF2-40B4-BE49-F238E27FC236}">
-                <a16:creationId xmlns:a16="http://schemas.microsoft.com/office/drawing/2014/main" id="{8D58AD3C-7E3D-4F51-B794-0A5B06AD953D}"/>
+                <a16:creationId xmlns:a16="http://schemas.microsoft.com/office/drawing/2014/main" id="{3B393E1A-D6EE-4ED2-A266-38411BBF3471}"/>
               </a:ext>
             </a:extLst>
           </p:cNvPr>
@@ -3549,7 +3549,7 @@
           <p:cNvPr id="11" name="state-name-1">
             <a:extLst xmlns:a="http://schemas.openxmlformats.org/drawingml/2006/main">
               <a:ext uri="{FF2B5EF4-FFF2-40B4-BE49-F238E27FC236}">
-                <a16:creationId xmlns:a16="http://schemas.microsoft.com/office/drawing/2014/main" id="{1E66DEC8-F847-478C-BCD2-FEB08449C893}"/>
+                <a16:creationId xmlns:a16="http://schemas.microsoft.com/office/drawing/2014/main" id="{752AF645-498D-48F7-B9AC-7820FADAF7E3}"/>
               </a:ext>
             </a:extLst>
           </p:cNvPr>
@@ -3606,7 +3606,7 @@
           <p:cNvPr id="12" name="state-detail-1">
             <a:extLst xmlns:a="http://schemas.openxmlformats.org/drawingml/2006/main">
               <a:ext uri="{FF2B5EF4-FFF2-40B4-BE49-F238E27FC236}">
-                <a16:creationId xmlns:a16="http://schemas.microsoft.com/office/drawing/2014/main" id="{B9A45FF2-42E5-4455-9974-DC178CEC1968}"/>
+                <a16:creationId xmlns:a16="http://schemas.microsoft.com/office/drawing/2014/main" id="{E0F415A7-16FB-42A7-B5A8-B84B672049D3}"/>
               </a:ext>
             </a:extLst>
           </p:cNvPr>
@@ -3663,7 +3663,7 @@
           <p:cNvPr id="13" name="state-2">
             <a:extLst xmlns:a="http://schemas.openxmlformats.org/drawingml/2006/main">
               <a:ext uri="{FF2B5EF4-FFF2-40B4-BE49-F238E27FC236}">
-                <a16:creationId xmlns:a16="http://schemas.microsoft.com/office/drawing/2014/main" id="{144619CD-1E42-4E9A-A6F2-903FBA944D49}"/>
+                <a16:creationId xmlns:a16="http://schemas.microsoft.com/office/drawing/2014/main" id="{A780ADD3-CA25-459A-BCE2-757E87892C6A}"/>
               </a:ext>
             </a:extLst>
           </p:cNvPr>
@@ -3694,7 +3694,7 @@
           <p:cNvPr id="14" name="step-2">
             <a:extLst xmlns:a="http://schemas.openxmlformats.org/drawingml/2006/main">
               <a:ext uri="{FF2B5EF4-FFF2-40B4-BE49-F238E27FC236}">
-                <a16:creationId xmlns:a16="http://schemas.microsoft.com/office/drawing/2014/main" id="{AF681C41-854D-4E00-8CB9-4E2D8620380D}"/>
+                <a16:creationId xmlns:a16="http://schemas.microsoft.com/office/drawing/2014/main" id="{E3984472-E5B9-4262-8024-40751A65591F}"/>
               </a:ext>
             </a:extLst>
           </p:cNvPr>
@@ -3751,7 +3751,7 @@
           <p:cNvPr id="15" name="state-name-2">
             <a:extLst xmlns:a="http://schemas.openxmlformats.org/drawingml/2006/main">
               <a:ext uri="{FF2B5EF4-FFF2-40B4-BE49-F238E27FC236}">
-                <a16:creationId xmlns:a16="http://schemas.microsoft.com/office/drawing/2014/main" id="{9F87F2FE-8819-4544-B0B1-90F394B0AE53}"/>
+                <a16:creationId xmlns:a16="http://schemas.microsoft.com/office/drawing/2014/main" id="{4FE92C40-EBC8-474E-885F-9D96BB308182}"/>
               </a:ext>
             </a:extLst>
           </p:cNvPr>
@@ -3808,7 +3808,7 @@
           <p:cNvPr id="16" name="state-detail-2">
             <a:extLst xmlns:a="http://schemas.openxmlformats.org/drawingml/2006/main">
               <a:ext uri="{FF2B5EF4-FFF2-40B4-BE49-F238E27FC236}">
-                <a16:creationId xmlns:a16="http://schemas.microsoft.com/office/drawing/2014/main" id="{E341D27D-83BD-4116-B294-88963AA1E485}"/>
+                <a16:creationId xmlns:a16="http://schemas.microsoft.com/office/drawing/2014/main" id="{DB87F43C-BC58-4C3F-9ACF-24B52B5039C9}"/>
               </a:ext>
             </a:extLst>
           </p:cNvPr>
@@ -3865,7 +3865,7 @@
           <p:cNvPr id="17" name="state-3">
             <a:extLst xmlns:a="http://schemas.openxmlformats.org/drawingml/2006/main">
               <a:ext uri="{FF2B5EF4-FFF2-40B4-BE49-F238E27FC236}">
-                <a16:creationId xmlns:a16="http://schemas.microsoft.com/office/drawing/2014/main" id="{321D1B2B-2FC7-4B1D-8205-0BC1B4646D32}"/>
+                <a16:creationId xmlns:a16="http://schemas.microsoft.com/office/drawing/2014/main" id="{D656AADC-9C59-4E61-BBEE-64258ADCF8D7}"/>
               </a:ext>
             </a:extLst>
           </p:cNvPr>
@@ -3898,7 +3898,7 @@
           <p:cNvPr id="18" name="step-3">
             <a:extLst xmlns:a="http://schemas.openxmlformats.org/drawingml/2006/main">
               <a:ext uri="{FF2B5EF4-FFF2-40B4-BE49-F238E27FC236}">
-                <a16:creationId xmlns:a16="http://schemas.microsoft.com/office/drawing/2014/main" id="{063CFE25-2B79-4477-AEBD-736925156754}"/>
+                <a16:creationId xmlns:a16="http://schemas.microsoft.com/office/drawing/2014/main" id="{DAA0709E-66EB-4022-8DB4-842055091C17}"/>
               </a:ext>
             </a:extLst>
           </p:cNvPr>
@@ -3955,7 +3955,7 @@
           <p:cNvPr id="19" name="state-name-3">
             <a:extLst xmlns:a="http://schemas.openxmlformats.org/drawingml/2006/main">
               <a:ext uri="{FF2B5EF4-FFF2-40B4-BE49-F238E27FC236}">
-                <a16:creationId xmlns:a16="http://schemas.microsoft.com/office/drawing/2014/main" id="{C00EDB98-DA38-49A5-A59C-DC77802679EB}"/>
+                <a16:creationId xmlns:a16="http://schemas.microsoft.com/office/drawing/2014/main" id="{73A79843-962D-4CAC-AAB8-75A73AF834AF}"/>
               </a:ext>
             </a:extLst>
           </p:cNvPr>
@@ -4012,7 +4012,7 @@
           <p:cNvPr id="20" name="state-detail-3">
             <a:extLst xmlns:a="http://schemas.openxmlformats.org/drawingml/2006/main">
               <a:ext uri="{FF2B5EF4-FFF2-40B4-BE49-F238E27FC236}">
-                <a16:creationId xmlns:a16="http://schemas.microsoft.com/office/drawing/2014/main" id="{0FFD0340-5D55-48C5-B983-268DDC346DFF}"/>
+                <a16:creationId xmlns:a16="http://schemas.microsoft.com/office/drawing/2014/main" id="{FED0B26B-EDDE-473E-BD75-630DDB9ADB5A}"/>
               </a:ext>
             </a:extLst>
           </p:cNvPr>
@@ -4147,7 +4147,7 @@
           <p:cNvPr id="24" name="waiting-note">
             <a:extLst xmlns:a="http://schemas.openxmlformats.org/drawingml/2006/main">
               <a:ext uri="{FF2B5EF4-FFF2-40B4-BE49-F238E27FC236}">
-                <a16:creationId xmlns:a16="http://schemas.microsoft.com/office/drawing/2014/main" id="{BA8B472F-62FC-4083-8D7D-2A596D41F6FC}"/>
+                <a16:creationId xmlns:a16="http://schemas.microsoft.com/office/drawing/2014/main" id="{60B8920E-42CD-47C0-B191-149AE0B388D6}"/>
               </a:ext>
             </a:extLst>
           </p:cNvPr>
@@ -4204,7 +4204,7 @@
           <p:cNvPr id="25" name="footer">
             <a:extLst xmlns:a="http://schemas.openxmlformats.org/drawingml/2006/main">
               <a:ext uri="{FF2B5EF4-FFF2-40B4-BE49-F238E27FC236}">
-                <a16:creationId xmlns:a16="http://schemas.microsoft.com/office/drawing/2014/main" id="{0C1A7D49-2098-4E45-AA6B-FE27D18AFE45}"/>
+                <a16:creationId xmlns:a16="http://schemas.microsoft.com/office/drawing/2014/main" id="{39C1A399-8B2B-420A-89BC-C889D18EEC7C}"/>
               </a:ext>
             </a:extLst>
           </p:cNvPr>
@@ -4259,7 +4259,7 @@
     </p:spTree>
     <p:extLst>
       <p:ext uri="{BB962C8B-B14F-4D97-AF65-F5344CB8AC3E}">
-        <p14:creationId xmlns:p14="http://schemas.microsoft.com/office/powerpoint/2010/main" val="732722551"/>
+        <p14:creationId xmlns:p14="http://schemas.microsoft.com/office/powerpoint/2010/main" val="1194935609"/>
       </p:ext>
     </p:extLst>
   </p:cSld>
@@ -4290,7 +4290,7 @@
           <p:cNvPr id="26" name="wordmark">
             <a:extLst xmlns:a="http://schemas.openxmlformats.org/drawingml/2006/main">
               <a:ext uri="{FF2B5EF4-FFF2-40B4-BE49-F238E27FC236}">
-                <a16:creationId xmlns:a16="http://schemas.microsoft.com/office/drawing/2014/main" id="{73C00F40-148A-47A2-AEB8-76FB3465E58C}"/>
+                <a16:creationId xmlns:a16="http://schemas.microsoft.com/office/drawing/2014/main" id="{914836AF-42DC-418D-BE7E-A2B6B51994E9}"/>
               </a:ext>
             </a:extLst>
           </p:cNvPr>
@@ -4347,7 +4347,7 @@
           <p:cNvPr id="2" name="page">
             <a:extLst xmlns:a="http://schemas.openxmlformats.org/drawingml/2006/main">
               <a:ext uri="{FF2B5EF4-FFF2-40B4-BE49-F238E27FC236}">
-                <a16:creationId xmlns:a16="http://schemas.microsoft.com/office/drawing/2014/main" id="{9DCE9F24-851D-47B3-A170-CEE59F5E15EF}"/>
+                <a16:creationId xmlns:a16="http://schemas.microsoft.com/office/drawing/2014/main" id="{B79D2EBB-91D8-4D05-A4FF-4977A85BBF3E}"/>
               </a:ext>
             </a:extLst>
           </p:cNvPr>
@@ -4404,7 +4404,7 @@
           <p:cNvPr id="3" name="title">
             <a:extLst xmlns:a="http://schemas.openxmlformats.org/drawingml/2006/main">
               <a:ext uri="{FF2B5EF4-FFF2-40B4-BE49-F238E27FC236}">
-                <a16:creationId xmlns:a16="http://schemas.microsoft.com/office/drawing/2014/main" id="{16AC43EE-F831-4DC7-A9B6-FA73AF2F5788}"/>
+                <a16:creationId xmlns:a16="http://schemas.microsoft.com/office/drawing/2014/main" id="{14DC9462-AED6-4DBC-95FF-B1AC4182A777}"/>
               </a:ext>
             </a:extLst>
           </p:cNvPr>
@@ -4461,7 +4461,7 @@
           <p:cNvPr id="4" name="subtitle">
             <a:extLst xmlns:a="http://schemas.openxmlformats.org/drawingml/2006/main">
               <a:ext uri="{FF2B5EF4-FFF2-40B4-BE49-F238E27FC236}">
-                <a16:creationId xmlns:a16="http://schemas.microsoft.com/office/drawing/2014/main" id="{C703DA2F-7136-499D-AD3A-75CA605EED4F}"/>
+                <a16:creationId xmlns:a16="http://schemas.microsoft.com/office/drawing/2014/main" id="{0B5A9594-AB87-4AC9-8D73-C8ACF4FEA821}"/>
               </a:ext>
             </a:extLst>
           </p:cNvPr>
@@ -4508,7 +4508,7 @@
                 <a:ea typeface="Noto Sans"/>
                 <a:cs typeface="Noto Sans"/>
               </a:rPr>
-              <a:t>Local simulator and MCP clients use the same validated workflow.</a:t>
+              <a:t>Web simulator and external MCP clients use the same validated workflow.</a:t>
             </a:r>
           </a:p>
         </p:txBody>
@@ -4518,7 +4518,7 @@
           <p:cNvPr id="5" name="architecture-title-0">
             <a:extLst xmlns:a="http://schemas.openxmlformats.org/drawingml/2006/main">
               <a:ext uri="{FF2B5EF4-FFF2-40B4-BE49-F238E27FC236}">
-                <a16:creationId xmlns:a16="http://schemas.microsoft.com/office/drawing/2014/main" id="{497EBB35-DE9F-41A1-A259-19F570B27904}"/>
+                <a16:creationId xmlns:a16="http://schemas.microsoft.com/office/drawing/2014/main" id="{0B3A00BD-C106-4D0C-825A-2F9216B7D99F}"/>
               </a:ext>
             </a:extLst>
           </p:cNvPr>
@@ -4565,7 +4565,7 @@
                 <a:ea typeface="Noto Sans"/>
                 <a:cs typeface="Noto Sans"/>
               </a:rPr>
-              <a:t>Client</a:t>
+              <a:t>Firebase Hosting</a:t>
             </a:r>
           </a:p>
         </p:txBody>
@@ -4575,7 +4575,7 @@
           <p:cNvPr id="6" name="architecture-node-0">
             <a:extLst xmlns:a="http://schemas.openxmlformats.org/drawingml/2006/main">
               <a:ext uri="{FF2B5EF4-FFF2-40B4-BE49-F238E27FC236}">
-                <a16:creationId xmlns:a16="http://schemas.microsoft.com/office/drawing/2014/main" id="{7C936E59-289F-456C-AF1E-912B806A0F06}"/>
+                <a16:creationId xmlns:a16="http://schemas.microsoft.com/office/drawing/2014/main" id="{9711C319-A623-46D8-BC3C-0A093DBE4F5E}"/>
               </a:ext>
             </a:extLst>
           </p:cNvPr>
@@ -4608,7 +4608,7 @@
           <p:cNvPr id="7" name="architecture-a-0">
             <a:extLst xmlns:a="http://schemas.openxmlformats.org/drawingml/2006/main">
               <a:ext uri="{FF2B5EF4-FFF2-40B4-BE49-F238E27FC236}">
-                <a16:creationId xmlns:a16="http://schemas.microsoft.com/office/drawing/2014/main" id="{CC925EA2-460C-42DE-A09A-D2955AD717A2}"/>
+                <a16:creationId xmlns:a16="http://schemas.microsoft.com/office/drawing/2014/main" id="{F3059CC1-A3FA-47E7-81BD-5083FE70B8EB}"/>
               </a:ext>
             </a:extLst>
           </p:cNvPr>
@@ -4665,7 +4665,7 @@
           <p:cNvPr id="8" name="architecture-b-0">
             <a:extLst xmlns:a="http://schemas.openxmlformats.org/drawingml/2006/main">
               <a:ext uri="{FF2B5EF4-FFF2-40B4-BE49-F238E27FC236}">
-                <a16:creationId xmlns:a16="http://schemas.microsoft.com/office/drawing/2014/main" id="{F26FC86A-4288-46A2-9D8C-FCCEDAC17674}"/>
+                <a16:creationId xmlns:a16="http://schemas.microsoft.com/office/drawing/2014/main" id="{6535D58A-ADEE-4973-9D94-1473732CC4DE}"/>
               </a:ext>
             </a:extLst>
           </p:cNvPr>
@@ -4712,7 +4712,30 @@
                 <a:ea typeface="Noto Sans"/>
                 <a:cs typeface="Noto Sans"/>
               </a:rPr>
-              <a:t>External MCP client</a:t>
+              <a:t>React 19.3</a:t>
+            </a:r>
+          </a:p>
+          <a:p xmlns:a="http://schemas.openxmlformats.org/drawingml/2006/main">
+            <a:pPr algn="l">
+              <a:defRPr sz="1575" b="0">
+                <a:solidFill>
+                  <a:srgbClr val="52677B"/>
+                </a:solidFill>
+                <a:latin typeface="Noto Sans"/>
+                <a:ea typeface="Noto Sans"/>
+                <a:cs typeface="Noto Sans"/>
+              </a:defRPr>
+            </a:pPr>
+            <a:r>
+              <a:rPr sz="1575" b="0">
+                <a:solidFill>
+                  <a:srgbClr val="52677B"/>
+                </a:solidFill>
+                <a:latin typeface="Noto Sans"/>
+                <a:ea typeface="Noto Sans"/>
+                <a:cs typeface="Noto Sans"/>
+              </a:rPr>
+              <a:t>Vite 8.3</a:t>
             </a:r>
           </a:p>
         </p:txBody>
@@ -4722,7 +4745,7 @@
           <p:cNvPr id="9" name="architecture-title-1">
             <a:extLst xmlns:a="http://schemas.openxmlformats.org/drawingml/2006/main">
               <a:ext uri="{FF2B5EF4-FFF2-40B4-BE49-F238E27FC236}">
-                <a16:creationId xmlns:a16="http://schemas.microsoft.com/office/drawing/2014/main" id="{FCCD8A12-30A9-441D-BC6D-A74A3D349554}"/>
+                <a16:creationId xmlns:a16="http://schemas.microsoft.com/office/drawing/2014/main" id="{D945F927-9F8E-4634-915C-E7B460D733C7}"/>
               </a:ext>
             </a:extLst>
           </p:cNvPr>
@@ -4769,7 +4792,7 @@
                 <a:ea typeface="Noto Sans"/>
                 <a:cs typeface="Noto Sans"/>
               </a:rPr>
-              <a:t>MCP server</a:t>
+              <a:t>Functions v2 / MCP</a:t>
             </a:r>
           </a:p>
         </p:txBody>
@@ -4779,7 +4802,7 @@
           <p:cNvPr id="10" name="architecture-node-1">
             <a:extLst xmlns:a="http://schemas.openxmlformats.org/drawingml/2006/main">
               <a:ext uri="{FF2B5EF4-FFF2-40B4-BE49-F238E27FC236}">
-                <a16:creationId xmlns:a16="http://schemas.microsoft.com/office/drawing/2014/main" id="{0556E09D-4781-4479-9343-EE075206F2DD}"/>
+                <a16:creationId xmlns:a16="http://schemas.microsoft.com/office/drawing/2014/main" id="{24EA1207-F738-4F79-ACC3-2B3A0DD6B37F}"/>
               </a:ext>
             </a:extLst>
           </p:cNvPr>
@@ -4812,7 +4835,7 @@
           <p:cNvPr id="11" name="architecture-a-1">
             <a:extLst xmlns:a="http://schemas.openxmlformats.org/drawingml/2006/main">
               <a:ext uri="{FF2B5EF4-FFF2-40B4-BE49-F238E27FC236}">
-                <a16:creationId xmlns:a16="http://schemas.microsoft.com/office/drawing/2014/main" id="{7A3C4DE1-A949-4638-BDE6-37ED41E6DD1D}"/>
+                <a16:creationId xmlns:a16="http://schemas.microsoft.com/office/drawing/2014/main" id="{BEDE7C6A-1755-4EF9-8D09-3D39E90D5430}"/>
               </a:ext>
             </a:extLst>
           </p:cNvPr>
@@ -4869,7 +4892,7 @@
           <p:cNvPr id="12" name="architecture-b-1">
             <a:extLst xmlns:a="http://schemas.openxmlformats.org/drawingml/2006/main">
               <a:ext uri="{FF2B5EF4-FFF2-40B4-BE49-F238E27FC236}">
-                <a16:creationId xmlns:a16="http://schemas.microsoft.com/office/drawing/2014/main" id="{C8061D1C-9926-4261-878F-B730D269E9CF}"/>
+                <a16:creationId xmlns:a16="http://schemas.microsoft.com/office/drawing/2014/main" id="{638B64DC-1392-49EA-8E62-609EF1400338}"/>
               </a:ext>
             </a:extLst>
           </p:cNvPr>
@@ -4949,7 +4972,7 @@
           <p:cNvPr id="13" name="architecture-title-2">
             <a:extLst xmlns:a="http://schemas.openxmlformats.org/drawingml/2006/main">
               <a:ext uri="{FF2B5EF4-FFF2-40B4-BE49-F238E27FC236}">
-                <a16:creationId xmlns:a16="http://schemas.microsoft.com/office/drawing/2014/main" id="{1F66A5CF-7BC5-450F-A534-E720C911FAB6}"/>
+                <a16:creationId xmlns:a16="http://schemas.microsoft.com/office/drawing/2014/main" id="{9D244C21-6A38-4548-B54B-CC819C122658}"/>
               </a:ext>
             </a:extLst>
           </p:cNvPr>
@@ -5006,7 +5029,7 @@
           <p:cNvPr id="14" name="architecture-node-2">
             <a:extLst xmlns:a="http://schemas.openxmlformats.org/drawingml/2006/main">
               <a:ext uri="{FF2B5EF4-FFF2-40B4-BE49-F238E27FC236}">
-                <a16:creationId xmlns:a16="http://schemas.microsoft.com/office/drawing/2014/main" id="{27905FE6-0340-4DD8-A200-B55C7FEF8E6D}"/>
+                <a16:creationId xmlns:a16="http://schemas.microsoft.com/office/drawing/2014/main" id="{70F76BA8-A837-41D6-80F3-4D4D4DDF5E90}"/>
               </a:ext>
             </a:extLst>
           </p:cNvPr>
@@ -5039,7 +5062,7 @@
           <p:cNvPr id="15" name="architecture-a-2">
             <a:extLst xmlns:a="http://schemas.openxmlformats.org/drawingml/2006/main">
               <a:ext uri="{FF2B5EF4-FFF2-40B4-BE49-F238E27FC236}">
-                <a16:creationId xmlns:a16="http://schemas.microsoft.com/office/drawing/2014/main" id="{E3B3342C-2032-494E-86C1-34D23E7B00F8}"/>
+                <a16:creationId xmlns:a16="http://schemas.microsoft.com/office/drawing/2014/main" id="{2D70EBDA-6A34-44EC-A78C-C88A3DDA0177}"/>
               </a:ext>
             </a:extLst>
           </p:cNvPr>
@@ -5096,7 +5119,7 @@
           <p:cNvPr id="16" name="architecture-b-2">
             <a:extLst xmlns:a="http://schemas.openxmlformats.org/drawingml/2006/main">
               <a:ext uri="{FF2B5EF4-FFF2-40B4-BE49-F238E27FC236}">
-                <a16:creationId xmlns:a16="http://schemas.microsoft.com/office/drawing/2014/main" id="{0275D26B-ED59-4067-92C7-6A6E7A308870}"/>
+                <a16:creationId xmlns:a16="http://schemas.microsoft.com/office/drawing/2014/main" id="{F96F3A6C-AE92-4698-B26B-FABFA2743A06}"/>
               </a:ext>
             </a:extLst>
           </p:cNvPr>
@@ -5153,7 +5176,7 @@
           <p:cNvPr id="17" name="architecture-title-3">
             <a:extLst xmlns:a="http://schemas.openxmlformats.org/drawingml/2006/main">
               <a:ext uri="{FF2B5EF4-FFF2-40B4-BE49-F238E27FC236}">
-                <a16:creationId xmlns:a16="http://schemas.microsoft.com/office/drawing/2014/main" id="{7D30365A-EC4A-4742-B20A-C487FF2A93CC}"/>
+                <a16:creationId xmlns:a16="http://schemas.microsoft.com/office/drawing/2014/main" id="{A2782682-E251-4B57-A751-232AC3AC9EE3}"/>
               </a:ext>
             </a:extLst>
           </p:cNvPr>
@@ -5200,7 +5223,7 @@
                 <a:ea typeface="Noto Sans"/>
                 <a:cs typeface="Noto Sans"/>
               </a:rPr>
-              <a:t>D1 storage</a:t>
+              <a:t>Firestore</a:t>
             </a:r>
           </a:p>
         </p:txBody>
@@ -5210,7 +5233,7 @@
           <p:cNvPr id="18" name="architecture-node-3">
             <a:extLst xmlns:a="http://schemas.openxmlformats.org/drawingml/2006/main">
               <a:ext uri="{FF2B5EF4-FFF2-40B4-BE49-F238E27FC236}">
-                <a16:creationId xmlns:a16="http://schemas.microsoft.com/office/drawing/2014/main" id="{89F88882-D3E9-4BAF-9745-028365E89FD3}"/>
+                <a16:creationId xmlns:a16="http://schemas.microsoft.com/office/drawing/2014/main" id="{6BF1B58E-A555-4C09-97AF-762D9947C7C6}"/>
               </a:ext>
             </a:extLst>
           </p:cNvPr>
@@ -5243,7 +5266,7 @@
           <p:cNvPr id="19" name="architecture-a-3">
             <a:extLst xmlns:a="http://schemas.openxmlformats.org/drawingml/2006/main">
               <a:ext uri="{FF2B5EF4-FFF2-40B4-BE49-F238E27FC236}">
-                <a16:creationId xmlns:a16="http://schemas.microsoft.com/office/drawing/2014/main" id="{C10CDDF1-B100-4560-8989-937A533B43FF}"/>
+                <a16:creationId xmlns:a16="http://schemas.microsoft.com/office/drawing/2014/main" id="{FCEA89C7-4260-42D1-BB8F-57A0A8AAC175}"/>
               </a:ext>
             </a:extLst>
           </p:cNvPr>
@@ -5300,7 +5323,7 @@
           <p:cNvPr id="20" name="architecture-b-3">
             <a:extLst xmlns:a="http://schemas.openxmlformats.org/drawingml/2006/main">
               <a:ext uri="{FF2B5EF4-FFF2-40B4-BE49-F238E27FC236}">
-                <a16:creationId xmlns:a16="http://schemas.microsoft.com/office/drawing/2014/main" id="{973F22A7-BD5C-4C04-9E4D-F6AEFE436281}"/>
+                <a16:creationId xmlns:a16="http://schemas.microsoft.com/office/drawing/2014/main" id="{F3F2B60B-D139-4310-A2B1-E4F8671C75A8}"/>
               </a:ext>
             </a:extLst>
           </p:cNvPr>
@@ -5370,7 +5393,7 @@
                 <a:ea typeface="Noto Sans"/>
                 <a:cs typeface="Noto Sans"/>
               </a:rPr>
-              <a:t>Compare and swap</a:t>
+              <a:t>Transaction</a:t>
             </a:r>
           </a:p>
         </p:txBody>
@@ -5458,7 +5481,7 @@
           <p:cNvPr id="24" name="auth-note">
             <a:extLst xmlns:a="http://schemas.openxmlformats.org/drawingml/2006/main">
               <a:ext uri="{FF2B5EF4-FFF2-40B4-BE49-F238E27FC236}">
-                <a16:creationId xmlns:a16="http://schemas.microsoft.com/office/drawing/2014/main" id="{9E30CB84-B1FD-4FDA-8FE6-C67DF6B096F9}"/>
+                <a16:creationId xmlns:a16="http://schemas.microsoft.com/office/drawing/2014/main" id="{EE30D7A9-EAF9-4261-846F-09415F4173B1}"/>
               </a:ext>
             </a:extLst>
           </p:cNvPr>
@@ -5505,7 +5528,7 @@
                 <a:ea typeface="Noto Sans"/>
                 <a:cs typeface="Noto Sans"/>
               </a:rPr>
-              <a:t>Owner sign-in and one-time helper invitations establish who may act.</a:t>
+              <a:t>Firebase email/password sign-in and one-time helper invitations.</a:t>
             </a:r>
           </a:p>
         </p:txBody>
@@ -5515,7 +5538,7 @@
           <p:cNvPr id="25" name="footer">
             <a:extLst xmlns:a="http://schemas.openxmlformats.org/drawingml/2006/main">
               <a:ext uri="{FF2B5EF4-FFF2-40B4-BE49-F238E27FC236}">
-                <a16:creationId xmlns:a16="http://schemas.microsoft.com/office/drawing/2014/main" id="{E0A97ACB-BF55-47B0-9276-487023DF45D8}"/>
+                <a16:creationId xmlns:a16="http://schemas.microsoft.com/office/drawing/2014/main" id="{0156AB9C-01A0-4F83-B72E-58AE91C3A148}"/>
               </a:ext>
             </a:extLst>
           </p:cNvPr>
@@ -5570,7 +5593,7 @@
     </p:spTree>
     <p:extLst>
       <p:ext uri="{BB962C8B-B14F-4D97-AF65-F5344CB8AC3E}">
-        <p14:creationId xmlns:p14="http://schemas.microsoft.com/office/powerpoint/2010/main" val="1383431759"/>
+        <p14:creationId xmlns:p14="http://schemas.microsoft.com/office/powerpoint/2010/main" val="1932256314"/>
       </p:ext>
     </p:extLst>
   </p:cSld>
@@ -5601,7 +5624,7 @@
           <p:cNvPr id="8" name="wordmark">
             <a:extLst xmlns:a="http://schemas.openxmlformats.org/drawingml/2006/main">
               <a:ext uri="{FF2B5EF4-FFF2-40B4-BE49-F238E27FC236}">
-                <a16:creationId xmlns:a16="http://schemas.microsoft.com/office/drawing/2014/main" id="{42E24C39-9696-42A3-A432-F428595EA09A}"/>
+                <a16:creationId xmlns:a16="http://schemas.microsoft.com/office/drawing/2014/main" id="{DAE0E7DD-E164-43CB-9357-411E777A4FB8}"/>
               </a:ext>
             </a:extLst>
           </p:cNvPr>
@@ -5658,7 +5681,7 @@
           <p:cNvPr id="2" name="page">
             <a:extLst xmlns:a="http://schemas.openxmlformats.org/drawingml/2006/main">
               <a:ext uri="{FF2B5EF4-FFF2-40B4-BE49-F238E27FC236}">
-                <a16:creationId xmlns:a16="http://schemas.microsoft.com/office/drawing/2014/main" id="{F06C5FD0-B071-46D4-B4A7-0A29A252731D}"/>
+                <a16:creationId xmlns:a16="http://schemas.microsoft.com/office/drawing/2014/main" id="{A2DDCB96-1245-481E-914D-112793F427E1}"/>
               </a:ext>
             </a:extLst>
           </p:cNvPr>
@@ -5715,7 +5738,7 @@
           <p:cNvPr id="3" name="title">
             <a:extLst xmlns:a="http://schemas.openxmlformats.org/drawingml/2006/main">
               <a:ext uri="{FF2B5EF4-FFF2-40B4-BE49-F238E27FC236}">
-                <a16:creationId xmlns:a16="http://schemas.microsoft.com/office/drawing/2014/main" id="{1A40AA2C-ABD0-4DE4-BA39-EC411D37D849}"/>
+                <a16:creationId xmlns:a16="http://schemas.microsoft.com/office/drawing/2014/main" id="{95CE1D1D-1673-42F0-A0E7-39DE9757819D}"/>
               </a:ext>
             </a:extLst>
           </p:cNvPr>
@@ -5772,7 +5795,7 @@
           <p:cNvPr id="4" name="subtitle">
             <a:extLst xmlns:a="http://schemas.openxmlformats.org/drawingml/2006/main">
               <a:ext uri="{FF2B5EF4-FFF2-40B4-BE49-F238E27FC236}">
-                <a16:creationId xmlns:a16="http://schemas.microsoft.com/office/drawing/2014/main" id="{EEE44E57-5574-498D-985B-4107BCD92E54}"/>
+                <a16:creationId xmlns:a16="http://schemas.microsoft.com/office/drawing/2014/main" id="{04006EA3-4110-4E28-8D20-4A80BF215CBE}"/>
               </a:ext>
             </a:extLst>
           </p:cNvPr>
@@ -6067,7 +6090,7 @@
           <p:cNvPr id="6" name="our-focus">
             <a:extLst xmlns:a="http://schemas.openxmlformats.org/drawingml/2006/main">
               <a:ext uri="{FF2B5EF4-FFF2-40B4-BE49-F238E27FC236}">
-                <a16:creationId xmlns:a16="http://schemas.microsoft.com/office/drawing/2014/main" id="{C53007C9-2EAF-4329-A137-748B68142A49}"/>
+                <a16:creationId xmlns:a16="http://schemas.microsoft.com/office/drawing/2014/main" id="{B0020E50-42E7-4DA8-8559-72DC6E345B20}"/>
               </a:ext>
             </a:extLst>
           </p:cNvPr>
@@ -6124,7 +6147,7 @@
           <p:cNvPr id="7" name="footer">
             <a:extLst xmlns:a="http://schemas.openxmlformats.org/drawingml/2006/main">
               <a:ext uri="{FF2B5EF4-FFF2-40B4-BE49-F238E27FC236}">
-                <a16:creationId xmlns:a16="http://schemas.microsoft.com/office/drawing/2014/main" id="{843A4A43-398D-495C-AE32-79054A3F131D}"/>
+                <a16:creationId xmlns:a16="http://schemas.microsoft.com/office/drawing/2014/main" id="{AD7743F1-DE9A-4AFA-9CC7-8CBB1BA1A760}"/>
               </a:ext>
             </a:extLst>
           </p:cNvPr>
@@ -6179,7 +6202,7 @@
     </p:spTree>
     <p:extLst>
       <p:ext uri="{BB962C8B-B14F-4D97-AF65-F5344CB8AC3E}">
-        <p14:creationId xmlns:p14="http://schemas.microsoft.com/office/powerpoint/2010/main" val="994754436"/>
+        <p14:creationId xmlns:p14="http://schemas.microsoft.com/office/powerpoint/2010/main" val="741513263"/>
       </p:ext>
     </p:extLst>
   </p:cSld>
@@ -6210,7 +6233,7 @@
           <p:cNvPr id="12" name="wordmark">
             <a:extLst xmlns:a="http://schemas.openxmlformats.org/drawingml/2006/main">
               <a:ext uri="{FF2B5EF4-FFF2-40B4-BE49-F238E27FC236}">
-                <a16:creationId xmlns:a16="http://schemas.microsoft.com/office/drawing/2014/main" id="{CCBF2AF6-FB26-4607-9839-1C75B4EB2224}"/>
+                <a16:creationId xmlns:a16="http://schemas.microsoft.com/office/drawing/2014/main" id="{74485722-329B-4584-9E01-5D552645193A}"/>
               </a:ext>
             </a:extLst>
           </p:cNvPr>
@@ -6267,7 +6290,7 @@
           <p:cNvPr id="2" name="page">
             <a:extLst xmlns:a="http://schemas.openxmlformats.org/drawingml/2006/main">
               <a:ext uri="{FF2B5EF4-FFF2-40B4-BE49-F238E27FC236}">
-                <a16:creationId xmlns:a16="http://schemas.microsoft.com/office/drawing/2014/main" id="{47B30E45-C170-462F-B198-BA4CFCCD99CF}"/>
+                <a16:creationId xmlns:a16="http://schemas.microsoft.com/office/drawing/2014/main" id="{7C1E8FA0-091C-46B2-ABB4-F622F0DDAA5B}"/>
               </a:ext>
             </a:extLst>
           </p:cNvPr>
@@ -6324,7 +6347,7 @@
           <p:cNvPr id="3" name="title">
             <a:extLst xmlns:a="http://schemas.openxmlformats.org/drawingml/2006/main">
               <a:ext uri="{FF2B5EF4-FFF2-40B4-BE49-F238E27FC236}">
-                <a16:creationId xmlns:a16="http://schemas.microsoft.com/office/drawing/2014/main" id="{71FF1401-A043-486A-A0AC-D2749B67D3EE}"/>
+                <a16:creationId xmlns:a16="http://schemas.microsoft.com/office/drawing/2014/main" id="{D2884050-1F96-4F37-91FD-ACD142D723CA}"/>
               </a:ext>
             </a:extLst>
           </p:cNvPr>
@@ -6381,7 +6404,7 @@
           <p:cNvPr id="4" name="subtitle">
             <a:extLst xmlns:a="http://schemas.openxmlformats.org/drawingml/2006/main">
               <a:ext uri="{FF2B5EF4-FFF2-40B4-BE49-F238E27FC236}">
-                <a16:creationId xmlns:a16="http://schemas.microsoft.com/office/drawing/2014/main" id="{26FD2A88-A407-4902-B7D5-21FA5311D369}"/>
+                <a16:creationId xmlns:a16="http://schemas.microsoft.com/office/drawing/2014/main" id="{FD2C7446-BF9D-4546-9E25-BBC982041F86}"/>
               </a:ext>
             </a:extLst>
           </p:cNvPr>
@@ -6438,7 +6461,7 @@
           <p:cNvPr id="5" name="price">
             <a:extLst xmlns:a="http://schemas.openxmlformats.org/drawingml/2006/main">
               <a:ext uri="{FF2B5EF4-FFF2-40B4-BE49-F238E27FC236}">
-                <a16:creationId xmlns:a16="http://schemas.microsoft.com/office/drawing/2014/main" id="{E693CBAC-1C98-4571-A10A-1E5603FF17E2}"/>
+                <a16:creationId xmlns:a16="http://schemas.microsoft.com/office/drawing/2014/main" id="{B933C5DF-905E-42D7-8AB6-85E947B9B255}"/>
               </a:ext>
             </a:extLst>
           </p:cNvPr>
@@ -6495,7 +6518,7 @@
           <p:cNvPr id="6" name="price-unit">
             <a:extLst xmlns:a="http://schemas.openxmlformats.org/drawingml/2006/main">
               <a:ext uri="{FF2B5EF4-FFF2-40B4-BE49-F238E27FC236}">
-                <a16:creationId xmlns:a16="http://schemas.microsoft.com/office/drawing/2014/main" id="{025ACF4D-CA33-4AB4-80F2-3D76AD606B58}"/>
+                <a16:creationId xmlns:a16="http://schemas.microsoft.com/office/drawing/2014/main" id="{743828C0-959F-457B-A041-E4CFA918CEB6}"/>
               </a:ext>
             </a:extLst>
           </p:cNvPr>
@@ -6552,7 +6575,7 @@
           <p:cNvPr id="7" name="hypothesis-label">
             <a:extLst xmlns:a="http://schemas.openxmlformats.org/drawingml/2006/main">
               <a:ext uri="{FF2B5EF4-FFF2-40B4-BE49-F238E27FC236}">
-                <a16:creationId xmlns:a16="http://schemas.microsoft.com/office/drawing/2014/main" id="{FA884B41-D669-4861-B43F-60662AC95112}"/>
+                <a16:creationId xmlns:a16="http://schemas.microsoft.com/office/drawing/2014/main" id="{94B8DA1A-1781-496A-965E-C46A9B1A835A}"/>
               </a:ext>
             </a:extLst>
           </p:cNvPr>
@@ -6609,7 +6632,7 @@
           <p:cNvPr id="8" name="business-benefit">
             <a:extLst xmlns:a="http://schemas.openxmlformats.org/drawingml/2006/main">
               <a:ext uri="{FF2B5EF4-FFF2-40B4-BE49-F238E27FC236}">
-                <a16:creationId xmlns:a16="http://schemas.microsoft.com/office/drawing/2014/main" id="{ACD849E3-0973-4B24-AD06-2C542632A63E}"/>
+                <a16:creationId xmlns:a16="http://schemas.microsoft.com/office/drawing/2014/main" id="{FEAED676-7AB3-4F88-96B8-5AD829FB86D7}"/>
               </a:ext>
             </a:extLst>
           </p:cNvPr>
@@ -6666,7 +6689,7 @@
           <p:cNvPr id="9" name="business-rationale">
             <a:extLst xmlns:a="http://schemas.openxmlformats.org/drawingml/2006/main">
               <a:ext uri="{FF2B5EF4-FFF2-40B4-BE49-F238E27FC236}">
-                <a16:creationId xmlns:a16="http://schemas.microsoft.com/office/drawing/2014/main" id="{33D8CA13-C753-413C-A329-D9181922F5B2}"/>
+                <a16:creationId xmlns:a16="http://schemas.microsoft.com/office/drawing/2014/main" id="{55377299-A177-4E68-9668-387393275D6E}"/>
               </a:ext>
             </a:extLst>
           </p:cNvPr>
@@ -6746,7 +6769,7 @@
           <p:cNvPr id="10" name="cost-discipline">
             <a:extLst xmlns:a="http://schemas.openxmlformats.org/drawingml/2006/main">
               <a:ext uri="{FF2B5EF4-FFF2-40B4-BE49-F238E27FC236}">
-                <a16:creationId xmlns:a16="http://schemas.microsoft.com/office/drawing/2014/main" id="{A3B1026E-074B-4258-AAD3-5DC7D00A45F4}"/>
+                <a16:creationId xmlns:a16="http://schemas.microsoft.com/office/drawing/2014/main" id="{0983AEFA-8F02-4C2C-8009-0C3FE7C003DB}"/>
               </a:ext>
             </a:extLst>
           </p:cNvPr>
@@ -6826,7 +6849,7 @@
           <p:cNvPr id="11" name="footer">
             <a:extLst xmlns:a="http://schemas.openxmlformats.org/drawingml/2006/main">
               <a:ext uri="{FF2B5EF4-FFF2-40B4-BE49-F238E27FC236}">
-                <a16:creationId xmlns:a16="http://schemas.microsoft.com/office/drawing/2014/main" id="{E4AB9A26-CE99-464B-BBCE-094F19E0093F}"/>
+                <a16:creationId xmlns:a16="http://schemas.microsoft.com/office/drawing/2014/main" id="{BEB3A08F-71C1-4927-B53B-56F5B42D6BA0}"/>
               </a:ext>
             </a:extLst>
           </p:cNvPr>
@@ -6881,7 +6904,7 @@
     </p:spTree>
     <p:extLst>
       <p:ext uri="{BB962C8B-B14F-4D97-AF65-F5344CB8AC3E}">
-        <p14:creationId xmlns:p14="http://schemas.microsoft.com/office/powerpoint/2010/main" val="1576449384"/>
+        <p14:creationId xmlns:p14="http://schemas.microsoft.com/office/powerpoint/2010/main" val="331654297"/>
       </p:ext>
     </p:extLst>
   </p:cSld>
@@ -6912,7 +6935,7 @@
           <p:cNvPr id="13" name="wordmark">
             <a:extLst xmlns:a="http://schemas.openxmlformats.org/drawingml/2006/main">
               <a:ext uri="{FF2B5EF4-FFF2-40B4-BE49-F238E27FC236}">
-                <a16:creationId xmlns:a16="http://schemas.microsoft.com/office/drawing/2014/main" id="{44C150DA-8820-4783-A9A6-43A937433319}"/>
+                <a16:creationId xmlns:a16="http://schemas.microsoft.com/office/drawing/2014/main" id="{1427301E-2357-4F83-8A30-A6EBDFFCF883}"/>
               </a:ext>
             </a:extLst>
           </p:cNvPr>
@@ -6969,7 +6992,7 @@
           <p:cNvPr id="2" name="page">
             <a:extLst xmlns:a="http://schemas.openxmlformats.org/drawingml/2006/main">
               <a:ext uri="{FF2B5EF4-FFF2-40B4-BE49-F238E27FC236}">
-                <a16:creationId xmlns:a16="http://schemas.microsoft.com/office/drawing/2014/main" id="{EE4906B4-9C84-4A95-8C3B-5AE4753D8ABB}"/>
+                <a16:creationId xmlns:a16="http://schemas.microsoft.com/office/drawing/2014/main" id="{046F0C09-F7BA-4AC5-9EF0-9C5BF0F552D1}"/>
               </a:ext>
             </a:extLst>
           </p:cNvPr>
@@ -7026,7 +7049,7 @@
           <p:cNvPr id="3" name="title">
             <a:extLst xmlns:a="http://schemas.openxmlformats.org/drawingml/2006/main">
               <a:ext uri="{FF2B5EF4-FFF2-40B4-BE49-F238E27FC236}">
-                <a16:creationId xmlns:a16="http://schemas.microsoft.com/office/drawing/2014/main" id="{6295177A-E0D5-4BB7-BA2C-EF3023AEC9F7}"/>
+                <a16:creationId xmlns:a16="http://schemas.microsoft.com/office/drawing/2014/main" id="{BC15F27E-87C9-473E-A1B2-899DFC196433}"/>
               </a:ext>
             </a:extLst>
           </p:cNvPr>
@@ -7083,7 +7106,7 @@
           <p:cNvPr id="4" name="subtitle">
             <a:extLst xmlns:a="http://schemas.openxmlformats.org/drawingml/2006/main">
               <a:ext uri="{FF2B5EF4-FFF2-40B4-BE49-F238E27FC236}">
-                <a16:creationId xmlns:a16="http://schemas.microsoft.com/office/drawing/2014/main" id="{4090F66B-F91E-44B6-BE52-8749FBF13840}"/>
+                <a16:creationId xmlns:a16="http://schemas.microsoft.com/office/drawing/2014/main" id="{06BE5BAC-3DB3-44C1-9E1F-859812CECF98}"/>
               </a:ext>
             </a:extLst>
           </p:cNvPr>
@@ -7140,7 +7163,7 @@
           <p:cNvPr id="5" name="interviews-number">
             <a:extLst xmlns:a="http://schemas.openxmlformats.org/drawingml/2006/main">
               <a:ext uri="{FF2B5EF4-FFF2-40B4-BE49-F238E27FC236}">
-                <a16:creationId xmlns:a16="http://schemas.microsoft.com/office/drawing/2014/main" id="{C125C71A-15B9-4D98-8A29-BFDF9DA9BBD0}"/>
+                <a16:creationId xmlns:a16="http://schemas.microsoft.com/office/drawing/2014/main" id="{D7EABEA1-3812-4831-B2EF-B8238184F23A}"/>
               </a:ext>
             </a:extLst>
           </p:cNvPr>
@@ -7197,7 +7220,7 @@
           <p:cNvPr id="6" name="interviews-label">
             <a:extLst xmlns:a="http://schemas.openxmlformats.org/drawingml/2006/main">
               <a:ext uri="{FF2B5EF4-FFF2-40B4-BE49-F238E27FC236}">
-                <a16:creationId xmlns:a16="http://schemas.microsoft.com/office/drawing/2014/main" id="{CFF1002F-A3A8-4CAC-80F3-E166C4DED8F1}"/>
+                <a16:creationId xmlns:a16="http://schemas.microsoft.com/office/drawing/2014/main" id="{FCAD7575-2527-41B5-9052-05E0FEFAD23E}"/>
               </a:ext>
             </a:extLst>
           </p:cNvPr>
@@ -7254,7 +7277,7 @@
           <p:cNvPr id="7" name="interviews-detail">
             <a:extLst xmlns:a="http://schemas.openxmlformats.org/drawingml/2006/main">
               <a:ext uri="{FF2B5EF4-FFF2-40B4-BE49-F238E27FC236}">
-                <a16:creationId xmlns:a16="http://schemas.microsoft.com/office/drawing/2014/main" id="{6751364C-CE9C-402F-8B67-57DCBC2DC2F1}"/>
+                <a16:creationId xmlns:a16="http://schemas.microsoft.com/office/drawing/2014/main" id="{B5EE8C6B-BDEE-453A-87A4-79BE25A18DC2}"/>
               </a:ext>
             </a:extLst>
           </p:cNvPr>
@@ -7334,7 +7357,7 @@
           <p:cNvPr id="8" name="pilot-number">
             <a:extLst xmlns:a="http://schemas.openxmlformats.org/drawingml/2006/main">
               <a:ext uri="{FF2B5EF4-FFF2-40B4-BE49-F238E27FC236}">
-                <a16:creationId xmlns:a16="http://schemas.microsoft.com/office/drawing/2014/main" id="{EA178D45-B681-44BA-AEAD-1263D795242F}"/>
+                <a16:creationId xmlns:a16="http://schemas.microsoft.com/office/drawing/2014/main" id="{084184CE-1D63-49AC-B616-41380C45BCC3}"/>
               </a:ext>
             </a:extLst>
           </p:cNvPr>
@@ -7391,7 +7414,7 @@
           <p:cNvPr id="9" name="pilot-label">
             <a:extLst xmlns:a="http://schemas.openxmlformats.org/drawingml/2006/main">
               <a:ext uri="{FF2B5EF4-FFF2-40B4-BE49-F238E27FC236}">
-                <a16:creationId xmlns:a16="http://schemas.microsoft.com/office/drawing/2014/main" id="{F9F60D8E-53BE-4A6F-926C-11FEBD2C9D05}"/>
+                <a16:creationId xmlns:a16="http://schemas.microsoft.com/office/drawing/2014/main" id="{BA326149-F0AE-418C-9D31-12FCD380A321}"/>
               </a:ext>
             </a:extLst>
           </p:cNvPr>
@@ -7448,7 +7471,7 @@
           <p:cNvPr id="10" name="pilot-detail">
             <a:extLst xmlns:a="http://schemas.openxmlformats.org/drawingml/2006/main">
               <a:ext uri="{FF2B5EF4-FFF2-40B4-BE49-F238E27FC236}">
-                <a16:creationId xmlns:a16="http://schemas.microsoft.com/office/drawing/2014/main" id="{C19E6A9C-9986-4748-ACEF-28B8535AF385}"/>
+                <a16:creationId xmlns:a16="http://schemas.microsoft.com/office/drawing/2014/main" id="{87006EC6-59EB-4C16-9F4A-533B1FBAF976}"/>
               </a:ext>
             </a:extLst>
           </p:cNvPr>
@@ -7528,7 +7551,7 @@
           <p:cNvPr id="11" name="metric">
             <a:extLst xmlns:a="http://schemas.openxmlformats.org/drawingml/2006/main">
               <a:ext uri="{FF2B5EF4-FFF2-40B4-BE49-F238E27FC236}">
-                <a16:creationId xmlns:a16="http://schemas.microsoft.com/office/drawing/2014/main" id="{6518F526-5916-4DED-A86F-820F18274EC7}"/>
+                <a16:creationId xmlns:a16="http://schemas.microsoft.com/office/drawing/2014/main" id="{1C78275F-C5BD-48D1-996A-7314EE7708C1}"/>
               </a:ext>
             </a:extLst>
           </p:cNvPr>
@@ -7585,7 +7608,7 @@
           <p:cNvPr id="12" name="footer">
             <a:extLst xmlns:a="http://schemas.openxmlformats.org/drawingml/2006/main">
               <a:ext uri="{FF2B5EF4-FFF2-40B4-BE49-F238E27FC236}">
-                <a16:creationId xmlns:a16="http://schemas.microsoft.com/office/drawing/2014/main" id="{D64BC637-EA73-4D89-86FC-037BAF4265DF}"/>
+                <a16:creationId xmlns:a16="http://schemas.microsoft.com/office/drawing/2014/main" id="{7EB327A0-D7AA-4A3A-8CE4-D3C0EFEE14DF}"/>
               </a:ext>
             </a:extLst>
           </p:cNvPr>
@@ -7640,7 +7663,7 @@
     </p:spTree>
     <p:extLst>
       <p:ext uri="{BB962C8B-B14F-4D97-AF65-F5344CB8AC3E}">
-        <p14:creationId xmlns:p14="http://schemas.microsoft.com/office/powerpoint/2010/main" val="1673088521"/>
+        <p14:creationId xmlns:p14="http://schemas.microsoft.com/office/powerpoint/2010/main" val="118617713"/>
       </p:ext>
     </p:extLst>
   </p:cSld>
@@ -7671,7 +7694,7 @@
           <p:cNvPr id="14" name="wordmark">
             <a:extLst xmlns:a="http://schemas.openxmlformats.org/drawingml/2006/main">
               <a:ext uri="{FF2B5EF4-FFF2-40B4-BE49-F238E27FC236}">
-                <a16:creationId xmlns:a16="http://schemas.microsoft.com/office/drawing/2014/main" id="{384E9A23-28C2-4F42-ACA8-5DE0FA4FFE36}"/>
+                <a16:creationId xmlns:a16="http://schemas.microsoft.com/office/drawing/2014/main" id="{CEF6DEB6-C996-4258-84A5-5FDBC79CE73F}"/>
               </a:ext>
             </a:extLst>
           </p:cNvPr>
@@ -7728,7 +7751,7 @@
           <p:cNvPr id="2" name="page">
             <a:extLst xmlns:a="http://schemas.openxmlformats.org/drawingml/2006/main">
               <a:ext uri="{FF2B5EF4-FFF2-40B4-BE49-F238E27FC236}">
-                <a16:creationId xmlns:a16="http://schemas.microsoft.com/office/drawing/2014/main" id="{A3BC6D61-1A18-418A-A85B-DCB1FD20DE6C}"/>
+                <a16:creationId xmlns:a16="http://schemas.microsoft.com/office/drawing/2014/main" id="{E61E2BFB-FABE-46CC-961A-D6BE9AF45322}"/>
               </a:ext>
             </a:extLst>
           </p:cNvPr>
@@ -7785,7 +7808,7 @@
           <p:cNvPr id="3" name="title">
             <a:extLst xmlns:a="http://schemas.openxmlformats.org/drawingml/2006/main">
               <a:ext uri="{FF2B5EF4-FFF2-40B4-BE49-F238E27FC236}">
-                <a16:creationId xmlns:a16="http://schemas.microsoft.com/office/drawing/2014/main" id="{1067CEDC-EEEE-4FDA-B217-3F39472BCC9D}"/>
+                <a16:creationId xmlns:a16="http://schemas.microsoft.com/office/drawing/2014/main" id="{1A1791CE-5DC5-46A7-8445-092DF7B85359}"/>
               </a:ext>
             </a:extLst>
           </p:cNvPr>
@@ -7842,7 +7865,7 @@
           <p:cNvPr id="4" name="subtitle">
             <a:extLst xmlns:a="http://schemas.openxmlformats.org/drawingml/2006/main">
               <a:ext uri="{FF2B5EF4-FFF2-40B4-BE49-F238E27FC236}">
-                <a16:creationId xmlns:a16="http://schemas.microsoft.com/office/drawing/2014/main" id="{DD8AE1B5-28E0-42B1-A81B-4C0AEAAF974E}"/>
+                <a16:creationId xmlns:a16="http://schemas.microsoft.com/office/drawing/2014/main" id="{01C6D246-AFB2-4A3F-8725-C106A695B37D}"/>
               </a:ext>
             </a:extLst>
           </p:cNvPr>
@@ -7899,7 +7922,7 @@
           <p:cNvPr id="5" name="next-label">
             <a:extLst xmlns:a="http://schemas.openxmlformats.org/drawingml/2006/main">
               <a:ext uri="{FF2B5EF4-FFF2-40B4-BE49-F238E27FC236}">
-                <a16:creationId xmlns:a16="http://schemas.microsoft.com/office/drawing/2014/main" id="{468113A8-5AE9-4EA6-AD11-35F62859EDF6}"/>
+                <a16:creationId xmlns:a16="http://schemas.microsoft.com/office/drawing/2014/main" id="{EFECE817-D188-4BCE-AC2D-C5FEB2A4770B}"/>
               </a:ext>
             </a:extLst>
           </p:cNvPr>
@@ -7956,7 +7979,7 @@
           <p:cNvPr id="6" name="next-one">
             <a:extLst xmlns:a="http://schemas.openxmlformats.org/drawingml/2006/main">
               <a:ext uri="{FF2B5EF4-FFF2-40B4-BE49-F238E27FC236}">
-                <a16:creationId xmlns:a16="http://schemas.microsoft.com/office/drawing/2014/main" id="{92A01914-3AAE-4595-9E68-55CDE1A86E32}"/>
+                <a16:creationId xmlns:a16="http://schemas.microsoft.com/office/drawing/2014/main" id="{8CB1D90D-7106-44AF-8B2F-632D84A59521}"/>
               </a:ext>
             </a:extLst>
           </p:cNvPr>
@@ -8013,7 +8036,7 @@
           <p:cNvPr id="7" name="next-two">
             <a:extLst xmlns:a="http://schemas.openxmlformats.org/drawingml/2006/main">
               <a:ext uri="{FF2B5EF4-FFF2-40B4-BE49-F238E27FC236}">
-                <a16:creationId xmlns:a16="http://schemas.microsoft.com/office/drawing/2014/main" id="{73F7E7E0-B2F6-4A1E-8D87-1C8A53032E5D}"/>
+                <a16:creationId xmlns:a16="http://schemas.microsoft.com/office/drawing/2014/main" id="{AD206DB7-090C-43F4-A355-235F569266DF}"/>
               </a:ext>
             </a:extLst>
           </p:cNvPr>
@@ -8070,7 +8093,7 @@
           <p:cNvPr id="8" name="next-three">
             <a:extLst xmlns:a="http://schemas.openxmlformats.org/drawingml/2006/main">
               <a:ext uri="{FF2B5EF4-FFF2-40B4-BE49-F238E27FC236}">
-                <a16:creationId xmlns:a16="http://schemas.microsoft.com/office/drawing/2014/main" id="{D2A4F653-8708-4096-9557-867165A08305}"/>
+                <a16:creationId xmlns:a16="http://schemas.microsoft.com/office/drawing/2014/main" id="{BAAC475F-5B05-4479-A1A8-3BAF5A3ED8CA}"/>
               </a:ext>
             </a:extLst>
           </p:cNvPr>
@@ -8127,7 +8150,7 @@
           <p:cNvPr id="9" name="contribution-label">
             <a:extLst xmlns:a="http://schemas.openxmlformats.org/drawingml/2006/main">
               <a:ext uri="{FF2B5EF4-FFF2-40B4-BE49-F238E27FC236}">
-                <a16:creationId xmlns:a16="http://schemas.microsoft.com/office/drawing/2014/main" id="{C2DD8F23-ACC4-4DDC-BCBB-33C593DC8996}"/>
+                <a16:creationId xmlns:a16="http://schemas.microsoft.com/office/drawing/2014/main" id="{6D2D4774-505F-40E7-A799-6C653C3BF972}"/>
               </a:ext>
             </a:extLst>
           </p:cNvPr>
@@ -8184,7 +8207,7 @@
           <p:cNvPr id="10" name="contribution-name">
             <a:extLst xmlns:a="http://schemas.openxmlformats.org/drawingml/2006/main">
               <a:ext uri="{FF2B5EF4-FFF2-40B4-BE49-F238E27FC236}">
-                <a16:creationId xmlns:a16="http://schemas.microsoft.com/office/drawing/2014/main" id="{59DCE214-CF2D-4517-9D21-53859BCF3755}"/>
+                <a16:creationId xmlns:a16="http://schemas.microsoft.com/office/drawing/2014/main" id="{08B716DA-9F60-492A-8178-92FAE1CB9B7A}"/>
               </a:ext>
             </a:extLst>
           </p:cNvPr>
@@ -8230,6 +8253,7 @@
                 <a:latin typeface="Noto Sans"/>
                 <a:ea typeface="Noto Sans"/>
                 <a:cs typeface="Noto Sans"/>
+                <a:hlinkClick xmlns:r="http://schemas.openxmlformats.org/officeDocument/2006/relationships" r:id="Rd3031e0decbf47d7"/>
               </a:rPr>
               <a:t>@kindhandoff/guard</a:t>
             </a:r>
@@ -8241,7 +8265,7 @@
           <p:cNvPr id="11" name="contribution-role">
             <a:extLst xmlns:a="http://schemas.openxmlformats.org/drawingml/2006/main">
               <a:ext uri="{FF2B5EF4-FFF2-40B4-BE49-F238E27FC236}">
-                <a16:creationId xmlns:a16="http://schemas.microsoft.com/office/drawing/2014/main" id="{2CF92353-11E7-46C0-AECE-4353DE0B57CB}"/>
+                <a16:creationId xmlns:a16="http://schemas.microsoft.com/office/drawing/2014/main" id="{9124040F-262D-4DFE-B8A7-49A2FC0C1C92}"/>
               </a:ext>
             </a:extLst>
           </p:cNvPr>
@@ -8344,7 +8368,7 @@
           <p:cNvPr id="12" name="repo-link">
             <a:extLst xmlns:a="http://schemas.openxmlformats.org/drawingml/2006/main">
               <a:ext uri="{FF2B5EF4-FFF2-40B4-BE49-F238E27FC236}">
-                <a16:creationId xmlns:a16="http://schemas.microsoft.com/office/drawing/2014/main" id="{DF17C894-E508-44F9-8230-5D74AEF9C80A}"/>
+                <a16:creationId xmlns:a16="http://schemas.microsoft.com/office/drawing/2014/main" id="{7ED4C521-6AA2-4D9A-A03B-ADF0A56316B6}"/>
               </a:ext>
             </a:extLst>
           </p:cNvPr>
@@ -8390,7 +8414,7 @@
                 <a:latin typeface="Noto Sans"/>
                 <a:ea typeface="Noto Sans"/>
                 <a:cs typeface="Noto Sans"/>
-                <a:hlinkClick xmlns:r="http://schemas.openxmlformats.org/officeDocument/2006/relationships" r:id="R64360b5a980d4b36"/>
+                <a:hlinkClick xmlns:r="http://schemas.openxmlformats.org/officeDocument/2006/relationships" r:id="R6a7a3806eeb5463b"/>
               </a:rPr>
               <a:t>github.com/shi1720/Amazon-Developer-Hackathon</a:t>
             </a:r>
@@ -8399,10 +8423,10 @@
       </p:sp>
       <p:sp>
         <p:nvSpPr>
-          <p:cNvPr id="13" name="preview-url">
-            <a:extLst xmlns:a="http://schemas.openxmlformats.org/drawingml/2006/main">
-              <a:ext uri="{FF2B5EF4-FFF2-40B4-BE49-F238E27FC236}">
-                <a16:creationId xmlns:a16="http://schemas.microsoft.com/office/drawing/2014/main" id="{219BE0E1-BD54-4863-9108-4550FF80BE4A}"/>
+          <p:cNvPr id="13" name="hosted-url">
+            <a:extLst xmlns:a="http://schemas.openxmlformats.org/drawingml/2006/main">
+              <a:ext uri="{FF2B5EF4-FFF2-40B4-BE49-F238E27FC236}">
+                <a16:creationId xmlns:a16="http://schemas.microsoft.com/office/drawing/2014/main" id="{FEBDB23B-526E-4015-9166-8BB0E7123D18}"/>
               </a:ext>
             </a:extLst>
           </p:cNvPr>
@@ -8448,8 +8472,9 @@
                 <a:latin typeface="Noto Sans"/>
                 <a:ea typeface="Noto Sans"/>
                 <a:cs typeface="Noto Sans"/>
-              </a:rPr>
-              <a:t>Preview, deployment pending: shivam-amazon-hackathon.sg127977958.chatgpt.site</a:t>
+                <a:hlinkClick xmlns:r="http://schemas.openxmlformats.org/officeDocument/2006/relationships" r:id="Re2ed6c2e287a424d"/>
+              </a:rPr>
+              <a:t>Public app — verified: kindhandoff.web.app</a:t>
             </a:r>
           </a:p>
         </p:txBody>
@@ -8457,7 +8482,7 @@
     </p:spTree>
     <p:extLst>
       <p:ext uri="{BB962C8B-B14F-4D97-AF65-F5344CB8AC3E}">
-        <p14:creationId xmlns:p14="http://schemas.microsoft.com/office/powerpoint/2010/main" val="558452029"/>
+        <p14:creationId xmlns:p14="http://schemas.microsoft.com/office/powerpoint/2010/main" val="1217971384"/>
       </p:ext>
     </p:extLst>
   </p:cSld>

</xml_diff>

<commit_message>
Complete household workflows and produce the captioned hackathon demo
</commit_message>
<xml_diff>
--- a/docs/deliverables/KindHandoff-Pitch.pptx
+++ b/docs/deliverables/KindHandoff-Pitch.pptx
@@ -2,20 +2,20 @@
 <file path=ppt/presentation.xml><?xml version="1.0" encoding="utf-8"?>
 <p:presentation xmlns:p="http://schemas.openxmlformats.org/presentationml/2006/main">
   <p:sldMasterIdLst>
-    <p:sldMasterId xmlns:r="http://schemas.openxmlformats.org/officeDocument/2006/relationships" id="2147483648" r:id="R84e28a3d1abc401c"/>
+    <p:sldMasterId xmlns:r="http://schemas.openxmlformats.org/officeDocument/2006/relationships" id="2147483648" r:id="R7d410e0f9bbd44ff"/>
   </p:sldMasterIdLst>
   <p:notesMasterIdLst>
-    <p:notesMasterId xmlns:r="http://schemas.openxmlformats.org/officeDocument/2006/relationships" r:id="Rb276a4d8c6d1469a"/>
+    <p:notesMasterId xmlns:r="http://schemas.openxmlformats.org/officeDocument/2006/relationships" r:id="R517ead20437d40b4"/>
   </p:notesMasterIdLst>
   <p:sldIdLst>
-    <p:sldId xmlns:r="http://schemas.openxmlformats.org/officeDocument/2006/relationships" id="256" r:id="Rfd1c4e9a30f74066"/>
-    <p:sldId xmlns:r="http://schemas.openxmlformats.org/officeDocument/2006/relationships" id="257" r:id="R370d6d3e6ad44298"/>
-    <p:sldId xmlns:r="http://schemas.openxmlformats.org/officeDocument/2006/relationships" id="258" r:id="Ree353d33b88b4e29"/>
-    <p:sldId xmlns:r="http://schemas.openxmlformats.org/officeDocument/2006/relationships" id="259" r:id="R82029e7d3f2f464e"/>
-    <p:sldId xmlns:r="http://schemas.openxmlformats.org/officeDocument/2006/relationships" id="260" r:id="R88175944537b4924"/>
-    <p:sldId xmlns:r="http://schemas.openxmlformats.org/officeDocument/2006/relationships" id="261" r:id="R32ce1de393e44e26"/>
-    <p:sldId xmlns:r="http://schemas.openxmlformats.org/officeDocument/2006/relationships" id="262" r:id="Rddf417b101a14c96"/>
-    <p:sldId xmlns:r="http://schemas.openxmlformats.org/officeDocument/2006/relationships" id="263" r:id="Rb41b1d7ded2141fc"/>
+    <p:sldId xmlns:r="http://schemas.openxmlformats.org/officeDocument/2006/relationships" id="256" r:id="R05263362c85f41e7"/>
+    <p:sldId xmlns:r="http://schemas.openxmlformats.org/officeDocument/2006/relationships" id="257" r:id="R2548aeea0a434964"/>
+    <p:sldId xmlns:r="http://schemas.openxmlformats.org/officeDocument/2006/relationships" id="258" r:id="R2353fb4cdcc04077"/>
+    <p:sldId xmlns:r="http://schemas.openxmlformats.org/officeDocument/2006/relationships" id="259" r:id="Re0b979eebbfb4925"/>
+    <p:sldId xmlns:r="http://schemas.openxmlformats.org/officeDocument/2006/relationships" id="260" r:id="Rff8ed195a44c40f6"/>
+    <p:sldId xmlns:r="http://schemas.openxmlformats.org/officeDocument/2006/relationships" id="261" r:id="R4c0a9b8e3c404de1"/>
+    <p:sldId xmlns:r="http://schemas.openxmlformats.org/officeDocument/2006/relationships" id="262" r:id="R8f2c88f4d7584429"/>
+    <p:sldId xmlns:r="http://schemas.openxmlformats.org/officeDocument/2006/relationships" id="263" r:id="Rd9f822ba051b4ec1"/>
   </p:sldIdLst>
   <p:sldSz cx="12192000" cy="6858000"/>
   <p:notesSz cx="6858000" cy="9144000"/>
@@ -519,7 +519,7 @@
           <a:lstStyle xmlns:a="http://schemas.openxmlformats.org/drawingml/2006/main"/>
           <a:p xmlns:a="http://schemas.openxmlformats.org/drawingml/2006/main">
             <a:r>
-              <a:t>Illustrative product scenario supplied for this deck. The deterministic planner proposes Jo for the 14:30–14:45 bag task because she can access the house during that interval. Dev can provide the 15:00–16:00 ride but cannot cover the earlier bag interval because his availability starts at 14:45. A feasible proposal is not an accepted commitment.</a:t>
+              <a:t>Illustrative product scenario supplied for this deck. The deterministic planner proposes Jo for the 14:30-14:45 bag task because she can access the house during that interval. Dev can provide the 15:00-16:00 ride but cannot cover the earlier bag interval because his availability starts at 14:45. A feasible proposal is not an accepted commitment.</a:t>
             </a:r>
           </a:p>
         </p:txBody>
@@ -659,7 +659,7 @@
           <a:lstStyle xmlns:a="http://schemas.openxmlformats.org/drawingml/2006/main"/>
           <a:p xmlns:a="http://schemas.openxmlformats.org/drawingml/2006/main">
             <a:r>
-              <a:t>Architecture supplied by the implementation team. React 19.3 and Vite 8.3 frontend on Firebase Hosting. MCP server uses @modelcontextprotocol/sdk 1.30.0, Streamable HTTP, and protocol 2025-11-25 in Cloud Functions v2 on Node 22. Authenticated tools validate inputs and membership, use deterministic planning and @kindhandoff/guard, and write household-scoped Firestore Standard records with version-aware transactions. Firebase Authentication email/password establishes account identity and the app uses a secure __session cookie plus one-time helper invitations. Firestore and Functions run in us-central1. Runtime settings: 256 MiB, 1 CPU, concurrency 40, minInstances 0, maxInstances 2, timeout 30 seconds. Seven-day artifact cleanup is configured. The guard library provides state transitions, coverage accounting, and candidate ranking. App code owns dependency readiness, exact identity authorization, and contentVersion brief acknowledgments. The deterministic browser language simulator uses Client and StreamableHTTPClientTransport to make real HTTP MCP initialize and tools/call requests. External MCP clients use the same server. No load-test result, native Alexa connection, cloud LLM, or AWS use is asserted. The implementation lead confirmed the public Firebase release at kindhandoff.web.app. Signed-out browser entry and the reviewed cancellation-to-Jo/Dev-plan-to-offers flow passed at desktop width 1365 and mobile width 390 without horizontal overflow. Against production, 15 HTTP MCP calls passed using protocol 2025-11-25, 13 multi-user checks passed across four sessions, and 11 real Firebase Authentication checks passed, including new-account verification, secure cookie, private-circle persistence, sign-in, export, sign-out, and deletion. Root unit tests (29) and Firestore integration checks (17) passed; main CI passed for source e3e8c5f. The separate browser authentication and invitation walkthrough was still in progress when this confirmation was recorded. No customer, load-test, live Alexa, cloud LLM, or AWS outcome is claimed. Amazon documentation: https://developer.amazon.com/docs/alexaplus/add-ons/mcp-toolkit-overview.html and https://www.developer.amazon.com/docs/alexaplus/add-ons/mcp-toolkit-quickstart.html.</a:t>
+              <a:t>Architecture supplied by the implementation team. React 19.3 and Vite 8.3 frontend on Firebase Hosting. MCP server uses @modelcontextprotocol/sdk 1.30.0, Streamable HTTP, and protocol 2025-11-25 in Cloud Functions v2 on Node 22. Authenticated tools validate inputs and membership, use deterministic planning and @kindhandoff/guard, and write household-scoped Firestore Standard records with version-aware transactions. Firebase Authentication email/password establishes account identity and the app uses a secure __session cookie plus one-time helper invitations. Firestore and Functions run in us-central1. Runtime settings: 256 MiB, 1 CPU, concurrency 40, minInstances 0, maxInstances 2, timeout 30 seconds. Seven-day artifact cleanup is configured. The guard library provides state transitions, coverage accounting, and candidate ranking. App code owns dependency readiness, exact identity authorization, and contentVersion brief acknowledgments. The deterministic browser language simulator uses Client and StreamableHTTPClientTransport to make real HTTP MCP initialize and tools/call requests. External MCP clients use the same server. No load-test result, native Alexa connection, cloud LLM, or AWS use is asserted. Public workflow verification is documented in the repository evidence. Amazon documentation: https://developer.amazon.com/docs/alexaplus/add-ons/mcp-toolkit-overview.html and https://www.developer.amazon.com/docs/alexaplus/add-ons/mcp-toolkit-quickstart.html.</a:t>
             </a:r>
           </a:p>
         </p:txBody>
@@ -799,7 +799,7 @@
           <a:lstStyle xmlns:a="http://schemas.openxmlformats.org/drawingml/2006/main"/>
           <a:p xmlns:a="http://schemas.openxmlformats.org/drawingml/2006/main">
             <a:r>
-              <a:t>The $12 per household per month price is an unvalidated hypothesis. The market-and-business.md brief proposes testing a $9–15 range after real use. All helpers are included to avoid a seat-pricing incentive against participation. No traction or financial results exist in the materials provided. The Firebase cost brief is arithmetic from declared visible-page polling, query, retention, and allocated-time assumptions. Four 15-minute visible sessions yield 304 refreshes per household/day, with one GET /api/session each. Five document reads per refresh and 20 per MCP action remain conservative budgets. With the other model assumptions, selected serving charges at five households fit unused allowances, or are about $0.39/month if the shared Cloud Run compute allowance is already consumed. The proposed $10 pilot operating allowance also anticipates deployment resources and uncertainty; it is neither an invoice forecast nor a cap. Billing is enabled. Builds, images, support, acquisition, and optional model calls are separate. Source rates: https://cloud.google.com/run/pricing , https://cloud.google.com/firestore/pricing , https://firebase.google.com/docs/hosting/usage-quotas-pricing . Related category price reference: https://caringvillage.com/pricing/ .</a:t>
+              <a:t>The $12 per household per month price is an unvalidated hypothesis. The market-and-business.md brief proposes testing a $9-15 range after real use. All helpers are included to avoid a seat-pricing incentive against participation. No traction or financial results exist in the materials provided. The Firebase cost brief is arithmetic from declared visible-page polling, query, retention, and allocated-time assumptions. Four 15-minute visible sessions yield 304 refreshes per household/day, with one GET /api/session each. Six document reads per authenticated refresh reflect transactional authorization. The model budgets six reads for every refresh and other API request, plus 20 per MCP action, totaling 2,016 reads per household/day pending telemetry. With the other model assumptions, selected serving charges at five households fit unused allowances, or are about $0.39/month if the shared Cloud Run compute allowance is already consumed. The proposed $10 pilot operating allowance also anticipates deployment resources and uncertainty; it is neither an invoice forecast nor a cap. Billing is enabled. Builds, images, support, acquisition, and optional model calls are separate. Source rates: https://cloud.google.com/run/pricing , https://cloud.google.com/firestore/pricing , https://firebase.google.com/docs/hosting/usage-quotas-pricing . Related category price reference: https://caringvillage.com/pricing/ .</a:t>
             </a:r>
           </a:p>
         </p:txBody>
@@ -939,7 +939,7 @@
           <a:lstStyle xmlns:a="http://schemas.openxmlformats.org/drawingml/2006/main"/>
           <a:p xmlns:a="http://schemas.openxmlformats.org/drawingml/2006/main">
             <a:r>
-              <a:t>Creator: Shivam Gupta. Public MIT main repository: https://github.com/shi1720/Amazon-Developer-Hackathon. Firebase application: https://kindhandoff.web.app. The implementation lead confirmed the public Firebase release at kindhandoff.web.app. Signed-out browser entry and the reviewed cancellation-to-Jo/Dev-plan-to-offers flow passed at desktop width 1365 and mobile width 390 without horizontal overflow. Against production, 15 HTTP MCP calls passed using protocol 2025-11-25, 13 multi-user checks passed across four sessions, and 11 real Firebase Authentication checks passed, including new-account verification, secure cookie, private-circle persistence, sign-in, export, sign-out, and deletion. Root unit tests (29) and Firestore integration checks (17) passed; main CI passed for source e3e8c5f. The separate browser authentication and invitation walkthrough was still in progress when this confirmation was recorded. No customer, load-test, live Alexa, cloud LLM, or AWS outcome is claimed. No public video URL has been claimed. The additional Open Source contribution is @kindhandoff/guard, public and MIT licensed: https://github.com/shi1720/kindhandoff-guard. Contribution: https://github.com/shi1720/kindhandoff-guard/commit/04a15ea016e552e3c031b9ec371af2df6a1de105. The library covers state transitions, coverage accounting, and candidate ranking. App code owns dependency readiness, exact identity authorization, and content-version acknowledgments. Next steps include recording a public English video under three minutes, household research, and live Alexa+ onboarding where access permits.</a:t>
+              <a:t>Creator: Shivam Gupta. Public MIT main repository: https://github.com/shi1720/Amazon-Developer-Hackathon. Firebase application: https://kindhandoff.web.app. Public workflow verification is documented in the repository evidence. No public video URL has been claimed. The additional Open Source contribution is @kindhandoff/guard, public and MIT licensed: https://github.com/shi1720/kindhandoff-guard. Contribution: https://github.com/shi1720/kindhandoff-guard/commit/04a15ea016e552e3c031b9ec371af2df6a1de105. The library covers state transitions, coverage accounting, and candidate ranking. App code owns dependency readiness, exact identity authorization, and content-version acknowledgments. Next steps include publishing the English captioned video under three minutes, household research, and live Alexa+ onboarding where access permits.</a:t>
             </a:r>
           </a:p>
         </p:txBody>
@@ -1007,7 +1007,7 @@
   </p:cSld>
   <p:clrMap bg1="lt1" tx1="dk1" bg2="lt2" tx2="dk2" accent1="accent1" accent2="accent2" accent3="accent3" accent4="accent4" accent5="accent5" accent6="accent6" hlink="hlink" folHlink="folHlink"/>
   <p:sldLayoutIdLst>
-    <p:sldLayoutId xmlns:r="http://schemas.openxmlformats.org/officeDocument/2006/relationships" id="2147483649" r:id="R61e3de921ec24ac7"/>
+    <p:sldLayoutId xmlns:r="http://schemas.openxmlformats.org/officeDocument/2006/relationships" id="2147483649" r:id="R354d02a6e3214ab2"/>
   </p:sldLayoutIdLst>
   <p:txStyles>
     <p:titleStyle>
@@ -1558,7 +1558,7 @@
           <p:cNvPr id="15" name="wordmark">
             <a:extLst xmlns:a="http://schemas.openxmlformats.org/drawingml/2006/main">
               <a:ext uri="{FF2B5EF4-FFF2-40B4-BE49-F238E27FC236}">
-                <a16:creationId xmlns:a16="http://schemas.microsoft.com/office/drawing/2014/main" id="{892A923C-E32E-4E9C-AA8B-0A3B0B809552}"/>
+                <a16:creationId xmlns:a16="http://schemas.microsoft.com/office/drawing/2014/main" id="{51D8E2DF-E99E-4C3B-8F1C-2E571F61EB8E}"/>
               </a:ext>
             </a:extLst>
           </p:cNvPr>
@@ -1615,7 +1615,7 @@
           <p:cNvPr id="2" name="page">
             <a:extLst xmlns:a="http://schemas.openxmlformats.org/drawingml/2006/main">
               <a:ext uri="{FF2B5EF4-FFF2-40B4-BE49-F238E27FC236}">
-                <a16:creationId xmlns:a16="http://schemas.microsoft.com/office/drawing/2014/main" id="{7F381C78-17E8-4FBC-B489-3CF092ABF8F9}"/>
+                <a16:creationId xmlns:a16="http://schemas.microsoft.com/office/drawing/2014/main" id="{9A46450F-7318-4259-AF80-A482121D189C}"/>
               </a:ext>
             </a:extLst>
           </p:cNvPr>
@@ -1672,7 +1672,7 @@
           <p:cNvPr id="3" name="cover-title">
             <a:extLst xmlns:a="http://schemas.openxmlformats.org/drawingml/2006/main">
               <a:ext uri="{FF2B5EF4-FFF2-40B4-BE49-F238E27FC236}">
-                <a16:creationId xmlns:a16="http://schemas.microsoft.com/office/drawing/2014/main" id="{DEA8E1B4-000B-49BA-BD38-47785A5805BA}"/>
+                <a16:creationId xmlns:a16="http://schemas.microsoft.com/office/drawing/2014/main" id="{92D1E6ED-3D97-421D-A620-B71268092B4F}"/>
               </a:ext>
             </a:extLst>
           </p:cNvPr>
@@ -1752,7 +1752,7 @@
           <p:cNvPr id="4" name="cover-problem">
             <a:extLst xmlns:a="http://schemas.openxmlformats.org/drawingml/2006/main">
               <a:ext uri="{FF2B5EF4-FFF2-40B4-BE49-F238E27FC236}">
-                <a16:creationId xmlns:a16="http://schemas.microsoft.com/office/drawing/2014/main" id="{E13DD999-8E39-4092-A75D-B5FB98BD1FF0}"/>
+                <a16:creationId xmlns:a16="http://schemas.microsoft.com/office/drawing/2014/main" id="{7073BBE0-5E9C-4D90-B685-D41F4160AB6A}"/>
               </a:ext>
             </a:extLst>
           </p:cNvPr>
@@ -1832,7 +1832,7 @@
           <p:cNvPr id="5" name="creator">
             <a:extLst xmlns:a="http://schemas.openxmlformats.org/drawingml/2006/main">
               <a:ext uri="{FF2B5EF4-FFF2-40B4-BE49-F238E27FC236}">
-                <a16:creationId xmlns:a16="http://schemas.microsoft.com/office/drawing/2014/main" id="{F33EDB6A-029B-4B04-AB23-C354F820BF35}"/>
+                <a16:creationId xmlns:a16="http://schemas.microsoft.com/office/drawing/2014/main" id="{DAD85AF9-1620-480A-B1DF-237786C45BD2}"/>
               </a:ext>
             </a:extLst>
           </p:cNvPr>
@@ -1889,7 +1889,7 @@
           <p:cNvPr id="6" name="bag-node">
             <a:extLst xmlns:a="http://schemas.openxmlformats.org/drawingml/2006/main">
               <a:ext uri="{FF2B5EF4-FFF2-40B4-BE49-F238E27FC236}">
-                <a16:creationId xmlns:a16="http://schemas.microsoft.com/office/drawing/2014/main" id="{67822C24-B3E5-4CD2-8646-F1C0C61BC319}"/>
+                <a16:creationId xmlns:a16="http://schemas.microsoft.com/office/drawing/2014/main" id="{C64D75C5-3EE7-4C70-A5FE-CD09D9A81198}"/>
               </a:ext>
             </a:extLst>
           </p:cNvPr>
@@ -1920,7 +1920,7 @@
           <p:cNvPr id="7" name="bag-time">
             <a:extLst xmlns:a="http://schemas.openxmlformats.org/drawingml/2006/main">
               <a:ext uri="{FF2B5EF4-FFF2-40B4-BE49-F238E27FC236}">
-                <a16:creationId xmlns:a16="http://schemas.microsoft.com/office/drawing/2014/main" id="{148B5D20-A612-4BB3-A0D3-5B84710B3F0A}"/>
+                <a16:creationId xmlns:a16="http://schemas.microsoft.com/office/drawing/2014/main" id="{E88BA149-394F-46B9-96D9-64BE863A53D6}"/>
               </a:ext>
             </a:extLst>
           </p:cNvPr>
@@ -1967,7 +1967,7 @@
                 <a:ea typeface="Noto Sans"/>
                 <a:cs typeface="Noto Sans"/>
               </a:rPr>
-              <a:t>14:30–14:45</a:t>
+              <a:t>14:30-14:45</a:t>
             </a:r>
           </a:p>
         </p:txBody>
@@ -1977,7 +1977,7 @@
           <p:cNvPr id="8" name="bag-task">
             <a:extLst xmlns:a="http://schemas.openxmlformats.org/drawingml/2006/main">
               <a:ext uri="{FF2B5EF4-FFF2-40B4-BE49-F238E27FC236}">
-                <a16:creationId xmlns:a16="http://schemas.microsoft.com/office/drawing/2014/main" id="{71F58339-814F-4395-BEC3-CE62C36BD16D}"/>
+                <a16:creationId xmlns:a16="http://schemas.microsoft.com/office/drawing/2014/main" id="{12836814-D379-4CF1-8964-CB10CBE3562D}"/>
               </a:ext>
             </a:extLst>
           </p:cNvPr>
@@ -2034,7 +2034,7 @@
           <p:cNvPr id="9" name="ride-node">
             <a:extLst xmlns:a="http://schemas.openxmlformats.org/drawingml/2006/main">
               <a:ext uri="{FF2B5EF4-FFF2-40B4-BE49-F238E27FC236}">
-                <a16:creationId xmlns:a16="http://schemas.microsoft.com/office/drawing/2014/main" id="{85D9831D-F11B-4EBE-97B8-7CD95E9966A4}"/>
+                <a16:creationId xmlns:a16="http://schemas.microsoft.com/office/drawing/2014/main" id="{1C20C8D9-7AD3-4489-82DA-345C937F9E48}"/>
               </a:ext>
             </a:extLst>
           </p:cNvPr>
@@ -2065,7 +2065,7 @@
           <p:cNvPr id="10" name="ride-time">
             <a:extLst xmlns:a="http://schemas.openxmlformats.org/drawingml/2006/main">
               <a:ext uri="{FF2B5EF4-FFF2-40B4-BE49-F238E27FC236}">
-                <a16:creationId xmlns:a16="http://schemas.microsoft.com/office/drawing/2014/main" id="{90B88914-18DB-43FA-9DF3-A4E712E18784}"/>
+                <a16:creationId xmlns:a16="http://schemas.microsoft.com/office/drawing/2014/main" id="{EA1385BF-546F-4A12-B8A6-2CEB9D87B135}"/>
               </a:ext>
             </a:extLst>
           </p:cNvPr>
@@ -2112,7 +2112,7 @@
                 <a:ea typeface="Noto Sans"/>
                 <a:cs typeface="Noto Sans"/>
               </a:rPr>
-              <a:t>15:00–16:00</a:t>
+              <a:t>15:00-16:00</a:t>
             </a:r>
           </a:p>
         </p:txBody>
@@ -2122,7 +2122,7 @@
           <p:cNvPr id="11" name="ride-task">
             <a:extLst xmlns:a="http://schemas.openxmlformats.org/drawingml/2006/main">
               <a:ext uri="{FF2B5EF4-FFF2-40B4-BE49-F238E27FC236}">
-                <a16:creationId xmlns:a16="http://schemas.microsoft.com/office/drawing/2014/main" id="{F36C1875-FE78-479D-8C91-E01BE4FF8859}"/>
+                <a16:creationId xmlns:a16="http://schemas.microsoft.com/office/drawing/2014/main" id="{F3948D38-1134-4CC3-BCC6-85E9E335BE4E}"/>
               </a:ext>
             </a:extLst>
           </p:cNvPr>
@@ -2205,7 +2205,7 @@
           <p:cNvPr id="13" name="prerequisite-label">
             <a:extLst xmlns:a="http://schemas.openxmlformats.org/drawingml/2006/main">
               <a:ext uri="{FF2B5EF4-FFF2-40B4-BE49-F238E27FC236}">
-                <a16:creationId xmlns:a16="http://schemas.microsoft.com/office/drawing/2014/main" id="{2A2B9376-6CF0-4AE0-AD66-510A38B07B87}"/>
+                <a16:creationId xmlns:a16="http://schemas.microsoft.com/office/drawing/2014/main" id="{53F3BAB4-A049-4C27-88B3-8F728B302758}"/>
               </a:ext>
             </a:extLst>
           </p:cNvPr>
@@ -2262,7 +2262,7 @@
           <p:cNvPr id="14" name="footer">
             <a:extLst xmlns:a="http://schemas.openxmlformats.org/drawingml/2006/main">
               <a:ext uri="{FF2B5EF4-FFF2-40B4-BE49-F238E27FC236}">
-                <a16:creationId xmlns:a16="http://schemas.microsoft.com/office/drawing/2014/main" id="{1CC35F60-E268-45AF-8CB0-85D1246EC988}"/>
+                <a16:creationId xmlns:a16="http://schemas.microsoft.com/office/drawing/2014/main" id="{9C733982-8038-4C19-9CD5-178DA0639203}"/>
               </a:ext>
             </a:extLst>
           </p:cNvPr>
@@ -2317,7 +2317,7 @@
     </p:spTree>
     <p:extLst>
       <p:ext uri="{BB962C8B-B14F-4D97-AF65-F5344CB8AC3E}">
-        <p14:creationId xmlns:p14="http://schemas.microsoft.com/office/powerpoint/2010/main" val="1919861995"/>
+        <p14:creationId xmlns:p14="http://schemas.microsoft.com/office/powerpoint/2010/main" val="117720750"/>
       </p:ext>
     </p:extLst>
   </p:cSld>
@@ -2348,7 +2348,7 @@
           <p:cNvPr id="7" name="wordmark">
             <a:extLst xmlns:a="http://schemas.openxmlformats.org/drawingml/2006/main">
               <a:ext uri="{FF2B5EF4-FFF2-40B4-BE49-F238E27FC236}">
-                <a16:creationId xmlns:a16="http://schemas.microsoft.com/office/drawing/2014/main" id="{81B3D72F-894E-408F-8E85-9016722D6B62}"/>
+                <a16:creationId xmlns:a16="http://schemas.microsoft.com/office/drawing/2014/main" id="{8B378D68-D653-45A4-8280-E2FA8CB1BAD4}"/>
               </a:ext>
             </a:extLst>
           </p:cNvPr>
@@ -2405,7 +2405,7 @@
           <p:cNvPr id="2" name="page">
             <a:extLst xmlns:a="http://schemas.openxmlformats.org/drawingml/2006/main">
               <a:ext uri="{FF2B5EF4-FFF2-40B4-BE49-F238E27FC236}">
-                <a16:creationId xmlns:a16="http://schemas.microsoft.com/office/drawing/2014/main" id="{3728E3D0-1043-4771-8243-B8EDE81D7AFB}"/>
+                <a16:creationId xmlns:a16="http://schemas.microsoft.com/office/drawing/2014/main" id="{6FF166E4-6E2D-4709-A8DC-1935372D428F}"/>
               </a:ext>
             </a:extLst>
           </p:cNvPr>
@@ -2462,7 +2462,7 @@
           <p:cNvPr id="3" name="title">
             <a:extLst xmlns:a="http://schemas.openxmlformats.org/drawingml/2006/main">
               <a:ext uri="{FF2B5EF4-FFF2-40B4-BE49-F238E27FC236}">
-                <a16:creationId xmlns:a16="http://schemas.microsoft.com/office/drawing/2014/main" id="{58949647-7E21-4E67-A37C-B8855F06AC45}"/>
+                <a16:creationId xmlns:a16="http://schemas.microsoft.com/office/drawing/2014/main" id="{A30FE265-9361-4E18-8B96-3D7A2912950F}"/>
               </a:ext>
             </a:extLst>
           </p:cNvPr>
@@ -2519,7 +2519,7 @@
           <p:cNvPr id="4" name="subtitle">
             <a:extLst xmlns:a="http://schemas.openxmlformats.org/drawingml/2006/main">
               <a:ext uri="{FF2B5EF4-FFF2-40B4-BE49-F238E27FC236}">
-                <a16:creationId xmlns:a16="http://schemas.microsoft.com/office/drawing/2014/main" id="{29BCC57B-57A0-4F1A-9E5C-EA03D503DD5C}"/>
+                <a16:creationId xmlns:a16="http://schemas.microsoft.com/office/drawing/2014/main" id="{C21E17C0-7FE2-4D2C-83E3-4C71462CDB57}"/>
               </a:ext>
             </a:extLst>
           </p:cNvPr>
@@ -2793,7 +2793,7 @@
                           <a:ea typeface="Noto Sans"/>
                           <a:cs typeface="Noto Sans"/>
                         </a:rPr>
-                        <a:t>Home access 14:00–15:00</a:t>
+                        <a:t>Home access 14:00-15:00</a:t>
                       </a:r>
                     </a:p>
                     <a:p>
@@ -2832,7 +2832,7 @@
                           <a:ea typeface="Noto Sans"/>
                           <a:cs typeface="Noto Sans"/>
                         </a:rPr>
-                        <a:t>Bag 14:30–14:45</a:t>
+                        <a:t>Bag 14:30-14:45</a:t>
                       </a:r>
                     </a:p>
                   </a:txBody>
@@ -2925,7 +2925,7 @@
                           <a:ea typeface="Noto Sans"/>
                           <a:cs typeface="Noto Sans"/>
                         </a:rPr>
-                        <a:t>Ride 15:00–16:00</a:t>
+                        <a:t>Ride 15:00-16:00</a:t>
                       </a:r>
                     </a:p>
                   </a:txBody>
@@ -2945,7 +2945,7 @@
           <p:cNvPr id="6" name="footer">
             <a:extLst xmlns:a="http://schemas.openxmlformats.org/drawingml/2006/main">
               <a:ext uri="{FF2B5EF4-FFF2-40B4-BE49-F238E27FC236}">
-                <a16:creationId xmlns:a16="http://schemas.microsoft.com/office/drawing/2014/main" id="{4D882A3A-A18C-4387-A202-8C60075A6941}"/>
+                <a16:creationId xmlns:a16="http://schemas.microsoft.com/office/drawing/2014/main" id="{CFD1BEC8-2612-47DC-A514-35CE0DC5E5CF}"/>
               </a:ext>
             </a:extLst>
           </p:cNvPr>
@@ -3000,7 +3000,7 @@
     </p:spTree>
     <p:extLst>
       <p:ext uri="{BB962C8B-B14F-4D97-AF65-F5344CB8AC3E}">
-        <p14:creationId xmlns:p14="http://schemas.microsoft.com/office/powerpoint/2010/main" val="696775243"/>
+        <p14:creationId xmlns:p14="http://schemas.microsoft.com/office/powerpoint/2010/main" val="1970819257"/>
       </p:ext>
     </p:extLst>
   </p:cSld>
@@ -3031,7 +3031,7 @@
           <p:cNvPr id="26" name="wordmark">
             <a:extLst xmlns:a="http://schemas.openxmlformats.org/drawingml/2006/main">
               <a:ext uri="{FF2B5EF4-FFF2-40B4-BE49-F238E27FC236}">
-                <a16:creationId xmlns:a16="http://schemas.microsoft.com/office/drawing/2014/main" id="{7DCF2176-3FF8-476C-A7D1-83AF92D7BA42}"/>
+                <a16:creationId xmlns:a16="http://schemas.microsoft.com/office/drawing/2014/main" id="{01890F5B-8FB9-4EED-9BB1-C427504E1E53}"/>
               </a:ext>
             </a:extLst>
           </p:cNvPr>
@@ -3088,7 +3088,7 @@
           <p:cNvPr id="2" name="page">
             <a:extLst xmlns:a="http://schemas.openxmlformats.org/drawingml/2006/main">
               <a:ext uri="{FF2B5EF4-FFF2-40B4-BE49-F238E27FC236}">
-                <a16:creationId xmlns:a16="http://schemas.microsoft.com/office/drawing/2014/main" id="{422E1C72-9EBF-443B-91C1-E0075B6566F1}"/>
+                <a16:creationId xmlns:a16="http://schemas.microsoft.com/office/drawing/2014/main" id="{B67B566E-71AE-4B4B-B5A5-0665FC980DD3}"/>
               </a:ext>
             </a:extLst>
           </p:cNvPr>
@@ -3145,7 +3145,7 @@
           <p:cNvPr id="3" name="title">
             <a:extLst xmlns:a="http://schemas.openxmlformats.org/drawingml/2006/main">
               <a:ext uri="{FF2B5EF4-FFF2-40B4-BE49-F238E27FC236}">
-                <a16:creationId xmlns:a16="http://schemas.microsoft.com/office/drawing/2014/main" id="{1FCD8565-93C1-4D3C-BD79-F2BA2394F1D8}"/>
+                <a16:creationId xmlns:a16="http://schemas.microsoft.com/office/drawing/2014/main" id="{82E5C0F2-19BE-4D91-A6FE-36305A219E1D}"/>
               </a:ext>
             </a:extLst>
           </p:cNvPr>
@@ -3202,7 +3202,7 @@
           <p:cNvPr id="4" name="subtitle">
             <a:extLst xmlns:a="http://schemas.openxmlformats.org/drawingml/2006/main">
               <a:ext uri="{FF2B5EF4-FFF2-40B4-BE49-F238E27FC236}">
-                <a16:creationId xmlns:a16="http://schemas.microsoft.com/office/drawing/2014/main" id="{33BFBF60-AF43-4CC2-8672-1823785409AB}"/>
+                <a16:creationId xmlns:a16="http://schemas.microsoft.com/office/drawing/2014/main" id="{8B5E1DD5-4342-4038-8290-C91D2DC7984B}"/>
               </a:ext>
             </a:extLst>
           </p:cNvPr>
@@ -3259,7 +3259,7 @@
           <p:cNvPr id="5" name="state-0">
             <a:extLst xmlns:a="http://schemas.openxmlformats.org/drawingml/2006/main">
               <a:ext uri="{FF2B5EF4-FFF2-40B4-BE49-F238E27FC236}">
-                <a16:creationId xmlns:a16="http://schemas.microsoft.com/office/drawing/2014/main" id="{84A921AE-F274-44B9-8A78-4562913B88A1}"/>
+                <a16:creationId xmlns:a16="http://schemas.microsoft.com/office/drawing/2014/main" id="{816A718E-C507-4116-A599-1D812FAB6929}"/>
               </a:ext>
             </a:extLst>
           </p:cNvPr>
@@ -3290,7 +3290,7 @@
           <p:cNvPr id="6" name="step-0">
             <a:extLst xmlns:a="http://schemas.openxmlformats.org/drawingml/2006/main">
               <a:ext uri="{FF2B5EF4-FFF2-40B4-BE49-F238E27FC236}">
-                <a16:creationId xmlns:a16="http://schemas.microsoft.com/office/drawing/2014/main" id="{91199349-81CC-4FE6-A0E9-C6D3EF1E6FF0}"/>
+                <a16:creationId xmlns:a16="http://schemas.microsoft.com/office/drawing/2014/main" id="{B46EB517-0D06-4894-90CC-394F2AA56E2C}"/>
               </a:ext>
             </a:extLst>
           </p:cNvPr>
@@ -3347,7 +3347,7 @@
           <p:cNvPr id="7" name="state-name-0">
             <a:extLst xmlns:a="http://schemas.openxmlformats.org/drawingml/2006/main">
               <a:ext uri="{FF2B5EF4-FFF2-40B4-BE49-F238E27FC236}">
-                <a16:creationId xmlns:a16="http://schemas.microsoft.com/office/drawing/2014/main" id="{52650A3B-2BE6-4B81-94B2-B0E6D82BA828}"/>
+                <a16:creationId xmlns:a16="http://schemas.microsoft.com/office/drawing/2014/main" id="{4B4B213A-3EB4-450E-813A-1DCAD795A8AD}"/>
               </a:ext>
             </a:extLst>
           </p:cNvPr>
@@ -3404,7 +3404,7 @@
           <p:cNvPr id="8" name="state-detail-0">
             <a:extLst xmlns:a="http://schemas.openxmlformats.org/drawingml/2006/main">
               <a:ext uri="{FF2B5EF4-FFF2-40B4-BE49-F238E27FC236}">
-                <a16:creationId xmlns:a16="http://schemas.microsoft.com/office/drawing/2014/main" id="{3E751D93-A278-48C0-A173-B48116216890}"/>
+                <a16:creationId xmlns:a16="http://schemas.microsoft.com/office/drawing/2014/main" id="{927C4C9E-53B0-4140-9133-AB6EC9797446}"/>
               </a:ext>
             </a:extLst>
           </p:cNvPr>
@@ -3461,7 +3461,7 @@
           <p:cNvPr id="9" name="state-1">
             <a:extLst xmlns:a="http://schemas.openxmlformats.org/drawingml/2006/main">
               <a:ext uri="{FF2B5EF4-FFF2-40B4-BE49-F238E27FC236}">
-                <a16:creationId xmlns:a16="http://schemas.microsoft.com/office/drawing/2014/main" id="{3791A4DD-2693-4987-A5F2-A8DB91110074}"/>
+                <a16:creationId xmlns:a16="http://schemas.microsoft.com/office/drawing/2014/main" id="{F3A45DCC-9665-4B15-BDAA-A36E493D07E3}"/>
               </a:ext>
             </a:extLst>
           </p:cNvPr>
@@ -3492,7 +3492,7 @@
           <p:cNvPr id="10" name="step-1">
             <a:extLst xmlns:a="http://schemas.openxmlformats.org/drawingml/2006/main">
               <a:ext uri="{FF2B5EF4-FFF2-40B4-BE49-F238E27FC236}">
-                <a16:creationId xmlns:a16="http://schemas.microsoft.com/office/drawing/2014/main" id="{3B393E1A-D6EE-4ED2-A266-38411BBF3471}"/>
+                <a16:creationId xmlns:a16="http://schemas.microsoft.com/office/drawing/2014/main" id="{F9C5869C-6554-4ACB-BEEE-640019F82E2F}"/>
               </a:ext>
             </a:extLst>
           </p:cNvPr>
@@ -3549,7 +3549,7 @@
           <p:cNvPr id="11" name="state-name-1">
             <a:extLst xmlns:a="http://schemas.openxmlformats.org/drawingml/2006/main">
               <a:ext uri="{FF2B5EF4-FFF2-40B4-BE49-F238E27FC236}">
-                <a16:creationId xmlns:a16="http://schemas.microsoft.com/office/drawing/2014/main" id="{752AF645-498D-48F7-B9AC-7820FADAF7E3}"/>
+                <a16:creationId xmlns:a16="http://schemas.microsoft.com/office/drawing/2014/main" id="{66948A08-0A6A-4942-9F49-27C06A1FCE93}"/>
               </a:ext>
             </a:extLst>
           </p:cNvPr>
@@ -3606,7 +3606,7 @@
           <p:cNvPr id="12" name="state-detail-1">
             <a:extLst xmlns:a="http://schemas.openxmlformats.org/drawingml/2006/main">
               <a:ext uri="{FF2B5EF4-FFF2-40B4-BE49-F238E27FC236}">
-                <a16:creationId xmlns:a16="http://schemas.microsoft.com/office/drawing/2014/main" id="{E0F415A7-16FB-42A7-B5A8-B84B672049D3}"/>
+                <a16:creationId xmlns:a16="http://schemas.microsoft.com/office/drawing/2014/main" id="{8E4CCF34-8D6D-4E36-A524-97A4C6429FFD}"/>
               </a:ext>
             </a:extLst>
           </p:cNvPr>
@@ -3663,7 +3663,7 @@
           <p:cNvPr id="13" name="state-2">
             <a:extLst xmlns:a="http://schemas.openxmlformats.org/drawingml/2006/main">
               <a:ext uri="{FF2B5EF4-FFF2-40B4-BE49-F238E27FC236}">
-                <a16:creationId xmlns:a16="http://schemas.microsoft.com/office/drawing/2014/main" id="{A780ADD3-CA25-459A-BCE2-757E87892C6A}"/>
+                <a16:creationId xmlns:a16="http://schemas.microsoft.com/office/drawing/2014/main" id="{80FA862D-AC03-47B2-A165-B6A4A151E33E}"/>
               </a:ext>
             </a:extLst>
           </p:cNvPr>
@@ -3694,7 +3694,7 @@
           <p:cNvPr id="14" name="step-2">
             <a:extLst xmlns:a="http://schemas.openxmlformats.org/drawingml/2006/main">
               <a:ext uri="{FF2B5EF4-FFF2-40B4-BE49-F238E27FC236}">
-                <a16:creationId xmlns:a16="http://schemas.microsoft.com/office/drawing/2014/main" id="{E3984472-E5B9-4262-8024-40751A65591F}"/>
+                <a16:creationId xmlns:a16="http://schemas.microsoft.com/office/drawing/2014/main" id="{AFE93F2B-4CEC-4BA8-90D8-FCF77B7887CA}"/>
               </a:ext>
             </a:extLst>
           </p:cNvPr>
@@ -3751,7 +3751,7 @@
           <p:cNvPr id="15" name="state-name-2">
             <a:extLst xmlns:a="http://schemas.openxmlformats.org/drawingml/2006/main">
               <a:ext uri="{FF2B5EF4-FFF2-40B4-BE49-F238E27FC236}">
-                <a16:creationId xmlns:a16="http://schemas.microsoft.com/office/drawing/2014/main" id="{4FE92C40-EBC8-474E-885F-9D96BB308182}"/>
+                <a16:creationId xmlns:a16="http://schemas.microsoft.com/office/drawing/2014/main" id="{41E5FA5C-9146-4607-9DBB-4FC622B09EE1}"/>
               </a:ext>
             </a:extLst>
           </p:cNvPr>
@@ -3808,7 +3808,7 @@
           <p:cNvPr id="16" name="state-detail-2">
             <a:extLst xmlns:a="http://schemas.openxmlformats.org/drawingml/2006/main">
               <a:ext uri="{FF2B5EF4-FFF2-40B4-BE49-F238E27FC236}">
-                <a16:creationId xmlns:a16="http://schemas.microsoft.com/office/drawing/2014/main" id="{DB87F43C-BC58-4C3F-9ACF-24B52B5039C9}"/>
+                <a16:creationId xmlns:a16="http://schemas.microsoft.com/office/drawing/2014/main" id="{4BC6F15B-FBE2-4F33-B75F-D60DCAAC7336}"/>
               </a:ext>
             </a:extLst>
           </p:cNvPr>
@@ -3865,7 +3865,7 @@
           <p:cNvPr id="17" name="state-3">
             <a:extLst xmlns:a="http://schemas.openxmlformats.org/drawingml/2006/main">
               <a:ext uri="{FF2B5EF4-FFF2-40B4-BE49-F238E27FC236}">
-                <a16:creationId xmlns:a16="http://schemas.microsoft.com/office/drawing/2014/main" id="{D656AADC-9C59-4E61-BBEE-64258ADCF8D7}"/>
+                <a16:creationId xmlns:a16="http://schemas.microsoft.com/office/drawing/2014/main" id="{43905AE7-4787-4EAE-B593-9C5A25685813}"/>
               </a:ext>
             </a:extLst>
           </p:cNvPr>
@@ -3898,7 +3898,7 @@
           <p:cNvPr id="18" name="step-3">
             <a:extLst xmlns:a="http://schemas.openxmlformats.org/drawingml/2006/main">
               <a:ext uri="{FF2B5EF4-FFF2-40B4-BE49-F238E27FC236}">
-                <a16:creationId xmlns:a16="http://schemas.microsoft.com/office/drawing/2014/main" id="{DAA0709E-66EB-4022-8DB4-842055091C17}"/>
+                <a16:creationId xmlns:a16="http://schemas.microsoft.com/office/drawing/2014/main" id="{FEA35F2C-70B6-4289-85A6-83D787989E65}"/>
               </a:ext>
             </a:extLst>
           </p:cNvPr>
@@ -3955,7 +3955,7 @@
           <p:cNvPr id="19" name="state-name-3">
             <a:extLst xmlns:a="http://schemas.openxmlformats.org/drawingml/2006/main">
               <a:ext uri="{FF2B5EF4-FFF2-40B4-BE49-F238E27FC236}">
-                <a16:creationId xmlns:a16="http://schemas.microsoft.com/office/drawing/2014/main" id="{73A79843-962D-4CAC-AAB8-75A73AF834AF}"/>
+                <a16:creationId xmlns:a16="http://schemas.microsoft.com/office/drawing/2014/main" id="{FC5FEE60-18DB-47A3-ABA1-3658153C7645}"/>
               </a:ext>
             </a:extLst>
           </p:cNvPr>
@@ -4012,7 +4012,7 @@
           <p:cNvPr id="20" name="state-detail-3">
             <a:extLst xmlns:a="http://schemas.openxmlformats.org/drawingml/2006/main">
               <a:ext uri="{FF2B5EF4-FFF2-40B4-BE49-F238E27FC236}">
-                <a16:creationId xmlns:a16="http://schemas.microsoft.com/office/drawing/2014/main" id="{FED0B26B-EDDE-473E-BD75-630DDB9ADB5A}"/>
+                <a16:creationId xmlns:a16="http://schemas.microsoft.com/office/drawing/2014/main" id="{A0A34B79-CF97-4CA3-8679-695ACE27D7A3}"/>
               </a:ext>
             </a:extLst>
           </p:cNvPr>
@@ -4147,7 +4147,7 @@
           <p:cNvPr id="24" name="waiting-note">
             <a:extLst xmlns:a="http://schemas.openxmlformats.org/drawingml/2006/main">
               <a:ext uri="{FF2B5EF4-FFF2-40B4-BE49-F238E27FC236}">
-                <a16:creationId xmlns:a16="http://schemas.microsoft.com/office/drawing/2014/main" id="{60B8920E-42CD-47C0-B191-149AE0B388D6}"/>
+                <a16:creationId xmlns:a16="http://schemas.microsoft.com/office/drawing/2014/main" id="{D2E10D81-744D-4180-8C9C-93DAEA747C54}"/>
               </a:ext>
             </a:extLst>
           </p:cNvPr>
@@ -4204,7 +4204,7 @@
           <p:cNvPr id="25" name="footer">
             <a:extLst xmlns:a="http://schemas.openxmlformats.org/drawingml/2006/main">
               <a:ext uri="{FF2B5EF4-FFF2-40B4-BE49-F238E27FC236}">
-                <a16:creationId xmlns:a16="http://schemas.microsoft.com/office/drawing/2014/main" id="{39C1A399-8B2B-420A-89BC-C889D18EEC7C}"/>
+                <a16:creationId xmlns:a16="http://schemas.microsoft.com/office/drawing/2014/main" id="{36CED55B-9165-4A84-93D2-614BF7C31159}"/>
               </a:ext>
             </a:extLst>
           </p:cNvPr>
@@ -4259,7 +4259,7 @@
     </p:spTree>
     <p:extLst>
       <p:ext uri="{BB962C8B-B14F-4D97-AF65-F5344CB8AC3E}">
-        <p14:creationId xmlns:p14="http://schemas.microsoft.com/office/powerpoint/2010/main" val="1194935609"/>
+        <p14:creationId xmlns:p14="http://schemas.microsoft.com/office/powerpoint/2010/main" val="1065871771"/>
       </p:ext>
     </p:extLst>
   </p:cSld>
@@ -4290,7 +4290,7 @@
           <p:cNvPr id="26" name="wordmark">
             <a:extLst xmlns:a="http://schemas.openxmlformats.org/drawingml/2006/main">
               <a:ext uri="{FF2B5EF4-FFF2-40B4-BE49-F238E27FC236}">
-                <a16:creationId xmlns:a16="http://schemas.microsoft.com/office/drawing/2014/main" id="{914836AF-42DC-418D-BE7E-A2B6B51994E9}"/>
+                <a16:creationId xmlns:a16="http://schemas.microsoft.com/office/drawing/2014/main" id="{62C6F775-375D-4660-BD63-35F97C09F4A2}"/>
               </a:ext>
             </a:extLst>
           </p:cNvPr>
@@ -4347,7 +4347,7 @@
           <p:cNvPr id="2" name="page">
             <a:extLst xmlns:a="http://schemas.openxmlformats.org/drawingml/2006/main">
               <a:ext uri="{FF2B5EF4-FFF2-40B4-BE49-F238E27FC236}">
-                <a16:creationId xmlns:a16="http://schemas.microsoft.com/office/drawing/2014/main" id="{B79D2EBB-91D8-4D05-A4FF-4977A85BBF3E}"/>
+                <a16:creationId xmlns:a16="http://schemas.microsoft.com/office/drawing/2014/main" id="{0728E292-BD37-4BA2-980F-28A9EED90836}"/>
               </a:ext>
             </a:extLst>
           </p:cNvPr>
@@ -4404,7 +4404,7 @@
           <p:cNvPr id="3" name="title">
             <a:extLst xmlns:a="http://schemas.openxmlformats.org/drawingml/2006/main">
               <a:ext uri="{FF2B5EF4-FFF2-40B4-BE49-F238E27FC236}">
-                <a16:creationId xmlns:a16="http://schemas.microsoft.com/office/drawing/2014/main" id="{14DC9462-AED6-4DBC-95FF-B1AC4182A777}"/>
+                <a16:creationId xmlns:a16="http://schemas.microsoft.com/office/drawing/2014/main" id="{D692EF6C-D994-4E18-A8B6-73C344CFD988}"/>
               </a:ext>
             </a:extLst>
           </p:cNvPr>
@@ -4461,7 +4461,7 @@
           <p:cNvPr id="4" name="subtitle">
             <a:extLst xmlns:a="http://schemas.openxmlformats.org/drawingml/2006/main">
               <a:ext uri="{FF2B5EF4-FFF2-40B4-BE49-F238E27FC236}">
-                <a16:creationId xmlns:a16="http://schemas.microsoft.com/office/drawing/2014/main" id="{0B5A9594-AB87-4AC9-8D73-C8ACF4FEA821}"/>
+                <a16:creationId xmlns:a16="http://schemas.microsoft.com/office/drawing/2014/main" id="{72898AC1-3ED4-420C-ABEE-874D03876466}"/>
               </a:ext>
             </a:extLst>
           </p:cNvPr>
@@ -4518,7 +4518,7 @@
           <p:cNvPr id="5" name="architecture-title-0">
             <a:extLst xmlns:a="http://schemas.openxmlformats.org/drawingml/2006/main">
               <a:ext uri="{FF2B5EF4-FFF2-40B4-BE49-F238E27FC236}">
-                <a16:creationId xmlns:a16="http://schemas.microsoft.com/office/drawing/2014/main" id="{0B3A00BD-C106-4D0C-825A-2F9216B7D99F}"/>
+                <a16:creationId xmlns:a16="http://schemas.microsoft.com/office/drawing/2014/main" id="{4581D151-3957-41F9-9AD1-B43E1328A363}"/>
               </a:ext>
             </a:extLst>
           </p:cNvPr>
@@ -4575,7 +4575,7 @@
           <p:cNvPr id="6" name="architecture-node-0">
             <a:extLst xmlns:a="http://schemas.openxmlformats.org/drawingml/2006/main">
               <a:ext uri="{FF2B5EF4-FFF2-40B4-BE49-F238E27FC236}">
-                <a16:creationId xmlns:a16="http://schemas.microsoft.com/office/drawing/2014/main" id="{9711C319-A623-46D8-BC3C-0A093DBE4F5E}"/>
+                <a16:creationId xmlns:a16="http://schemas.microsoft.com/office/drawing/2014/main" id="{A422E326-790E-4603-8F76-F8B7E195B923}"/>
               </a:ext>
             </a:extLst>
           </p:cNvPr>
@@ -4608,7 +4608,7 @@
           <p:cNvPr id="7" name="architecture-a-0">
             <a:extLst xmlns:a="http://schemas.openxmlformats.org/drawingml/2006/main">
               <a:ext uri="{FF2B5EF4-FFF2-40B4-BE49-F238E27FC236}">
-                <a16:creationId xmlns:a16="http://schemas.microsoft.com/office/drawing/2014/main" id="{F3059CC1-A3FA-47E7-81BD-5083FE70B8EB}"/>
+                <a16:creationId xmlns:a16="http://schemas.microsoft.com/office/drawing/2014/main" id="{93475944-5F5C-479C-AF30-4BE9153DEC6F}"/>
               </a:ext>
             </a:extLst>
           </p:cNvPr>
@@ -4665,7 +4665,7 @@
           <p:cNvPr id="8" name="architecture-b-0">
             <a:extLst xmlns:a="http://schemas.openxmlformats.org/drawingml/2006/main">
               <a:ext uri="{FF2B5EF4-FFF2-40B4-BE49-F238E27FC236}">
-                <a16:creationId xmlns:a16="http://schemas.microsoft.com/office/drawing/2014/main" id="{6535D58A-ADEE-4973-9D94-1473732CC4DE}"/>
+                <a16:creationId xmlns:a16="http://schemas.microsoft.com/office/drawing/2014/main" id="{708EF03A-00B6-42A7-8D40-4274C14ACFAC}"/>
               </a:ext>
             </a:extLst>
           </p:cNvPr>
@@ -4745,7 +4745,7 @@
           <p:cNvPr id="9" name="architecture-title-1">
             <a:extLst xmlns:a="http://schemas.openxmlformats.org/drawingml/2006/main">
               <a:ext uri="{FF2B5EF4-FFF2-40B4-BE49-F238E27FC236}">
-                <a16:creationId xmlns:a16="http://schemas.microsoft.com/office/drawing/2014/main" id="{D945F927-9F8E-4634-915C-E7B460D733C7}"/>
+                <a16:creationId xmlns:a16="http://schemas.microsoft.com/office/drawing/2014/main" id="{38A6EAA2-0B97-4346-B59D-309A118EB3BD}"/>
               </a:ext>
             </a:extLst>
           </p:cNvPr>
@@ -4802,7 +4802,7 @@
           <p:cNvPr id="10" name="architecture-node-1">
             <a:extLst xmlns:a="http://schemas.openxmlformats.org/drawingml/2006/main">
               <a:ext uri="{FF2B5EF4-FFF2-40B4-BE49-F238E27FC236}">
-                <a16:creationId xmlns:a16="http://schemas.microsoft.com/office/drawing/2014/main" id="{24EA1207-F738-4F79-ACC3-2B3A0DD6B37F}"/>
+                <a16:creationId xmlns:a16="http://schemas.microsoft.com/office/drawing/2014/main" id="{AA39FC4F-EBD2-49C3-B487-5F4D8CAA3D95}"/>
               </a:ext>
             </a:extLst>
           </p:cNvPr>
@@ -4835,7 +4835,7 @@
           <p:cNvPr id="11" name="architecture-a-1">
             <a:extLst xmlns:a="http://schemas.openxmlformats.org/drawingml/2006/main">
               <a:ext uri="{FF2B5EF4-FFF2-40B4-BE49-F238E27FC236}">
-                <a16:creationId xmlns:a16="http://schemas.microsoft.com/office/drawing/2014/main" id="{BEDE7C6A-1755-4EF9-8D09-3D39E90D5430}"/>
+                <a16:creationId xmlns:a16="http://schemas.microsoft.com/office/drawing/2014/main" id="{C5C04BDD-3BC9-48E8-8239-4FE725406571}"/>
               </a:ext>
             </a:extLst>
           </p:cNvPr>
@@ -4892,7 +4892,7 @@
           <p:cNvPr id="12" name="architecture-b-1">
             <a:extLst xmlns:a="http://schemas.openxmlformats.org/drawingml/2006/main">
               <a:ext uri="{FF2B5EF4-FFF2-40B4-BE49-F238E27FC236}">
-                <a16:creationId xmlns:a16="http://schemas.microsoft.com/office/drawing/2014/main" id="{638B64DC-1392-49EA-8E62-609EF1400338}"/>
+                <a16:creationId xmlns:a16="http://schemas.microsoft.com/office/drawing/2014/main" id="{A530C99E-E750-4694-9DDC-283D947A7908}"/>
               </a:ext>
             </a:extLst>
           </p:cNvPr>
@@ -4972,7 +4972,7 @@
           <p:cNvPr id="13" name="architecture-title-2">
             <a:extLst xmlns:a="http://schemas.openxmlformats.org/drawingml/2006/main">
               <a:ext uri="{FF2B5EF4-FFF2-40B4-BE49-F238E27FC236}">
-                <a16:creationId xmlns:a16="http://schemas.microsoft.com/office/drawing/2014/main" id="{9D244C21-6A38-4548-B54B-CC819C122658}"/>
+                <a16:creationId xmlns:a16="http://schemas.microsoft.com/office/drawing/2014/main" id="{DD9D6AC8-C0B0-4858-8308-54A08B81B6EB}"/>
               </a:ext>
             </a:extLst>
           </p:cNvPr>
@@ -5029,7 +5029,7 @@
           <p:cNvPr id="14" name="architecture-node-2">
             <a:extLst xmlns:a="http://schemas.openxmlformats.org/drawingml/2006/main">
               <a:ext uri="{FF2B5EF4-FFF2-40B4-BE49-F238E27FC236}">
-                <a16:creationId xmlns:a16="http://schemas.microsoft.com/office/drawing/2014/main" id="{70F76BA8-A837-41D6-80F3-4D4D4DDF5E90}"/>
+                <a16:creationId xmlns:a16="http://schemas.microsoft.com/office/drawing/2014/main" id="{74320CD1-E363-4118-8137-46B6CD1AF695}"/>
               </a:ext>
             </a:extLst>
           </p:cNvPr>
@@ -5062,7 +5062,7 @@
           <p:cNvPr id="15" name="architecture-a-2">
             <a:extLst xmlns:a="http://schemas.openxmlformats.org/drawingml/2006/main">
               <a:ext uri="{FF2B5EF4-FFF2-40B4-BE49-F238E27FC236}">
-                <a16:creationId xmlns:a16="http://schemas.microsoft.com/office/drawing/2014/main" id="{2D70EBDA-6A34-44EC-A78C-C88A3DDA0177}"/>
+                <a16:creationId xmlns:a16="http://schemas.microsoft.com/office/drawing/2014/main" id="{1187760E-3988-4A98-B6D1-368E7A5525E2}"/>
               </a:ext>
             </a:extLst>
           </p:cNvPr>
@@ -5119,7 +5119,7 @@
           <p:cNvPr id="16" name="architecture-b-2">
             <a:extLst xmlns:a="http://schemas.openxmlformats.org/drawingml/2006/main">
               <a:ext uri="{FF2B5EF4-FFF2-40B4-BE49-F238E27FC236}">
-                <a16:creationId xmlns:a16="http://schemas.microsoft.com/office/drawing/2014/main" id="{F96F3A6C-AE92-4698-B26B-FABFA2743A06}"/>
+                <a16:creationId xmlns:a16="http://schemas.microsoft.com/office/drawing/2014/main" id="{79F7AFD7-FC12-414E-8044-DBAEC2AAAED7}"/>
               </a:ext>
             </a:extLst>
           </p:cNvPr>
@@ -5176,7 +5176,7 @@
           <p:cNvPr id="17" name="architecture-title-3">
             <a:extLst xmlns:a="http://schemas.openxmlformats.org/drawingml/2006/main">
               <a:ext uri="{FF2B5EF4-FFF2-40B4-BE49-F238E27FC236}">
-                <a16:creationId xmlns:a16="http://schemas.microsoft.com/office/drawing/2014/main" id="{A2782682-E251-4B57-A751-232AC3AC9EE3}"/>
+                <a16:creationId xmlns:a16="http://schemas.microsoft.com/office/drawing/2014/main" id="{D5769CE7-A0F6-46B6-9D01-316377CF4ACE}"/>
               </a:ext>
             </a:extLst>
           </p:cNvPr>
@@ -5233,7 +5233,7 @@
           <p:cNvPr id="18" name="architecture-node-3">
             <a:extLst xmlns:a="http://schemas.openxmlformats.org/drawingml/2006/main">
               <a:ext uri="{FF2B5EF4-FFF2-40B4-BE49-F238E27FC236}">
-                <a16:creationId xmlns:a16="http://schemas.microsoft.com/office/drawing/2014/main" id="{6BF1B58E-A555-4C09-97AF-762D9947C7C6}"/>
+                <a16:creationId xmlns:a16="http://schemas.microsoft.com/office/drawing/2014/main" id="{30E1F278-0131-43CD-82AE-A440F0ABDE81}"/>
               </a:ext>
             </a:extLst>
           </p:cNvPr>
@@ -5266,7 +5266,7 @@
           <p:cNvPr id="19" name="architecture-a-3">
             <a:extLst xmlns:a="http://schemas.openxmlformats.org/drawingml/2006/main">
               <a:ext uri="{FF2B5EF4-FFF2-40B4-BE49-F238E27FC236}">
-                <a16:creationId xmlns:a16="http://schemas.microsoft.com/office/drawing/2014/main" id="{FCEA89C7-4260-42D1-BB8F-57A0A8AAC175}"/>
+                <a16:creationId xmlns:a16="http://schemas.microsoft.com/office/drawing/2014/main" id="{8E917A25-CCAB-41AC-B2FB-8F3C25CAD984}"/>
               </a:ext>
             </a:extLst>
           </p:cNvPr>
@@ -5323,7 +5323,7 @@
           <p:cNvPr id="20" name="architecture-b-3">
             <a:extLst xmlns:a="http://schemas.openxmlformats.org/drawingml/2006/main">
               <a:ext uri="{FF2B5EF4-FFF2-40B4-BE49-F238E27FC236}">
-                <a16:creationId xmlns:a16="http://schemas.microsoft.com/office/drawing/2014/main" id="{F3F2B60B-D139-4310-A2B1-E4F8671C75A8}"/>
+                <a16:creationId xmlns:a16="http://schemas.microsoft.com/office/drawing/2014/main" id="{CC474B23-6C77-4F61-99DA-D303A2AAD70A}"/>
               </a:ext>
             </a:extLst>
           </p:cNvPr>
@@ -5481,7 +5481,7 @@
           <p:cNvPr id="24" name="auth-note">
             <a:extLst xmlns:a="http://schemas.openxmlformats.org/drawingml/2006/main">
               <a:ext uri="{FF2B5EF4-FFF2-40B4-BE49-F238E27FC236}">
-                <a16:creationId xmlns:a16="http://schemas.microsoft.com/office/drawing/2014/main" id="{EE30D7A9-EAF9-4261-846F-09415F4173B1}"/>
+                <a16:creationId xmlns:a16="http://schemas.microsoft.com/office/drawing/2014/main" id="{44388997-D07B-4F62-BD21-3206DEB25462}"/>
               </a:ext>
             </a:extLst>
           </p:cNvPr>
@@ -5538,7 +5538,7 @@
           <p:cNvPr id="25" name="footer">
             <a:extLst xmlns:a="http://schemas.openxmlformats.org/drawingml/2006/main">
               <a:ext uri="{FF2B5EF4-FFF2-40B4-BE49-F238E27FC236}">
-                <a16:creationId xmlns:a16="http://schemas.microsoft.com/office/drawing/2014/main" id="{0156AB9C-01A0-4F83-B72E-58AE91C3A148}"/>
+                <a16:creationId xmlns:a16="http://schemas.microsoft.com/office/drawing/2014/main" id="{06FF2BF9-502C-4261-BD05-62C22A5212B9}"/>
               </a:ext>
             </a:extLst>
           </p:cNvPr>
@@ -5593,7 +5593,7 @@
     </p:spTree>
     <p:extLst>
       <p:ext uri="{BB962C8B-B14F-4D97-AF65-F5344CB8AC3E}">
-        <p14:creationId xmlns:p14="http://schemas.microsoft.com/office/powerpoint/2010/main" val="1932256314"/>
+        <p14:creationId xmlns:p14="http://schemas.microsoft.com/office/powerpoint/2010/main" val="2135621738"/>
       </p:ext>
     </p:extLst>
   </p:cSld>
@@ -5624,7 +5624,7 @@
           <p:cNvPr id="8" name="wordmark">
             <a:extLst xmlns:a="http://schemas.openxmlformats.org/drawingml/2006/main">
               <a:ext uri="{FF2B5EF4-FFF2-40B4-BE49-F238E27FC236}">
-                <a16:creationId xmlns:a16="http://schemas.microsoft.com/office/drawing/2014/main" id="{DAE0E7DD-E164-43CB-9357-411E777A4FB8}"/>
+                <a16:creationId xmlns:a16="http://schemas.microsoft.com/office/drawing/2014/main" id="{419B2061-DDDF-499A-88AE-C530ACAA1887}"/>
               </a:ext>
             </a:extLst>
           </p:cNvPr>
@@ -5681,7 +5681,7 @@
           <p:cNvPr id="2" name="page">
             <a:extLst xmlns:a="http://schemas.openxmlformats.org/drawingml/2006/main">
               <a:ext uri="{FF2B5EF4-FFF2-40B4-BE49-F238E27FC236}">
-                <a16:creationId xmlns:a16="http://schemas.microsoft.com/office/drawing/2014/main" id="{A2DDCB96-1245-481E-914D-112793F427E1}"/>
+                <a16:creationId xmlns:a16="http://schemas.microsoft.com/office/drawing/2014/main" id="{FC70C586-DC99-472C-BAD4-552500A3A88D}"/>
               </a:ext>
             </a:extLst>
           </p:cNvPr>
@@ -5738,7 +5738,7 @@
           <p:cNvPr id="3" name="title">
             <a:extLst xmlns:a="http://schemas.openxmlformats.org/drawingml/2006/main">
               <a:ext uri="{FF2B5EF4-FFF2-40B4-BE49-F238E27FC236}">
-                <a16:creationId xmlns:a16="http://schemas.microsoft.com/office/drawing/2014/main" id="{95CE1D1D-1673-42F0-A0E7-39DE9757819D}"/>
+                <a16:creationId xmlns:a16="http://schemas.microsoft.com/office/drawing/2014/main" id="{5C9D62A8-2398-4197-B40B-A2858B2AE545}"/>
               </a:ext>
             </a:extLst>
           </p:cNvPr>
@@ -5795,7 +5795,7 @@
           <p:cNvPr id="4" name="subtitle">
             <a:extLst xmlns:a="http://schemas.openxmlformats.org/drawingml/2006/main">
               <a:ext uri="{FF2B5EF4-FFF2-40B4-BE49-F238E27FC236}">
-                <a16:creationId xmlns:a16="http://schemas.microsoft.com/office/drawing/2014/main" id="{04006EA3-4110-4E28-8D20-4A80BF215CBE}"/>
+                <a16:creationId xmlns:a16="http://schemas.microsoft.com/office/drawing/2014/main" id="{7B282E5C-9B62-4BA0-8383-DA06FCB9465A}"/>
               </a:ext>
             </a:extLst>
           </p:cNvPr>
@@ -6090,7 +6090,7 @@
           <p:cNvPr id="6" name="our-focus">
             <a:extLst xmlns:a="http://schemas.openxmlformats.org/drawingml/2006/main">
               <a:ext uri="{FF2B5EF4-FFF2-40B4-BE49-F238E27FC236}">
-                <a16:creationId xmlns:a16="http://schemas.microsoft.com/office/drawing/2014/main" id="{B0020E50-42E7-4DA8-8559-72DC6E345B20}"/>
+                <a16:creationId xmlns:a16="http://schemas.microsoft.com/office/drawing/2014/main" id="{8F371A41-BE9C-4396-A156-627372264D50}"/>
               </a:ext>
             </a:extLst>
           </p:cNvPr>
@@ -6147,7 +6147,7 @@
           <p:cNvPr id="7" name="footer">
             <a:extLst xmlns:a="http://schemas.openxmlformats.org/drawingml/2006/main">
               <a:ext uri="{FF2B5EF4-FFF2-40B4-BE49-F238E27FC236}">
-                <a16:creationId xmlns:a16="http://schemas.microsoft.com/office/drawing/2014/main" id="{AD7743F1-DE9A-4AFA-9CC7-8CBB1BA1A760}"/>
+                <a16:creationId xmlns:a16="http://schemas.microsoft.com/office/drawing/2014/main" id="{79CAEAC6-8C93-4503-B18D-AAE1AAD3FBA9}"/>
               </a:ext>
             </a:extLst>
           </p:cNvPr>
@@ -6202,7 +6202,7 @@
     </p:spTree>
     <p:extLst>
       <p:ext uri="{BB962C8B-B14F-4D97-AF65-F5344CB8AC3E}">
-        <p14:creationId xmlns:p14="http://schemas.microsoft.com/office/powerpoint/2010/main" val="741513263"/>
+        <p14:creationId xmlns:p14="http://schemas.microsoft.com/office/powerpoint/2010/main" val="1826992471"/>
       </p:ext>
     </p:extLst>
   </p:cSld>
@@ -6233,7 +6233,7 @@
           <p:cNvPr id="12" name="wordmark">
             <a:extLst xmlns:a="http://schemas.openxmlformats.org/drawingml/2006/main">
               <a:ext uri="{FF2B5EF4-FFF2-40B4-BE49-F238E27FC236}">
-                <a16:creationId xmlns:a16="http://schemas.microsoft.com/office/drawing/2014/main" id="{74485722-329B-4584-9E01-5D552645193A}"/>
+                <a16:creationId xmlns:a16="http://schemas.microsoft.com/office/drawing/2014/main" id="{78261158-90CB-41A5-93CB-24AB731AF9E7}"/>
               </a:ext>
             </a:extLst>
           </p:cNvPr>
@@ -6290,7 +6290,7 @@
           <p:cNvPr id="2" name="page">
             <a:extLst xmlns:a="http://schemas.openxmlformats.org/drawingml/2006/main">
               <a:ext uri="{FF2B5EF4-FFF2-40B4-BE49-F238E27FC236}">
-                <a16:creationId xmlns:a16="http://schemas.microsoft.com/office/drawing/2014/main" id="{7C1E8FA0-091C-46B2-ABB4-F622F0DDAA5B}"/>
+                <a16:creationId xmlns:a16="http://schemas.microsoft.com/office/drawing/2014/main" id="{4D763EF5-8C94-471C-A6BF-707F16AD9BCB}"/>
               </a:ext>
             </a:extLst>
           </p:cNvPr>
@@ -6347,7 +6347,7 @@
           <p:cNvPr id="3" name="title">
             <a:extLst xmlns:a="http://schemas.openxmlformats.org/drawingml/2006/main">
               <a:ext uri="{FF2B5EF4-FFF2-40B4-BE49-F238E27FC236}">
-                <a16:creationId xmlns:a16="http://schemas.microsoft.com/office/drawing/2014/main" id="{D2884050-1F96-4F37-91FD-ACD142D723CA}"/>
+                <a16:creationId xmlns:a16="http://schemas.microsoft.com/office/drawing/2014/main" id="{985A3D73-E840-40FC-80FB-23D521458CD9}"/>
               </a:ext>
             </a:extLst>
           </p:cNvPr>
@@ -6404,7 +6404,7 @@
           <p:cNvPr id="4" name="subtitle">
             <a:extLst xmlns:a="http://schemas.openxmlformats.org/drawingml/2006/main">
               <a:ext uri="{FF2B5EF4-FFF2-40B4-BE49-F238E27FC236}">
-                <a16:creationId xmlns:a16="http://schemas.microsoft.com/office/drawing/2014/main" id="{FD2C7446-BF9D-4546-9E25-BBC982041F86}"/>
+                <a16:creationId xmlns:a16="http://schemas.microsoft.com/office/drawing/2014/main" id="{B6AF1B28-325A-4855-9F56-C4D7E778909D}"/>
               </a:ext>
             </a:extLst>
           </p:cNvPr>
@@ -6461,7 +6461,7 @@
           <p:cNvPr id="5" name="price">
             <a:extLst xmlns:a="http://schemas.openxmlformats.org/drawingml/2006/main">
               <a:ext uri="{FF2B5EF4-FFF2-40B4-BE49-F238E27FC236}">
-                <a16:creationId xmlns:a16="http://schemas.microsoft.com/office/drawing/2014/main" id="{B933C5DF-905E-42D7-8AB6-85E947B9B255}"/>
+                <a16:creationId xmlns:a16="http://schemas.microsoft.com/office/drawing/2014/main" id="{49D3DE58-0A6E-415A-A29A-330505B4128F}"/>
               </a:ext>
             </a:extLst>
           </p:cNvPr>
@@ -6518,7 +6518,7 @@
           <p:cNvPr id="6" name="price-unit">
             <a:extLst xmlns:a="http://schemas.openxmlformats.org/drawingml/2006/main">
               <a:ext uri="{FF2B5EF4-FFF2-40B4-BE49-F238E27FC236}">
-                <a16:creationId xmlns:a16="http://schemas.microsoft.com/office/drawing/2014/main" id="{743828C0-959F-457B-A041-E4CFA918CEB6}"/>
+                <a16:creationId xmlns:a16="http://schemas.microsoft.com/office/drawing/2014/main" id="{A164BD4F-914A-48AA-AB04-1A30A486DDF8}"/>
               </a:ext>
             </a:extLst>
           </p:cNvPr>
@@ -6575,7 +6575,7 @@
           <p:cNvPr id="7" name="hypothesis-label">
             <a:extLst xmlns:a="http://schemas.openxmlformats.org/drawingml/2006/main">
               <a:ext uri="{FF2B5EF4-FFF2-40B4-BE49-F238E27FC236}">
-                <a16:creationId xmlns:a16="http://schemas.microsoft.com/office/drawing/2014/main" id="{94B8DA1A-1781-496A-965E-C46A9B1A835A}"/>
+                <a16:creationId xmlns:a16="http://schemas.microsoft.com/office/drawing/2014/main" id="{AD0E5656-DB59-4CCB-BCFE-136EEE7E986E}"/>
               </a:ext>
             </a:extLst>
           </p:cNvPr>
@@ -6632,7 +6632,7 @@
           <p:cNvPr id="8" name="business-benefit">
             <a:extLst xmlns:a="http://schemas.openxmlformats.org/drawingml/2006/main">
               <a:ext uri="{FF2B5EF4-FFF2-40B4-BE49-F238E27FC236}">
-                <a16:creationId xmlns:a16="http://schemas.microsoft.com/office/drawing/2014/main" id="{FEAED676-7AB3-4F88-96B8-5AD829FB86D7}"/>
+                <a16:creationId xmlns:a16="http://schemas.microsoft.com/office/drawing/2014/main" id="{E90FCBA7-9A00-4584-856F-23801A224B73}"/>
               </a:ext>
             </a:extLst>
           </p:cNvPr>
@@ -6689,7 +6689,7 @@
           <p:cNvPr id="9" name="business-rationale">
             <a:extLst xmlns:a="http://schemas.openxmlformats.org/drawingml/2006/main">
               <a:ext uri="{FF2B5EF4-FFF2-40B4-BE49-F238E27FC236}">
-                <a16:creationId xmlns:a16="http://schemas.microsoft.com/office/drawing/2014/main" id="{55377299-A177-4E68-9668-387393275D6E}"/>
+                <a16:creationId xmlns:a16="http://schemas.microsoft.com/office/drawing/2014/main" id="{32E99BD5-A746-495D-AE7B-25347C68E72D}"/>
               </a:ext>
             </a:extLst>
           </p:cNvPr>
@@ -6769,7 +6769,7 @@
           <p:cNvPr id="10" name="cost-discipline">
             <a:extLst xmlns:a="http://schemas.openxmlformats.org/drawingml/2006/main">
               <a:ext uri="{FF2B5EF4-FFF2-40B4-BE49-F238E27FC236}">
-                <a16:creationId xmlns:a16="http://schemas.microsoft.com/office/drawing/2014/main" id="{0983AEFA-8F02-4C2C-8009-0C3FE7C003DB}"/>
+                <a16:creationId xmlns:a16="http://schemas.microsoft.com/office/drawing/2014/main" id="{580C4378-522A-43B5-B348-223955F06C81}"/>
               </a:ext>
             </a:extLst>
           </p:cNvPr>
@@ -6849,7 +6849,7 @@
           <p:cNvPr id="11" name="footer">
             <a:extLst xmlns:a="http://schemas.openxmlformats.org/drawingml/2006/main">
               <a:ext uri="{FF2B5EF4-FFF2-40B4-BE49-F238E27FC236}">
-                <a16:creationId xmlns:a16="http://schemas.microsoft.com/office/drawing/2014/main" id="{BEB3A08F-71C1-4927-B53B-56F5B42D6BA0}"/>
+                <a16:creationId xmlns:a16="http://schemas.microsoft.com/office/drawing/2014/main" id="{6FB1B272-41B9-4942-817D-1A587E877C74}"/>
               </a:ext>
             </a:extLst>
           </p:cNvPr>
@@ -6904,7 +6904,7 @@
     </p:spTree>
     <p:extLst>
       <p:ext uri="{BB962C8B-B14F-4D97-AF65-F5344CB8AC3E}">
-        <p14:creationId xmlns:p14="http://schemas.microsoft.com/office/powerpoint/2010/main" val="331654297"/>
+        <p14:creationId xmlns:p14="http://schemas.microsoft.com/office/powerpoint/2010/main" val="1738913255"/>
       </p:ext>
     </p:extLst>
   </p:cSld>
@@ -6935,7 +6935,7 @@
           <p:cNvPr id="13" name="wordmark">
             <a:extLst xmlns:a="http://schemas.openxmlformats.org/drawingml/2006/main">
               <a:ext uri="{FF2B5EF4-FFF2-40B4-BE49-F238E27FC236}">
-                <a16:creationId xmlns:a16="http://schemas.microsoft.com/office/drawing/2014/main" id="{1427301E-2357-4F83-8A30-A6EBDFFCF883}"/>
+                <a16:creationId xmlns:a16="http://schemas.microsoft.com/office/drawing/2014/main" id="{70E4902A-31F2-45F7-AB34-57D50A60C6AC}"/>
               </a:ext>
             </a:extLst>
           </p:cNvPr>
@@ -6992,7 +6992,7 @@
           <p:cNvPr id="2" name="page">
             <a:extLst xmlns:a="http://schemas.openxmlformats.org/drawingml/2006/main">
               <a:ext uri="{FF2B5EF4-FFF2-40B4-BE49-F238E27FC236}">
-                <a16:creationId xmlns:a16="http://schemas.microsoft.com/office/drawing/2014/main" id="{046F0C09-F7BA-4AC5-9EF0-9C5BF0F552D1}"/>
+                <a16:creationId xmlns:a16="http://schemas.microsoft.com/office/drawing/2014/main" id="{A2D6FDFC-F4C5-42BD-A08C-C87FB803CDB3}"/>
               </a:ext>
             </a:extLst>
           </p:cNvPr>
@@ -7049,7 +7049,7 @@
           <p:cNvPr id="3" name="title">
             <a:extLst xmlns:a="http://schemas.openxmlformats.org/drawingml/2006/main">
               <a:ext uri="{FF2B5EF4-FFF2-40B4-BE49-F238E27FC236}">
-                <a16:creationId xmlns:a16="http://schemas.microsoft.com/office/drawing/2014/main" id="{BC15F27E-87C9-473E-A1B2-899DFC196433}"/>
+                <a16:creationId xmlns:a16="http://schemas.microsoft.com/office/drawing/2014/main" id="{2297366E-2094-4D2B-B47E-6ABB579BB13C}"/>
               </a:ext>
             </a:extLst>
           </p:cNvPr>
@@ -7106,7 +7106,7 @@
           <p:cNvPr id="4" name="subtitle">
             <a:extLst xmlns:a="http://schemas.openxmlformats.org/drawingml/2006/main">
               <a:ext uri="{FF2B5EF4-FFF2-40B4-BE49-F238E27FC236}">
-                <a16:creationId xmlns:a16="http://schemas.microsoft.com/office/drawing/2014/main" id="{06BE5BAC-3DB3-44C1-9E1F-859812CECF98}"/>
+                <a16:creationId xmlns:a16="http://schemas.microsoft.com/office/drawing/2014/main" id="{3BFBE165-26D4-4213-9C07-97BB0B9A049B}"/>
               </a:ext>
             </a:extLst>
           </p:cNvPr>
@@ -7163,7 +7163,7 @@
           <p:cNvPr id="5" name="interviews-number">
             <a:extLst xmlns:a="http://schemas.openxmlformats.org/drawingml/2006/main">
               <a:ext uri="{FF2B5EF4-FFF2-40B4-BE49-F238E27FC236}">
-                <a16:creationId xmlns:a16="http://schemas.microsoft.com/office/drawing/2014/main" id="{D7EABEA1-3812-4831-B2EF-B8238184F23A}"/>
+                <a16:creationId xmlns:a16="http://schemas.microsoft.com/office/drawing/2014/main" id="{3652DA2B-2710-438E-91E3-01A39823AF4A}"/>
               </a:ext>
             </a:extLst>
           </p:cNvPr>
@@ -7220,7 +7220,7 @@
           <p:cNvPr id="6" name="interviews-label">
             <a:extLst xmlns:a="http://schemas.openxmlformats.org/drawingml/2006/main">
               <a:ext uri="{FF2B5EF4-FFF2-40B4-BE49-F238E27FC236}">
-                <a16:creationId xmlns:a16="http://schemas.microsoft.com/office/drawing/2014/main" id="{FCAD7575-2527-41B5-9052-05E0FEFAD23E}"/>
+                <a16:creationId xmlns:a16="http://schemas.microsoft.com/office/drawing/2014/main" id="{055780AA-2808-4128-80D0-EA3AA285D44A}"/>
               </a:ext>
             </a:extLst>
           </p:cNvPr>
@@ -7277,7 +7277,7 @@
           <p:cNvPr id="7" name="interviews-detail">
             <a:extLst xmlns:a="http://schemas.openxmlformats.org/drawingml/2006/main">
               <a:ext uri="{FF2B5EF4-FFF2-40B4-BE49-F238E27FC236}">
-                <a16:creationId xmlns:a16="http://schemas.microsoft.com/office/drawing/2014/main" id="{B5EE8C6B-BDEE-453A-87A4-79BE25A18DC2}"/>
+                <a16:creationId xmlns:a16="http://schemas.microsoft.com/office/drawing/2014/main" id="{2C71AB35-D261-4B62-8E45-0E1955710C1B}"/>
               </a:ext>
             </a:extLst>
           </p:cNvPr>
@@ -7357,7 +7357,7 @@
           <p:cNvPr id="8" name="pilot-number">
             <a:extLst xmlns:a="http://schemas.openxmlformats.org/drawingml/2006/main">
               <a:ext uri="{FF2B5EF4-FFF2-40B4-BE49-F238E27FC236}">
-                <a16:creationId xmlns:a16="http://schemas.microsoft.com/office/drawing/2014/main" id="{084184CE-1D63-49AC-B616-41380C45BCC3}"/>
+                <a16:creationId xmlns:a16="http://schemas.microsoft.com/office/drawing/2014/main" id="{B8CDBAA1-DF4C-49D0-83DF-6D300AAD115F}"/>
               </a:ext>
             </a:extLst>
           </p:cNvPr>
@@ -7414,7 +7414,7 @@
           <p:cNvPr id="9" name="pilot-label">
             <a:extLst xmlns:a="http://schemas.openxmlformats.org/drawingml/2006/main">
               <a:ext uri="{FF2B5EF4-FFF2-40B4-BE49-F238E27FC236}">
-                <a16:creationId xmlns:a16="http://schemas.microsoft.com/office/drawing/2014/main" id="{BA326149-F0AE-418C-9D31-12FCD380A321}"/>
+                <a16:creationId xmlns:a16="http://schemas.microsoft.com/office/drawing/2014/main" id="{4B4BB3C6-AA36-43B5-B13A-7513569462B3}"/>
               </a:ext>
             </a:extLst>
           </p:cNvPr>
@@ -7471,7 +7471,7 @@
           <p:cNvPr id="10" name="pilot-detail">
             <a:extLst xmlns:a="http://schemas.openxmlformats.org/drawingml/2006/main">
               <a:ext uri="{FF2B5EF4-FFF2-40B4-BE49-F238E27FC236}">
-                <a16:creationId xmlns:a16="http://schemas.microsoft.com/office/drawing/2014/main" id="{87006EC6-59EB-4C16-9F4A-533B1FBAF976}"/>
+                <a16:creationId xmlns:a16="http://schemas.microsoft.com/office/drawing/2014/main" id="{85F94838-3A9A-4FC6-9586-5D7280BD13CB}"/>
               </a:ext>
             </a:extLst>
           </p:cNvPr>
@@ -7551,7 +7551,7 @@
           <p:cNvPr id="11" name="metric">
             <a:extLst xmlns:a="http://schemas.openxmlformats.org/drawingml/2006/main">
               <a:ext uri="{FF2B5EF4-FFF2-40B4-BE49-F238E27FC236}">
-                <a16:creationId xmlns:a16="http://schemas.microsoft.com/office/drawing/2014/main" id="{1C78275F-C5BD-48D1-996A-7314EE7708C1}"/>
+                <a16:creationId xmlns:a16="http://schemas.microsoft.com/office/drawing/2014/main" id="{932867EA-95A2-4E61-B974-63440F5AF1C9}"/>
               </a:ext>
             </a:extLst>
           </p:cNvPr>
@@ -7608,7 +7608,7 @@
           <p:cNvPr id="12" name="footer">
             <a:extLst xmlns:a="http://schemas.openxmlformats.org/drawingml/2006/main">
               <a:ext uri="{FF2B5EF4-FFF2-40B4-BE49-F238E27FC236}">
-                <a16:creationId xmlns:a16="http://schemas.microsoft.com/office/drawing/2014/main" id="{7EB327A0-D7AA-4A3A-8CE4-D3C0EFEE14DF}"/>
+                <a16:creationId xmlns:a16="http://schemas.microsoft.com/office/drawing/2014/main" id="{676C6466-CB3A-4649-A64F-1A3BE7FD9757}"/>
               </a:ext>
             </a:extLst>
           </p:cNvPr>
@@ -7663,7 +7663,7 @@
     </p:spTree>
     <p:extLst>
       <p:ext uri="{BB962C8B-B14F-4D97-AF65-F5344CB8AC3E}">
-        <p14:creationId xmlns:p14="http://schemas.microsoft.com/office/powerpoint/2010/main" val="118617713"/>
+        <p14:creationId xmlns:p14="http://schemas.microsoft.com/office/powerpoint/2010/main" val="128901145"/>
       </p:ext>
     </p:extLst>
   </p:cSld>
@@ -7694,7 +7694,7 @@
           <p:cNvPr id="14" name="wordmark">
             <a:extLst xmlns:a="http://schemas.openxmlformats.org/drawingml/2006/main">
               <a:ext uri="{FF2B5EF4-FFF2-40B4-BE49-F238E27FC236}">
-                <a16:creationId xmlns:a16="http://schemas.microsoft.com/office/drawing/2014/main" id="{CEF6DEB6-C996-4258-84A5-5FDBC79CE73F}"/>
+                <a16:creationId xmlns:a16="http://schemas.microsoft.com/office/drawing/2014/main" id="{48E7B85F-2969-48D9-AF63-BCA71A6FECC8}"/>
               </a:ext>
             </a:extLst>
           </p:cNvPr>
@@ -7751,7 +7751,7 @@
           <p:cNvPr id="2" name="page">
             <a:extLst xmlns:a="http://schemas.openxmlformats.org/drawingml/2006/main">
               <a:ext uri="{FF2B5EF4-FFF2-40B4-BE49-F238E27FC236}">
-                <a16:creationId xmlns:a16="http://schemas.microsoft.com/office/drawing/2014/main" id="{E61E2BFB-FABE-46CC-961A-D6BE9AF45322}"/>
+                <a16:creationId xmlns:a16="http://schemas.microsoft.com/office/drawing/2014/main" id="{FC8CAA48-6502-421D-914B-CD7546B8F05E}"/>
               </a:ext>
             </a:extLst>
           </p:cNvPr>
@@ -7808,7 +7808,7 @@
           <p:cNvPr id="3" name="title">
             <a:extLst xmlns:a="http://schemas.openxmlformats.org/drawingml/2006/main">
               <a:ext uri="{FF2B5EF4-FFF2-40B4-BE49-F238E27FC236}">
-                <a16:creationId xmlns:a16="http://schemas.microsoft.com/office/drawing/2014/main" id="{1A1791CE-5DC5-46A7-8445-092DF7B85359}"/>
+                <a16:creationId xmlns:a16="http://schemas.microsoft.com/office/drawing/2014/main" id="{8BF6615B-45F0-40EA-BDEE-BE7BE355099E}"/>
               </a:ext>
             </a:extLst>
           </p:cNvPr>
@@ -7865,7 +7865,7 @@
           <p:cNvPr id="4" name="subtitle">
             <a:extLst xmlns:a="http://schemas.openxmlformats.org/drawingml/2006/main">
               <a:ext uri="{FF2B5EF4-FFF2-40B4-BE49-F238E27FC236}">
-                <a16:creationId xmlns:a16="http://schemas.microsoft.com/office/drawing/2014/main" id="{01C6D246-AFB2-4A3F-8725-C106A695B37D}"/>
+                <a16:creationId xmlns:a16="http://schemas.microsoft.com/office/drawing/2014/main" id="{BFB49722-BE9A-4FD3-95EA-76CB6F3A0F15}"/>
               </a:ext>
             </a:extLst>
           </p:cNvPr>
@@ -7922,7 +7922,7 @@
           <p:cNvPr id="5" name="next-label">
             <a:extLst xmlns:a="http://schemas.openxmlformats.org/drawingml/2006/main">
               <a:ext uri="{FF2B5EF4-FFF2-40B4-BE49-F238E27FC236}">
-                <a16:creationId xmlns:a16="http://schemas.microsoft.com/office/drawing/2014/main" id="{EFECE817-D188-4BCE-AC2D-C5FEB2A4770B}"/>
+                <a16:creationId xmlns:a16="http://schemas.microsoft.com/office/drawing/2014/main" id="{C320F70D-C64B-47D2-8360-C785BF54904D}"/>
               </a:ext>
             </a:extLst>
           </p:cNvPr>
@@ -7979,7 +7979,7 @@
           <p:cNvPr id="6" name="next-one">
             <a:extLst xmlns:a="http://schemas.openxmlformats.org/drawingml/2006/main">
               <a:ext uri="{FF2B5EF4-FFF2-40B4-BE49-F238E27FC236}">
-                <a16:creationId xmlns:a16="http://schemas.microsoft.com/office/drawing/2014/main" id="{8CB1D90D-7106-44AF-8B2F-632D84A59521}"/>
+                <a16:creationId xmlns:a16="http://schemas.microsoft.com/office/drawing/2014/main" id="{22B5DCEB-A65E-4720-8821-1A78E58C32DD}"/>
               </a:ext>
             </a:extLst>
           </p:cNvPr>
@@ -8026,7 +8026,7 @@
                 <a:ea typeface="Noto Sans"/>
                 <a:cs typeface="Noto Sans"/>
               </a:rPr>
-              <a:t>Record the public demo video</a:t>
+              <a:t>Publish the captioned demo video</a:t>
             </a:r>
           </a:p>
         </p:txBody>
@@ -8036,7 +8036,7 @@
           <p:cNvPr id="7" name="next-two">
             <a:extLst xmlns:a="http://schemas.openxmlformats.org/drawingml/2006/main">
               <a:ext uri="{FF2B5EF4-FFF2-40B4-BE49-F238E27FC236}">
-                <a16:creationId xmlns:a16="http://schemas.microsoft.com/office/drawing/2014/main" id="{AD206DB7-090C-43F4-A355-235F569266DF}"/>
+                <a16:creationId xmlns:a16="http://schemas.microsoft.com/office/drawing/2014/main" id="{40F06627-BD4A-46F6-BA45-7352FAA2772B}"/>
               </a:ext>
             </a:extLst>
           </p:cNvPr>
@@ -8093,7 +8093,7 @@
           <p:cNvPr id="8" name="next-three">
             <a:extLst xmlns:a="http://schemas.openxmlformats.org/drawingml/2006/main">
               <a:ext uri="{FF2B5EF4-FFF2-40B4-BE49-F238E27FC236}">
-                <a16:creationId xmlns:a16="http://schemas.microsoft.com/office/drawing/2014/main" id="{BAAC475F-5B05-4479-A1A8-3BAF5A3ED8CA}"/>
+                <a16:creationId xmlns:a16="http://schemas.microsoft.com/office/drawing/2014/main" id="{57B67199-21F3-452C-B219-69FF847B5CEC}"/>
               </a:ext>
             </a:extLst>
           </p:cNvPr>
@@ -8150,7 +8150,7 @@
           <p:cNvPr id="9" name="contribution-label">
             <a:extLst xmlns:a="http://schemas.openxmlformats.org/drawingml/2006/main">
               <a:ext uri="{FF2B5EF4-FFF2-40B4-BE49-F238E27FC236}">
-                <a16:creationId xmlns:a16="http://schemas.microsoft.com/office/drawing/2014/main" id="{6D2D4774-505F-40E7-A799-6C653C3BF972}"/>
+                <a16:creationId xmlns:a16="http://schemas.microsoft.com/office/drawing/2014/main" id="{6B2FBC6C-42F2-421E-B0F5-FD4F4AB3B078}"/>
               </a:ext>
             </a:extLst>
           </p:cNvPr>
@@ -8207,7 +8207,7 @@
           <p:cNvPr id="10" name="contribution-name">
             <a:extLst xmlns:a="http://schemas.openxmlformats.org/drawingml/2006/main">
               <a:ext uri="{FF2B5EF4-FFF2-40B4-BE49-F238E27FC236}">
-                <a16:creationId xmlns:a16="http://schemas.microsoft.com/office/drawing/2014/main" id="{08B716DA-9F60-492A-8178-92FAE1CB9B7A}"/>
+                <a16:creationId xmlns:a16="http://schemas.microsoft.com/office/drawing/2014/main" id="{0438820F-F387-4B99-A296-139CCB3C81AC}"/>
               </a:ext>
             </a:extLst>
           </p:cNvPr>
@@ -8253,7 +8253,7 @@
                 <a:latin typeface="Noto Sans"/>
                 <a:ea typeface="Noto Sans"/>
                 <a:cs typeface="Noto Sans"/>
-                <a:hlinkClick xmlns:r="http://schemas.openxmlformats.org/officeDocument/2006/relationships" r:id="Rd3031e0decbf47d7"/>
+                <a:hlinkClick xmlns:r="http://schemas.openxmlformats.org/officeDocument/2006/relationships" r:id="R50bc4f3de3624a28"/>
               </a:rPr>
               <a:t>@kindhandoff/guard</a:t>
             </a:r>
@@ -8265,7 +8265,7 @@
           <p:cNvPr id="11" name="contribution-role">
             <a:extLst xmlns:a="http://schemas.openxmlformats.org/drawingml/2006/main">
               <a:ext uri="{FF2B5EF4-FFF2-40B4-BE49-F238E27FC236}">
-                <a16:creationId xmlns:a16="http://schemas.microsoft.com/office/drawing/2014/main" id="{9124040F-262D-4DFE-B8A7-49A2FC0C1C92}"/>
+                <a16:creationId xmlns:a16="http://schemas.microsoft.com/office/drawing/2014/main" id="{4425D530-03B2-4F5E-8D08-B5CBD7CE00BE}"/>
               </a:ext>
             </a:extLst>
           </p:cNvPr>
@@ -8368,7 +8368,7 @@
           <p:cNvPr id="12" name="repo-link">
             <a:extLst xmlns:a="http://schemas.openxmlformats.org/drawingml/2006/main">
               <a:ext uri="{FF2B5EF4-FFF2-40B4-BE49-F238E27FC236}">
-                <a16:creationId xmlns:a16="http://schemas.microsoft.com/office/drawing/2014/main" id="{7ED4C521-6AA2-4D9A-A03B-ADF0A56316B6}"/>
+                <a16:creationId xmlns:a16="http://schemas.microsoft.com/office/drawing/2014/main" id="{8E349F2C-5653-4956-944B-F4EB79A7ED71}"/>
               </a:ext>
             </a:extLst>
           </p:cNvPr>
@@ -8414,7 +8414,7 @@
                 <a:latin typeface="Noto Sans"/>
                 <a:ea typeface="Noto Sans"/>
                 <a:cs typeface="Noto Sans"/>
-                <a:hlinkClick xmlns:r="http://schemas.openxmlformats.org/officeDocument/2006/relationships" r:id="R6a7a3806eeb5463b"/>
+                <a:hlinkClick xmlns:r="http://schemas.openxmlformats.org/officeDocument/2006/relationships" r:id="Rfba57f31fe2042e1"/>
               </a:rPr>
               <a:t>github.com/shi1720/Amazon-Developer-Hackathon</a:t>
             </a:r>
@@ -8426,7 +8426,7 @@
           <p:cNvPr id="13" name="hosted-url">
             <a:extLst xmlns:a="http://schemas.openxmlformats.org/drawingml/2006/main">
               <a:ext uri="{FF2B5EF4-FFF2-40B4-BE49-F238E27FC236}">
-                <a16:creationId xmlns:a16="http://schemas.microsoft.com/office/drawing/2014/main" id="{FEBDB23B-526E-4015-9166-8BB0E7123D18}"/>
+                <a16:creationId xmlns:a16="http://schemas.microsoft.com/office/drawing/2014/main" id="{367048E4-045D-4685-AB21-52AEF46BFC0D}"/>
               </a:ext>
             </a:extLst>
           </p:cNvPr>
@@ -8472,9 +8472,9 @@
                 <a:latin typeface="Noto Sans"/>
                 <a:ea typeface="Noto Sans"/>
                 <a:cs typeface="Noto Sans"/>
-                <a:hlinkClick xmlns:r="http://schemas.openxmlformats.org/officeDocument/2006/relationships" r:id="Re2ed6c2e287a424d"/>
-              </a:rPr>
-              <a:t>Public app — verified: kindhandoff.web.app</a:t>
+                <a:hlinkClick xmlns:r="http://schemas.openxmlformats.org/officeDocument/2006/relationships" r:id="R182ada68d73843a7"/>
+              </a:rPr>
+              <a:t>Verified public app: kindhandoff.web.app</a:t>
             </a:r>
           </a:p>
         </p:txBody>
@@ -8482,7 +8482,7 @@
     </p:spTree>
     <p:extLst>
       <p:ext uri="{BB962C8B-B14F-4D97-AF65-F5344CB8AC3E}">
-        <p14:creationId xmlns:p14="http://schemas.microsoft.com/office/powerpoint/2010/main" val="1217971384"/>
+        <p14:creationId xmlns:p14="http://schemas.microsoft.com/office/powerpoint/2010/main" val="714123412"/>
       </p:ext>
     </p:extLst>
   </p:cSld>

</xml_diff>

<commit_message>
Publish the demo and complete the Devpost submission materials
</commit_message>
<xml_diff>
--- a/docs/deliverables/KindHandoff-Pitch.pptx
+++ b/docs/deliverables/KindHandoff-Pitch.pptx
@@ -2,20 +2,20 @@
 <file path=ppt/presentation.xml><?xml version="1.0" encoding="utf-8"?>
 <p:presentation xmlns:p="http://schemas.openxmlformats.org/presentationml/2006/main">
   <p:sldMasterIdLst>
-    <p:sldMasterId xmlns:r="http://schemas.openxmlformats.org/officeDocument/2006/relationships" id="2147483648" r:id="R7d410e0f9bbd44ff"/>
+    <p:sldMasterId xmlns:r="http://schemas.openxmlformats.org/officeDocument/2006/relationships" id="2147483648" r:id="R09f1dd50ca0f499e"/>
   </p:sldMasterIdLst>
   <p:notesMasterIdLst>
-    <p:notesMasterId xmlns:r="http://schemas.openxmlformats.org/officeDocument/2006/relationships" r:id="R517ead20437d40b4"/>
+    <p:notesMasterId xmlns:r="http://schemas.openxmlformats.org/officeDocument/2006/relationships" r:id="Rd5d1116002a64289"/>
   </p:notesMasterIdLst>
   <p:sldIdLst>
-    <p:sldId xmlns:r="http://schemas.openxmlformats.org/officeDocument/2006/relationships" id="256" r:id="R05263362c85f41e7"/>
-    <p:sldId xmlns:r="http://schemas.openxmlformats.org/officeDocument/2006/relationships" id="257" r:id="R2548aeea0a434964"/>
-    <p:sldId xmlns:r="http://schemas.openxmlformats.org/officeDocument/2006/relationships" id="258" r:id="R2353fb4cdcc04077"/>
-    <p:sldId xmlns:r="http://schemas.openxmlformats.org/officeDocument/2006/relationships" id="259" r:id="Re0b979eebbfb4925"/>
-    <p:sldId xmlns:r="http://schemas.openxmlformats.org/officeDocument/2006/relationships" id="260" r:id="Rff8ed195a44c40f6"/>
-    <p:sldId xmlns:r="http://schemas.openxmlformats.org/officeDocument/2006/relationships" id="261" r:id="R4c0a9b8e3c404de1"/>
-    <p:sldId xmlns:r="http://schemas.openxmlformats.org/officeDocument/2006/relationships" id="262" r:id="R8f2c88f4d7584429"/>
-    <p:sldId xmlns:r="http://schemas.openxmlformats.org/officeDocument/2006/relationships" id="263" r:id="Rd9f822ba051b4ec1"/>
+    <p:sldId xmlns:r="http://schemas.openxmlformats.org/officeDocument/2006/relationships" id="256" r:id="Re681d2b403b3464a"/>
+    <p:sldId xmlns:r="http://schemas.openxmlformats.org/officeDocument/2006/relationships" id="257" r:id="Rc07d67d5fef74b40"/>
+    <p:sldId xmlns:r="http://schemas.openxmlformats.org/officeDocument/2006/relationships" id="258" r:id="Rcd77fb081b1a401d"/>
+    <p:sldId xmlns:r="http://schemas.openxmlformats.org/officeDocument/2006/relationships" id="259" r:id="R485d0b7a69f1432d"/>
+    <p:sldId xmlns:r="http://schemas.openxmlformats.org/officeDocument/2006/relationships" id="260" r:id="Ra079b6859af24470"/>
+    <p:sldId xmlns:r="http://schemas.openxmlformats.org/officeDocument/2006/relationships" id="261" r:id="Rec16b7d7e41240fc"/>
+    <p:sldId xmlns:r="http://schemas.openxmlformats.org/officeDocument/2006/relationships" id="262" r:id="R96abf2e542b047b3"/>
+    <p:sldId xmlns:r="http://schemas.openxmlformats.org/officeDocument/2006/relationships" id="263" r:id="R105afa8d48a04e91"/>
   </p:sldIdLst>
   <p:sldSz cx="12192000" cy="6858000"/>
   <p:notesSz cx="6858000" cy="9144000"/>
@@ -939,7 +939,7 @@
           <a:lstStyle xmlns:a="http://schemas.openxmlformats.org/drawingml/2006/main"/>
           <a:p xmlns:a="http://schemas.openxmlformats.org/drawingml/2006/main">
             <a:r>
-              <a:t>Creator: Shivam Gupta. Public MIT main repository: https://github.com/shi1720/Amazon-Developer-Hackathon. Firebase application: https://kindhandoff.web.app. Public workflow verification is documented in the repository evidence. No public video URL has been claimed. The additional Open Source contribution is @kindhandoff/guard, public and MIT licensed: https://github.com/shi1720/kindhandoff-guard. Contribution: https://github.com/shi1720/kindhandoff-guard/commit/04a15ea016e552e3c031b9ec371af2df6a1de105. The library covers state transitions, coverage accounting, and candidate ranking. App code owns dependency readiness, exact identity authorization, and content-version acknowledgments. Next steps include publishing the English captioned video under three minutes, household research, and live Alexa+ onboarding where access permits.</a:t>
+              <a:t>Creator: Shivam Gupta. Public MIT main repository: https://github.com/shi1720/Amazon-Developer-Hackathon. Firebase application: https://kindhandoff.web.app. Public workflow verification is documented in the repository evidence. Public English captioned demo: https://youtu.be/t7e00FzIk2M . Signed-out playback and the public transcript were verified by the implementation lead. The additional Open Source contribution is @kindhandoff/guard, public and MIT licensed: https://github.com/shi1720/kindhandoff-guard. Contribution: https://github.com/shi1720/kindhandoff-guard/commit/04a15ea016e552e3c031b9ec371af2df6a1de105. The library covers state transitions, coverage accounting, and candidate ranking. App code owns dependency readiness, exact identity authorization, and content-version acknowledgments. Next steps include household research and live Alexa+ onboarding where access permits. The Devpost project remains a draft, not submitted.</a:t>
             </a:r>
           </a:p>
         </p:txBody>
@@ -1007,7 +1007,7 @@
   </p:cSld>
   <p:clrMap bg1="lt1" tx1="dk1" bg2="lt2" tx2="dk2" accent1="accent1" accent2="accent2" accent3="accent3" accent4="accent4" accent5="accent5" accent6="accent6" hlink="hlink" folHlink="folHlink"/>
   <p:sldLayoutIdLst>
-    <p:sldLayoutId xmlns:r="http://schemas.openxmlformats.org/officeDocument/2006/relationships" id="2147483649" r:id="R354d02a6e3214ab2"/>
+    <p:sldLayoutId xmlns:r="http://schemas.openxmlformats.org/officeDocument/2006/relationships" id="2147483649" r:id="R5c04550d38be42ae"/>
   </p:sldLayoutIdLst>
   <p:txStyles>
     <p:titleStyle>
@@ -1558,7 +1558,7 @@
           <p:cNvPr id="15" name="wordmark">
             <a:extLst xmlns:a="http://schemas.openxmlformats.org/drawingml/2006/main">
               <a:ext uri="{FF2B5EF4-FFF2-40B4-BE49-F238E27FC236}">
-                <a16:creationId xmlns:a16="http://schemas.microsoft.com/office/drawing/2014/main" id="{51D8E2DF-E99E-4C3B-8F1C-2E571F61EB8E}"/>
+                <a16:creationId xmlns:a16="http://schemas.microsoft.com/office/drawing/2014/main" id="{6C1214D0-EF66-4263-8647-E827702EE382}"/>
               </a:ext>
             </a:extLst>
           </p:cNvPr>
@@ -1615,7 +1615,7 @@
           <p:cNvPr id="2" name="page">
             <a:extLst xmlns:a="http://schemas.openxmlformats.org/drawingml/2006/main">
               <a:ext uri="{FF2B5EF4-FFF2-40B4-BE49-F238E27FC236}">
-                <a16:creationId xmlns:a16="http://schemas.microsoft.com/office/drawing/2014/main" id="{9A46450F-7318-4259-AF80-A482121D189C}"/>
+                <a16:creationId xmlns:a16="http://schemas.microsoft.com/office/drawing/2014/main" id="{42170147-A523-4DEA-A9C7-5D6DEC2201AC}"/>
               </a:ext>
             </a:extLst>
           </p:cNvPr>
@@ -1672,7 +1672,7 @@
           <p:cNvPr id="3" name="cover-title">
             <a:extLst xmlns:a="http://schemas.openxmlformats.org/drawingml/2006/main">
               <a:ext uri="{FF2B5EF4-FFF2-40B4-BE49-F238E27FC236}">
-                <a16:creationId xmlns:a16="http://schemas.microsoft.com/office/drawing/2014/main" id="{92D1E6ED-3D97-421D-A620-B71268092B4F}"/>
+                <a16:creationId xmlns:a16="http://schemas.microsoft.com/office/drawing/2014/main" id="{4E253170-0644-47C3-9EB5-0E6A85AB387C}"/>
               </a:ext>
             </a:extLst>
           </p:cNvPr>
@@ -1752,7 +1752,7 @@
           <p:cNvPr id="4" name="cover-problem">
             <a:extLst xmlns:a="http://schemas.openxmlformats.org/drawingml/2006/main">
               <a:ext uri="{FF2B5EF4-FFF2-40B4-BE49-F238E27FC236}">
-                <a16:creationId xmlns:a16="http://schemas.microsoft.com/office/drawing/2014/main" id="{7073BBE0-5E9C-4D90-B685-D41F4160AB6A}"/>
+                <a16:creationId xmlns:a16="http://schemas.microsoft.com/office/drawing/2014/main" id="{984B8A4E-F56E-4356-AEF2-71E545268518}"/>
               </a:ext>
             </a:extLst>
           </p:cNvPr>
@@ -1832,7 +1832,7 @@
           <p:cNvPr id="5" name="creator">
             <a:extLst xmlns:a="http://schemas.openxmlformats.org/drawingml/2006/main">
               <a:ext uri="{FF2B5EF4-FFF2-40B4-BE49-F238E27FC236}">
-                <a16:creationId xmlns:a16="http://schemas.microsoft.com/office/drawing/2014/main" id="{DAD85AF9-1620-480A-B1DF-237786C45BD2}"/>
+                <a16:creationId xmlns:a16="http://schemas.microsoft.com/office/drawing/2014/main" id="{2EC0DA58-2196-4E56-9465-ED35D8259E64}"/>
               </a:ext>
             </a:extLst>
           </p:cNvPr>
@@ -1889,7 +1889,7 @@
           <p:cNvPr id="6" name="bag-node">
             <a:extLst xmlns:a="http://schemas.openxmlformats.org/drawingml/2006/main">
               <a:ext uri="{FF2B5EF4-FFF2-40B4-BE49-F238E27FC236}">
-                <a16:creationId xmlns:a16="http://schemas.microsoft.com/office/drawing/2014/main" id="{C64D75C5-3EE7-4C70-A5FE-CD09D9A81198}"/>
+                <a16:creationId xmlns:a16="http://schemas.microsoft.com/office/drawing/2014/main" id="{B2E66E14-39A6-4B80-9F15-A84C4FBF6AF4}"/>
               </a:ext>
             </a:extLst>
           </p:cNvPr>
@@ -1920,7 +1920,7 @@
           <p:cNvPr id="7" name="bag-time">
             <a:extLst xmlns:a="http://schemas.openxmlformats.org/drawingml/2006/main">
               <a:ext uri="{FF2B5EF4-FFF2-40B4-BE49-F238E27FC236}">
-                <a16:creationId xmlns:a16="http://schemas.microsoft.com/office/drawing/2014/main" id="{E88BA149-394F-46B9-96D9-64BE863A53D6}"/>
+                <a16:creationId xmlns:a16="http://schemas.microsoft.com/office/drawing/2014/main" id="{DC98B147-4135-40F5-8B8F-57F7C4F0BD50}"/>
               </a:ext>
             </a:extLst>
           </p:cNvPr>
@@ -1977,7 +1977,7 @@
           <p:cNvPr id="8" name="bag-task">
             <a:extLst xmlns:a="http://schemas.openxmlformats.org/drawingml/2006/main">
               <a:ext uri="{FF2B5EF4-FFF2-40B4-BE49-F238E27FC236}">
-                <a16:creationId xmlns:a16="http://schemas.microsoft.com/office/drawing/2014/main" id="{12836814-D379-4CF1-8964-CB10CBE3562D}"/>
+                <a16:creationId xmlns:a16="http://schemas.microsoft.com/office/drawing/2014/main" id="{C14DA6AF-D6CD-414C-B85C-47225F357413}"/>
               </a:ext>
             </a:extLst>
           </p:cNvPr>
@@ -2034,7 +2034,7 @@
           <p:cNvPr id="9" name="ride-node">
             <a:extLst xmlns:a="http://schemas.openxmlformats.org/drawingml/2006/main">
               <a:ext uri="{FF2B5EF4-FFF2-40B4-BE49-F238E27FC236}">
-                <a16:creationId xmlns:a16="http://schemas.microsoft.com/office/drawing/2014/main" id="{1C20C8D9-7AD3-4489-82DA-345C937F9E48}"/>
+                <a16:creationId xmlns:a16="http://schemas.microsoft.com/office/drawing/2014/main" id="{46BFDB56-AC48-4759-A5C4-071750FB6AB3}"/>
               </a:ext>
             </a:extLst>
           </p:cNvPr>
@@ -2065,7 +2065,7 @@
           <p:cNvPr id="10" name="ride-time">
             <a:extLst xmlns:a="http://schemas.openxmlformats.org/drawingml/2006/main">
               <a:ext uri="{FF2B5EF4-FFF2-40B4-BE49-F238E27FC236}">
-                <a16:creationId xmlns:a16="http://schemas.microsoft.com/office/drawing/2014/main" id="{EA1385BF-546F-4A12-B8A6-2CEB9D87B135}"/>
+                <a16:creationId xmlns:a16="http://schemas.microsoft.com/office/drawing/2014/main" id="{AF9C4B6E-EC44-4BC1-BB00-48A4D59E4F7A}"/>
               </a:ext>
             </a:extLst>
           </p:cNvPr>
@@ -2122,7 +2122,7 @@
           <p:cNvPr id="11" name="ride-task">
             <a:extLst xmlns:a="http://schemas.openxmlformats.org/drawingml/2006/main">
               <a:ext uri="{FF2B5EF4-FFF2-40B4-BE49-F238E27FC236}">
-                <a16:creationId xmlns:a16="http://schemas.microsoft.com/office/drawing/2014/main" id="{F3948D38-1134-4CC3-BCC6-85E9E335BE4E}"/>
+                <a16:creationId xmlns:a16="http://schemas.microsoft.com/office/drawing/2014/main" id="{E737B459-0ED4-467F-8728-A343F870EF07}"/>
               </a:ext>
             </a:extLst>
           </p:cNvPr>
@@ -2205,7 +2205,7 @@
           <p:cNvPr id="13" name="prerequisite-label">
             <a:extLst xmlns:a="http://schemas.openxmlformats.org/drawingml/2006/main">
               <a:ext uri="{FF2B5EF4-FFF2-40B4-BE49-F238E27FC236}">
-                <a16:creationId xmlns:a16="http://schemas.microsoft.com/office/drawing/2014/main" id="{53F3BAB4-A049-4C27-88B3-8F728B302758}"/>
+                <a16:creationId xmlns:a16="http://schemas.microsoft.com/office/drawing/2014/main" id="{E0296D0A-69A3-4B17-9839-6E4E31937ADC}"/>
               </a:ext>
             </a:extLst>
           </p:cNvPr>
@@ -2262,7 +2262,7 @@
           <p:cNvPr id="14" name="footer">
             <a:extLst xmlns:a="http://schemas.openxmlformats.org/drawingml/2006/main">
               <a:ext uri="{FF2B5EF4-FFF2-40B4-BE49-F238E27FC236}">
-                <a16:creationId xmlns:a16="http://schemas.microsoft.com/office/drawing/2014/main" id="{9C733982-8038-4C19-9CD5-178DA0639203}"/>
+                <a16:creationId xmlns:a16="http://schemas.microsoft.com/office/drawing/2014/main" id="{EE439423-B127-4B8A-8270-C8C9EAB18AB9}"/>
               </a:ext>
             </a:extLst>
           </p:cNvPr>
@@ -2317,7 +2317,7 @@
     </p:spTree>
     <p:extLst>
       <p:ext uri="{BB962C8B-B14F-4D97-AF65-F5344CB8AC3E}">
-        <p14:creationId xmlns:p14="http://schemas.microsoft.com/office/powerpoint/2010/main" val="117720750"/>
+        <p14:creationId xmlns:p14="http://schemas.microsoft.com/office/powerpoint/2010/main" val="2035614859"/>
       </p:ext>
     </p:extLst>
   </p:cSld>
@@ -2348,7 +2348,7 @@
           <p:cNvPr id="7" name="wordmark">
             <a:extLst xmlns:a="http://schemas.openxmlformats.org/drawingml/2006/main">
               <a:ext uri="{FF2B5EF4-FFF2-40B4-BE49-F238E27FC236}">
-                <a16:creationId xmlns:a16="http://schemas.microsoft.com/office/drawing/2014/main" id="{8B378D68-D653-45A4-8280-E2FA8CB1BAD4}"/>
+                <a16:creationId xmlns:a16="http://schemas.microsoft.com/office/drawing/2014/main" id="{AD7B69FB-3856-498E-8D8E-C7C576B0AA60}"/>
               </a:ext>
             </a:extLst>
           </p:cNvPr>
@@ -2405,7 +2405,7 @@
           <p:cNvPr id="2" name="page">
             <a:extLst xmlns:a="http://schemas.openxmlformats.org/drawingml/2006/main">
               <a:ext uri="{FF2B5EF4-FFF2-40B4-BE49-F238E27FC236}">
-                <a16:creationId xmlns:a16="http://schemas.microsoft.com/office/drawing/2014/main" id="{6FF166E4-6E2D-4709-A8DC-1935372D428F}"/>
+                <a16:creationId xmlns:a16="http://schemas.microsoft.com/office/drawing/2014/main" id="{83634013-51FA-4910-883F-3C82374573CA}"/>
               </a:ext>
             </a:extLst>
           </p:cNvPr>
@@ -2462,7 +2462,7 @@
           <p:cNvPr id="3" name="title">
             <a:extLst xmlns:a="http://schemas.openxmlformats.org/drawingml/2006/main">
               <a:ext uri="{FF2B5EF4-FFF2-40B4-BE49-F238E27FC236}">
-                <a16:creationId xmlns:a16="http://schemas.microsoft.com/office/drawing/2014/main" id="{A30FE265-9361-4E18-8B96-3D7A2912950F}"/>
+                <a16:creationId xmlns:a16="http://schemas.microsoft.com/office/drawing/2014/main" id="{B566CCDF-B344-4102-ADAE-6EA357E5B063}"/>
               </a:ext>
             </a:extLst>
           </p:cNvPr>
@@ -2519,7 +2519,7 @@
           <p:cNvPr id="4" name="subtitle">
             <a:extLst xmlns:a="http://schemas.openxmlformats.org/drawingml/2006/main">
               <a:ext uri="{FF2B5EF4-FFF2-40B4-BE49-F238E27FC236}">
-                <a16:creationId xmlns:a16="http://schemas.microsoft.com/office/drawing/2014/main" id="{C21E17C0-7FE2-4D2C-83E3-4C71462CDB57}"/>
+                <a16:creationId xmlns:a16="http://schemas.microsoft.com/office/drawing/2014/main" id="{531C0528-69A2-477E-8B2C-198C809EF14C}"/>
               </a:ext>
             </a:extLst>
           </p:cNvPr>
@@ -2945,7 +2945,7 @@
           <p:cNvPr id="6" name="footer">
             <a:extLst xmlns:a="http://schemas.openxmlformats.org/drawingml/2006/main">
               <a:ext uri="{FF2B5EF4-FFF2-40B4-BE49-F238E27FC236}">
-                <a16:creationId xmlns:a16="http://schemas.microsoft.com/office/drawing/2014/main" id="{CFD1BEC8-2612-47DC-A514-35CE0DC5E5CF}"/>
+                <a16:creationId xmlns:a16="http://schemas.microsoft.com/office/drawing/2014/main" id="{FD14DE01-5D6E-4BA8-96EE-E4A89EEC55A2}"/>
               </a:ext>
             </a:extLst>
           </p:cNvPr>
@@ -3000,7 +3000,7 @@
     </p:spTree>
     <p:extLst>
       <p:ext uri="{BB962C8B-B14F-4D97-AF65-F5344CB8AC3E}">
-        <p14:creationId xmlns:p14="http://schemas.microsoft.com/office/powerpoint/2010/main" val="1970819257"/>
+        <p14:creationId xmlns:p14="http://schemas.microsoft.com/office/powerpoint/2010/main" val="725860867"/>
       </p:ext>
     </p:extLst>
   </p:cSld>
@@ -3031,7 +3031,7 @@
           <p:cNvPr id="26" name="wordmark">
             <a:extLst xmlns:a="http://schemas.openxmlformats.org/drawingml/2006/main">
               <a:ext uri="{FF2B5EF4-FFF2-40B4-BE49-F238E27FC236}">
-                <a16:creationId xmlns:a16="http://schemas.microsoft.com/office/drawing/2014/main" id="{01890F5B-8FB9-4EED-9BB1-C427504E1E53}"/>
+                <a16:creationId xmlns:a16="http://schemas.microsoft.com/office/drawing/2014/main" id="{84DDAD64-8F57-4A02-BCD5-98ABAA40DDC6}"/>
               </a:ext>
             </a:extLst>
           </p:cNvPr>
@@ -3088,7 +3088,7 @@
           <p:cNvPr id="2" name="page">
             <a:extLst xmlns:a="http://schemas.openxmlformats.org/drawingml/2006/main">
               <a:ext uri="{FF2B5EF4-FFF2-40B4-BE49-F238E27FC236}">
-                <a16:creationId xmlns:a16="http://schemas.microsoft.com/office/drawing/2014/main" id="{B67B566E-71AE-4B4B-B5A5-0665FC980DD3}"/>
+                <a16:creationId xmlns:a16="http://schemas.microsoft.com/office/drawing/2014/main" id="{91DD01B2-F775-46A5-9635-B2EB33FDA006}"/>
               </a:ext>
             </a:extLst>
           </p:cNvPr>
@@ -3145,7 +3145,7 @@
           <p:cNvPr id="3" name="title">
             <a:extLst xmlns:a="http://schemas.openxmlformats.org/drawingml/2006/main">
               <a:ext uri="{FF2B5EF4-FFF2-40B4-BE49-F238E27FC236}">
-                <a16:creationId xmlns:a16="http://schemas.microsoft.com/office/drawing/2014/main" id="{82E5C0F2-19BE-4D91-A6FE-36305A219E1D}"/>
+                <a16:creationId xmlns:a16="http://schemas.microsoft.com/office/drawing/2014/main" id="{7A68739A-F21C-4294-B705-76D5B58F7AB6}"/>
               </a:ext>
             </a:extLst>
           </p:cNvPr>
@@ -3202,7 +3202,7 @@
           <p:cNvPr id="4" name="subtitle">
             <a:extLst xmlns:a="http://schemas.openxmlformats.org/drawingml/2006/main">
               <a:ext uri="{FF2B5EF4-FFF2-40B4-BE49-F238E27FC236}">
-                <a16:creationId xmlns:a16="http://schemas.microsoft.com/office/drawing/2014/main" id="{8B5E1DD5-4342-4038-8290-C91D2DC7984B}"/>
+                <a16:creationId xmlns:a16="http://schemas.microsoft.com/office/drawing/2014/main" id="{AAE2165A-66FC-4EB3-B405-1919021C4BE5}"/>
               </a:ext>
             </a:extLst>
           </p:cNvPr>
@@ -3259,7 +3259,7 @@
           <p:cNvPr id="5" name="state-0">
             <a:extLst xmlns:a="http://schemas.openxmlformats.org/drawingml/2006/main">
               <a:ext uri="{FF2B5EF4-FFF2-40B4-BE49-F238E27FC236}">
-                <a16:creationId xmlns:a16="http://schemas.microsoft.com/office/drawing/2014/main" id="{816A718E-C507-4116-A599-1D812FAB6929}"/>
+                <a16:creationId xmlns:a16="http://schemas.microsoft.com/office/drawing/2014/main" id="{41007E19-F7FD-40E0-830B-5BFFA610FCE0}"/>
               </a:ext>
             </a:extLst>
           </p:cNvPr>
@@ -3290,7 +3290,7 @@
           <p:cNvPr id="6" name="step-0">
             <a:extLst xmlns:a="http://schemas.openxmlformats.org/drawingml/2006/main">
               <a:ext uri="{FF2B5EF4-FFF2-40B4-BE49-F238E27FC236}">
-                <a16:creationId xmlns:a16="http://schemas.microsoft.com/office/drawing/2014/main" id="{B46EB517-0D06-4894-90CC-394F2AA56E2C}"/>
+                <a16:creationId xmlns:a16="http://schemas.microsoft.com/office/drawing/2014/main" id="{CA57AECB-AAE4-4D9C-8220-3F9F83370DBD}"/>
               </a:ext>
             </a:extLst>
           </p:cNvPr>
@@ -3347,7 +3347,7 @@
           <p:cNvPr id="7" name="state-name-0">
             <a:extLst xmlns:a="http://schemas.openxmlformats.org/drawingml/2006/main">
               <a:ext uri="{FF2B5EF4-FFF2-40B4-BE49-F238E27FC236}">
-                <a16:creationId xmlns:a16="http://schemas.microsoft.com/office/drawing/2014/main" id="{4B4B213A-3EB4-450E-813A-1DCAD795A8AD}"/>
+                <a16:creationId xmlns:a16="http://schemas.microsoft.com/office/drawing/2014/main" id="{EB35BBB4-D740-4964-A59E-8266B10FC444}"/>
               </a:ext>
             </a:extLst>
           </p:cNvPr>
@@ -3404,7 +3404,7 @@
           <p:cNvPr id="8" name="state-detail-0">
             <a:extLst xmlns:a="http://schemas.openxmlformats.org/drawingml/2006/main">
               <a:ext uri="{FF2B5EF4-FFF2-40B4-BE49-F238E27FC236}">
-                <a16:creationId xmlns:a16="http://schemas.microsoft.com/office/drawing/2014/main" id="{927C4C9E-53B0-4140-9133-AB6EC9797446}"/>
+                <a16:creationId xmlns:a16="http://schemas.microsoft.com/office/drawing/2014/main" id="{BB62EDB4-F920-410A-8FEE-F40064D08BBC}"/>
               </a:ext>
             </a:extLst>
           </p:cNvPr>
@@ -3461,7 +3461,7 @@
           <p:cNvPr id="9" name="state-1">
             <a:extLst xmlns:a="http://schemas.openxmlformats.org/drawingml/2006/main">
               <a:ext uri="{FF2B5EF4-FFF2-40B4-BE49-F238E27FC236}">
-                <a16:creationId xmlns:a16="http://schemas.microsoft.com/office/drawing/2014/main" id="{F3A45DCC-9665-4B15-BDAA-A36E493D07E3}"/>
+                <a16:creationId xmlns:a16="http://schemas.microsoft.com/office/drawing/2014/main" id="{FEBA964A-F4CB-4618-BAA9-86BAA6AD1D97}"/>
               </a:ext>
             </a:extLst>
           </p:cNvPr>
@@ -3492,7 +3492,7 @@
           <p:cNvPr id="10" name="step-1">
             <a:extLst xmlns:a="http://schemas.openxmlformats.org/drawingml/2006/main">
               <a:ext uri="{FF2B5EF4-FFF2-40B4-BE49-F238E27FC236}">
-                <a16:creationId xmlns:a16="http://schemas.microsoft.com/office/drawing/2014/main" id="{F9C5869C-6554-4ACB-BEEE-640019F82E2F}"/>
+                <a16:creationId xmlns:a16="http://schemas.microsoft.com/office/drawing/2014/main" id="{67A162AB-D7AB-4786-AB72-A37AB735B8CF}"/>
               </a:ext>
             </a:extLst>
           </p:cNvPr>
@@ -3549,7 +3549,7 @@
           <p:cNvPr id="11" name="state-name-1">
             <a:extLst xmlns:a="http://schemas.openxmlformats.org/drawingml/2006/main">
               <a:ext uri="{FF2B5EF4-FFF2-40B4-BE49-F238E27FC236}">
-                <a16:creationId xmlns:a16="http://schemas.microsoft.com/office/drawing/2014/main" id="{66948A08-0A6A-4942-9F49-27C06A1FCE93}"/>
+                <a16:creationId xmlns:a16="http://schemas.microsoft.com/office/drawing/2014/main" id="{D1865057-9DE0-48FC-A9F6-137FBC53C94B}"/>
               </a:ext>
             </a:extLst>
           </p:cNvPr>
@@ -3606,7 +3606,7 @@
           <p:cNvPr id="12" name="state-detail-1">
             <a:extLst xmlns:a="http://schemas.openxmlformats.org/drawingml/2006/main">
               <a:ext uri="{FF2B5EF4-FFF2-40B4-BE49-F238E27FC236}">
-                <a16:creationId xmlns:a16="http://schemas.microsoft.com/office/drawing/2014/main" id="{8E4CCF34-8D6D-4E36-A524-97A4C6429FFD}"/>
+                <a16:creationId xmlns:a16="http://schemas.microsoft.com/office/drawing/2014/main" id="{AA6D69A0-575C-485D-9058-1A53933B436C}"/>
               </a:ext>
             </a:extLst>
           </p:cNvPr>
@@ -3663,7 +3663,7 @@
           <p:cNvPr id="13" name="state-2">
             <a:extLst xmlns:a="http://schemas.openxmlformats.org/drawingml/2006/main">
               <a:ext uri="{FF2B5EF4-FFF2-40B4-BE49-F238E27FC236}">
-                <a16:creationId xmlns:a16="http://schemas.microsoft.com/office/drawing/2014/main" id="{80FA862D-AC03-47B2-A165-B6A4A151E33E}"/>
+                <a16:creationId xmlns:a16="http://schemas.microsoft.com/office/drawing/2014/main" id="{87568A39-E17A-4D8A-A1FE-B9B4E13575E3}"/>
               </a:ext>
             </a:extLst>
           </p:cNvPr>
@@ -3694,7 +3694,7 @@
           <p:cNvPr id="14" name="step-2">
             <a:extLst xmlns:a="http://schemas.openxmlformats.org/drawingml/2006/main">
               <a:ext uri="{FF2B5EF4-FFF2-40B4-BE49-F238E27FC236}">
-                <a16:creationId xmlns:a16="http://schemas.microsoft.com/office/drawing/2014/main" id="{AFE93F2B-4CEC-4BA8-90D8-FCF77B7887CA}"/>
+                <a16:creationId xmlns:a16="http://schemas.microsoft.com/office/drawing/2014/main" id="{2A84BD49-97A7-4D55-B4CB-319BC3D8B4C9}"/>
               </a:ext>
             </a:extLst>
           </p:cNvPr>
@@ -3751,7 +3751,7 @@
           <p:cNvPr id="15" name="state-name-2">
             <a:extLst xmlns:a="http://schemas.openxmlformats.org/drawingml/2006/main">
               <a:ext uri="{FF2B5EF4-FFF2-40B4-BE49-F238E27FC236}">
-                <a16:creationId xmlns:a16="http://schemas.microsoft.com/office/drawing/2014/main" id="{41E5FA5C-9146-4607-9DBB-4FC622B09EE1}"/>
+                <a16:creationId xmlns:a16="http://schemas.microsoft.com/office/drawing/2014/main" id="{D2BD80B3-6779-48E5-BE07-054FF4E9621C}"/>
               </a:ext>
             </a:extLst>
           </p:cNvPr>
@@ -3808,7 +3808,7 @@
           <p:cNvPr id="16" name="state-detail-2">
             <a:extLst xmlns:a="http://schemas.openxmlformats.org/drawingml/2006/main">
               <a:ext uri="{FF2B5EF4-FFF2-40B4-BE49-F238E27FC236}">
-                <a16:creationId xmlns:a16="http://schemas.microsoft.com/office/drawing/2014/main" id="{4BC6F15B-FBE2-4F33-B75F-D60DCAAC7336}"/>
+                <a16:creationId xmlns:a16="http://schemas.microsoft.com/office/drawing/2014/main" id="{EB40F648-C097-4FA0-9513-E7305FA7ABE7}"/>
               </a:ext>
             </a:extLst>
           </p:cNvPr>
@@ -3865,7 +3865,7 @@
           <p:cNvPr id="17" name="state-3">
             <a:extLst xmlns:a="http://schemas.openxmlformats.org/drawingml/2006/main">
               <a:ext uri="{FF2B5EF4-FFF2-40B4-BE49-F238E27FC236}">
-                <a16:creationId xmlns:a16="http://schemas.microsoft.com/office/drawing/2014/main" id="{43905AE7-4787-4EAE-B593-9C5A25685813}"/>
+                <a16:creationId xmlns:a16="http://schemas.microsoft.com/office/drawing/2014/main" id="{70657936-F82F-456A-9463-62618DD79219}"/>
               </a:ext>
             </a:extLst>
           </p:cNvPr>
@@ -3898,7 +3898,7 @@
           <p:cNvPr id="18" name="step-3">
             <a:extLst xmlns:a="http://schemas.openxmlformats.org/drawingml/2006/main">
               <a:ext uri="{FF2B5EF4-FFF2-40B4-BE49-F238E27FC236}">
-                <a16:creationId xmlns:a16="http://schemas.microsoft.com/office/drawing/2014/main" id="{FEA35F2C-70B6-4289-85A6-83D787989E65}"/>
+                <a16:creationId xmlns:a16="http://schemas.microsoft.com/office/drawing/2014/main" id="{285E41A2-AC47-4324-BA26-55B802782DE4}"/>
               </a:ext>
             </a:extLst>
           </p:cNvPr>
@@ -3955,7 +3955,7 @@
           <p:cNvPr id="19" name="state-name-3">
             <a:extLst xmlns:a="http://schemas.openxmlformats.org/drawingml/2006/main">
               <a:ext uri="{FF2B5EF4-FFF2-40B4-BE49-F238E27FC236}">
-                <a16:creationId xmlns:a16="http://schemas.microsoft.com/office/drawing/2014/main" id="{FC5FEE60-18DB-47A3-ABA1-3658153C7645}"/>
+                <a16:creationId xmlns:a16="http://schemas.microsoft.com/office/drawing/2014/main" id="{2B7A2CB1-C6A1-49F1-8B57-55D85756D314}"/>
               </a:ext>
             </a:extLst>
           </p:cNvPr>
@@ -4012,7 +4012,7 @@
           <p:cNvPr id="20" name="state-detail-3">
             <a:extLst xmlns:a="http://schemas.openxmlformats.org/drawingml/2006/main">
               <a:ext uri="{FF2B5EF4-FFF2-40B4-BE49-F238E27FC236}">
-                <a16:creationId xmlns:a16="http://schemas.microsoft.com/office/drawing/2014/main" id="{A0A34B79-CF97-4CA3-8679-695ACE27D7A3}"/>
+                <a16:creationId xmlns:a16="http://schemas.microsoft.com/office/drawing/2014/main" id="{1572031C-1C6C-4281-A286-0071A324BB6F}"/>
               </a:ext>
             </a:extLst>
           </p:cNvPr>
@@ -4147,7 +4147,7 @@
           <p:cNvPr id="24" name="waiting-note">
             <a:extLst xmlns:a="http://schemas.openxmlformats.org/drawingml/2006/main">
               <a:ext uri="{FF2B5EF4-FFF2-40B4-BE49-F238E27FC236}">
-                <a16:creationId xmlns:a16="http://schemas.microsoft.com/office/drawing/2014/main" id="{D2E10D81-744D-4180-8C9C-93DAEA747C54}"/>
+                <a16:creationId xmlns:a16="http://schemas.microsoft.com/office/drawing/2014/main" id="{F9EB8600-BD21-4C8F-A3D7-D49FEA70B672}"/>
               </a:ext>
             </a:extLst>
           </p:cNvPr>
@@ -4204,7 +4204,7 @@
           <p:cNvPr id="25" name="footer">
             <a:extLst xmlns:a="http://schemas.openxmlformats.org/drawingml/2006/main">
               <a:ext uri="{FF2B5EF4-FFF2-40B4-BE49-F238E27FC236}">
-                <a16:creationId xmlns:a16="http://schemas.microsoft.com/office/drawing/2014/main" id="{36CED55B-9165-4A84-93D2-614BF7C31159}"/>
+                <a16:creationId xmlns:a16="http://schemas.microsoft.com/office/drawing/2014/main" id="{2CB99D7E-ADAC-4FCD-8D1C-482CDE90E945}"/>
               </a:ext>
             </a:extLst>
           </p:cNvPr>
@@ -4259,7 +4259,7 @@
     </p:spTree>
     <p:extLst>
       <p:ext uri="{BB962C8B-B14F-4D97-AF65-F5344CB8AC3E}">
-        <p14:creationId xmlns:p14="http://schemas.microsoft.com/office/powerpoint/2010/main" val="1065871771"/>
+        <p14:creationId xmlns:p14="http://schemas.microsoft.com/office/powerpoint/2010/main" val="2048311375"/>
       </p:ext>
     </p:extLst>
   </p:cSld>
@@ -4290,7 +4290,7 @@
           <p:cNvPr id="26" name="wordmark">
             <a:extLst xmlns:a="http://schemas.openxmlformats.org/drawingml/2006/main">
               <a:ext uri="{FF2B5EF4-FFF2-40B4-BE49-F238E27FC236}">
-                <a16:creationId xmlns:a16="http://schemas.microsoft.com/office/drawing/2014/main" id="{62C6F775-375D-4660-BD63-35F97C09F4A2}"/>
+                <a16:creationId xmlns:a16="http://schemas.microsoft.com/office/drawing/2014/main" id="{F8B238FB-5076-4342-ACC9-CD4575CC651C}"/>
               </a:ext>
             </a:extLst>
           </p:cNvPr>
@@ -4347,7 +4347,7 @@
           <p:cNvPr id="2" name="page">
             <a:extLst xmlns:a="http://schemas.openxmlformats.org/drawingml/2006/main">
               <a:ext uri="{FF2B5EF4-FFF2-40B4-BE49-F238E27FC236}">
-                <a16:creationId xmlns:a16="http://schemas.microsoft.com/office/drawing/2014/main" id="{0728E292-BD37-4BA2-980F-28A9EED90836}"/>
+                <a16:creationId xmlns:a16="http://schemas.microsoft.com/office/drawing/2014/main" id="{9D321146-3D95-45BB-A02D-03B4D213411C}"/>
               </a:ext>
             </a:extLst>
           </p:cNvPr>
@@ -4404,7 +4404,7 @@
           <p:cNvPr id="3" name="title">
             <a:extLst xmlns:a="http://schemas.openxmlformats.org/drawingml/2006/main">
               <a:ext uri="{FF2B5EF4-FFF2-40B4-BE49-F238E27FC236}">
-                <a16:creationId xmlns:a16="http://schemas.microsoft.com/office/drawing/2014/main" id="{D692EF6C-D994-4E18-A8B6-73C344CFD988}"/>
+                <a16:creationId xmlns:a16="http://schemas.microsoft.com/office/drawing/2014/main" id="{29B837B8-8B84-42E2-8166-E9220F70958B}"/>
               </a:ext>
             </a:extLst>
           </p:cNvPr>
@@ -4461,7 +4461,7 @@
           <p:cNvPr id="4" name="subtitle">
             <a:extLst xmlns:a="http://schemas.openxmlformats.org/drawingml/2006/main">
               <a:ext uri="{FF2B5EF4-FFF2-40B4-BE49-F238E27FC236}">
-                <a16:creationId xmlns:a16="http://schemas.microsoft.com/office/drawing/2014/main" id="{72898AC1-3ED4-420C-ABEE-874D03876466}"/>
+                <a16:creationId xmlns:a16="http://schemas.microsoft.com/office/drawing/2014/main" id="{6B4BCBCB-77C8-405C-8CF8-3B9E671C3C8B}"/>
               </a:ext>
             </a:extLst>
           </p:cNvPr>
@@ -4518,7 +4518,7 @@
           <p:cNvPr id="5" name="architecture-title-0">
             <a:extLst xmlns:a="http://schemas.openxmlformats.org/drawingml/2006/main">
               <a:ext uri="{FF2B5EF4-FFF2-40B4-BE49-F238E27FC236}">
-                <a16:creationId xmlns:a16="http://schemas.microsoft.com/office/drawing/2014/main" id="{4581D151-3957-41F9-9AD1-B43E1328A363}"/>
+                <a16:creationId xmlns:a16="http://schemas.microsoft.com/office/drawing/2014/main" id="{C6E9FCD8-0A87-4D22-8F58-A4DF0908B2CD}"/>
               </a:ext>
             </a:extLst>
           </p:cNvPr>
@@ -4575,7 +4575,7 @@
           <p:cNvPr id="6" name="architecture-node-0">
             <a:extLst xmlns:a="http://schemas.openxmlformats.org/drawingml/2006/main">
               <a:ext uri="{FF2B5EF4-FFF2-40B4-BE49-F238E27FC236}">
-                <a16:creationId xmlns:a16="http://schemas.microsoft.com/office/drawing/2014/main" id="{A422E326-790E-4603-8F76-F8B7E195B923}"/>
+                <a16:creationId xmlns:a16="http://schemas.microsoft.com/office/drawing/2014/main" id="{55889C1D-D384-4631-9E65-6A47650F1E6E}"/>
               </a:ext>
             </a:extLst>
           </p:cNvPr>
@@ -4608,7 +4608,7 @@
           <p:cNvPr id="7" name="architecture-a-0">
             <a:extLst xmlns:a="http://schemas.openxmlformats.org/drawingml/2006/main">
               <a:ext uri="{FF2B5EF4-FFF2-40B4-BE49-F238E27FC236}">
-                <a16:creationId xmlns:a16="http://schemas.microsoft.com/office/drawing/2014/main" id="{93475944-5F5C-479C-AF30-4BE9153DEC6F}"/>
+                <a16:creationId xmlns:a16="http://schemas.microsoft.com/office/drawing/2014/main" id="{624296DA-AD2F-418B-9FBB-1A189F0C334A}"/>
               </a:ext>
             </a:extLst>
           </p:cNvPr>
@@ -4665,7 +4665,7 @@
           <p:cNvPr id="8" name="architecture-b-0">
             <a:extLst xmlns:a="http://schemas.openxmlformats.org/drawingml/2006/main">
               <a:ext uri="{FF2B5EF4-FFF2-40B4-BE49-F238E27FC236}">
-                <a16:creationId xmlns:a16="http://schemas.microsoft.com/office/drawing/2014/main" id="{708EF03A-00B6-42A7-8D40-4274C14ACFAC}"/>
+                <a16:creationId xmlns:a16="http://schemas.microsoft.com/office/drawing/2014/main" id="{BB148FAC-154D-4B85-8B3E-6346A8F6D8B2}"/>
               </a:ext>
             </a:extLst>
           </p:cNvPr>
@@ -4745,7 +4745,7 @@
           <p:cNvPr id="9" name="architecture-title-1">
             <a:extLst xmlns:a="http://schemas.openxmlformats.org/drawingml/2006/main">
               <a:ext uri="{FF2B5EF4-FFF2-40B4-BE49-F238E27FC236}">
-                <a16:creationId xmlns:a16="http://schemas.microsoft.com/office/drawing/2014/main" id="{38A6EAA2-0B97-4346-B59D-309A118EB3BD}"/>
+                <a16:creationId xmlns:a16="http://schemas.microsoft.com/office/drawing/2014/main" id="{7BD81F31-0A9C-4789-911A-7A12A35E0071}"/>
               </a:ext>
             </a:extLst>
           </p:cNvPr>
@@ -4802,7 +4802,7 @@
           <p:cNvPr id="10" name="architecture-node-1">
             <a:extLst xmlns:a="http://schemas.openxmlformats.org/drawingml/2006/main">
               <a:ext uri="{FF2B5EF4-FFF2-40B4-BE49-F238E27FC236}">
-                <a16:creationId xmlns:a16="http://schemas.microsoft.com/office/drawing/2014/main" id="{AA39FC4F-EBD2-49C3-B487-5F4D8CAA3D95}"/>
+                <a16:creationId xmlns:a16="http://schemas.microsoft.com/office/drawing/2014/main" id="{04898307-F0C9-41D8-A4BE-93DCEC6CB61E}"/>
               </a:ext>
             </a:extLst>
           </p:cNvPr>
@@ -4835,7 +4835,7 @@
           <p:cNvPr id="11" name="architecture-a-1">
             <a:extLst xmlns:a="http://schemas.openxmlformats.org/drawingml/2006/main">
               <a:ext uri="{FF2B5EF4-FFF2-40B4-BE49-F238E27FC236}">
-                <a16:creationId xmlns:a16="http://schemas.microsoft.com/office/drawing/2014/main" id="{C5C04BDD-3BC9-48E8-8239-4FE725406571}"/>
+                <a16:creationId xmlns:a16="http://schemas.microsoft.com/office/drawing/2014/main" id="{0A8D71A5-A691-4B42-909A-0C50E6BF4509}"/>
               </a:ext>
             </a:extLst>
           </p:cNvPr>
@@ -4892,7 +4892,7 @@
           <p:cNvPr id="12" name="architecture-b-1">
             <a:extLst xmlns:a="http://schemas.openxmlformats.org/drawingml/2006/main">
               <a:ext uri="{FF2B5EF4-FFF2-40B4-BE49-F238E27FC236}">
-                <a16:creationId xmlns:a16="http://schemas.microsoft.com/office/drawing/2014/main" id="{A530C99E-E750-4694-9DDC-283D947A7908}"/>
+                <a16:creationId xmlns:a16="http://schemas.microsoft.com/office/drawing/2014/main" id="{873A2D15-A498-44A8-8266-B85C805FFC2F}"/>
               </a:ext>
             </a:extLst>
           </p:cNvPr>
@@ -4972,7 +4972,7 @@
           <p:cNvPr id="13" name="architecture-title-2">
             <a:extLst xmlns:a="http://schemas.openxmlformats.org/drawingml/2006/main">
               <a:ext uri="{FF2B5EF4-FFF2-40B4-BE49-F238E27FC236}">
-                <a16:creationId xmlns:a16="http://schemas.microsoft.com/office/drawing/2014/main" id="{DD9D6AC8-C0B0-4858-8308-54A08B81B6EB}"/>
+                <a16:creationId xmlns:a16="http://schemas.microsoft.com/office/drawing/2014/main" id="{C8E11428-77D6-4A87-9247-DDC4A27F5625}"/>
               </a:ext>
             </a:extLst>
           </p:cNvPr>
@@ -5029,7 +5029,7 @@
           <p:cNvPr id="14" name="architecture-node-2">
             <a:extLst xmlns:a="http://schemas.openxmlformats.org/drawingml/2006/main">
               <a:ext uri="{FF2B5EF4-FFF2-40B4-BE49-F238E27FC236}">
-                <a16:creationId xmlns:a16="http://schemas.microsoft.com/office/drawing/2014/main" id="{74320CD1-E363-4118-8137-46B6CD1AF695}"/>
+                <a16:creationId xmlns:a16="http://schemas.microsoft.com/office/drawing/2014/main" id="{9BF1A729-38AF-45F2-A2FC-2F1A5053940E}"/>
               </a:ext>
             </a:extLst>
           </p:cNvPr>
@@ -5062,7 +5062,7 @@
           <p:cNvPr id="15" name="architecture-a-2">
             <a:extLst xmlns:a="http://schemas.openxmlformats.org/drawingml/2006/main">
               <a:ext uri="{FF2B5EF4-FFF2-40B4-BE49-F238E27FC236}">
-                <a16:creationId xmlns:a16="http://schemas.microsoft.com/office/drawing/2014/main" id="{1187760E-3988-4A98-B6D1-368E7A5525E2}"/>
+                <a16:creationId xmlns:a16="http://schemas.microsoft.com/office/drawing/2014/main" id="{0E337A7D-B9E7-4357-8DB7-E457533120FB}"/>
               </a:ext>
             </a:extLst>
           </p:cNvPr>
@@ -5119,7 +5119,7 @@
           <p:cNvPr id="16" name="architecture-b-2">
             <a:extLst xmlns:a="http://schemas.openxmlformats.org/drawingml/2006/main">
               <a:ext uri="{FF2B5EF4-FFF2-40B4-BE49-F238E27FC236}">
-                <a16:creationId xmlns:a16="http://schemas.microsoft.com/office/drawing/2014/main" id="{79F7AFD7-FC12-414E-8044-DBAEC2AAAED7}"/>
+                <a16:creationId xmlns:a16="http://schemas.microsoft.com/office/drawing/2014/main" id="{93D92462-F5B8-4CF3-81A4-7051CAC78367}"/>
               </a:ext>
             </a:extLst>
           </p:cNvPr>
@@ -5176,7 +5176,7 @@
           <p:cNvPr id="17" name="architecture-title-3">
             <a:extLst xmlns:a="http://schemas.openxmlformats.org/drawingml/2006/main">
               <a:ext uri="{FF2B5EF4-FFF2-40B4-BE49-F238E27FC236}">
-                <a16:creationId xmlns:a16="http://schemas.microsoft.com/office/drawing/2014/main" id="{D5769CE7-A0F6-46B6-9D01-316377CF4ACE}"/>
+                <a16:creationId xmlns:a16="http://schemas.microsoft.com/office/drawing/2014/main" id="{BA8B85E7-F26A-43E1-BD89-05F0CA7C48D0}"/>
               </a:ext>
             </a:extLst>
           </p:cNvPr>
@@ -5233,7 +5233,7 @@
           <p:cNvPr id="18" name="architecture-node-3">
             <a:extLst xmlns:a="http://schemas.openxmlformats.org/drawingml/2006/main">
               <a:ext uri="{FF2B5EF4-FFF2-40B4-BE49-F238E27FC236}">
-                <a16:creationId xmlns:a16="http://schemas.microsoft.com/office/drawing/2014/main" id="{30E1F278-0131-43CD-82AE-A440F0ABDE81}"/>
+                <a16:creationId xmlns:a16="http://schemas.microsoft.com/office/drawing/2014/main" id="{637573FC-84C9-4B73-9C9C-006A77E0188D}"/>
               </a:ext>
             </a:extLst>
           </p:cNvPr>
@@ -5266,7 +5266,7 @@
           <p:cNvPr id="19" name="architecture-a-3">
             <a:extLst xmlns:a="http://schemas.openxmlformats.org/drawingml/2006/main">
               <a:ext uri="{FF2B5EF4-FFF2-40B4-BE49-F238E27FC236}">
-                <a16:creationId xmlns:a16="http://schemas.microsoft.com/office/drawing/2014/main" id="{8E917A25-CCAB-41AC-B2FB-8F3C25CAD984}"/>
+                <a16:creationId xmlns:a16="http://schemas.microsoft.com/office/drawing/2014/main" id="{7749F1C6-382C-43EE-8A44-52F60D03C35D}"/>
               </a:ext>
             </a:extLst>
           </p:cNvPr>
@@ -5323,7 +5323,7 @@
           <p:cNvPr id="20" name="architecture-b-3">
             <a:extLst xmlns:a="http://schemas.openxmlformats.org/drawingml/2006/main">
               <a:ext uri="{FF2B5EF4-FFF2-40B4-BE49-F238E27FC236}">
-                <a16:creationId xmlns:a16="http://schemas.microsoft.com/office/drawing/2014/main" id="{CC474B23-6C77-4F61-99DA-D303A2AAD70A}"/>
+                <a16:creationId xmlns:a16="http://schemas.microsoft.com/office/drawing/2014/main" id="{6BA2F42E-00F2-4530-99D6-3CB90A3D61B2}"/>
               </a:ext>
             </a:extLst>
           </p:cNvPr>
@@ -5481,7 +5481,7 @@
           <p:cNvPr id="24" name="auth-note">
             <a:extLst xmlns:a="http://schemas.openxmlformats.org/drawingml/2006/main">
               <a:ext uri="{FF2B5EF4-FFF2-40B4-BE49-F238E27FC236}">
-                <a16:creationId xmlns:a16="http://schemas.microsoft.com/office/drawing/2014/main" id="{44388997-D07B-4F62-BD21-3206DEB25462}"/>
+                <a16:creationId xmlns:a16="http://schemas.microsoft.com/office/drawing/2014/main" id="{CA7BD35E-AA38-44BB-A60D-CF3A69F51D86}"/>
               </a:ext>
             </a:extLst>
           </p:cNvPr>
@@ -5538,7 +5538,7 @@
           <p:cNvPr id="25" name="footer">
             <a:extLst xmlns:a="http://schemas.openxmlformats.org/drawingml/2006/main">
               <a:ext uri="{FF2B5EF4-FFF2-40B4-BE49-F238E27FC236}">
-                <a16:creationId xmlns:a16="http://schemas.microsoft.com/office/drawing/2014/main" id="{06FF2BF9-502C-4261-BD05-62C22A5212B9}"/>
+                <a16:creationId xmlns:a16="http://schemas.microsoft.com/office/drawing/2014/main" id="{D1C2BC23-6621-4AF1-9873-33C90EB7C5C9}"/>
               </a:ext>
             </a:extLst>
           </p:cNvPr>
@@ -5593,7 +5593,7 @@
     </p:spTree>
     <p:extLst>
       <p:ext uri="{BB962C8B-B14F-4D97-AF65-F5344CB8AC3E}">
-        <p14:creationId xmlns:p14="http://schemas.microsoft.com/office/powerpoint/2010/main" val="2135621738"/>
+        <p14:creationId xmlns:p14="http://schemas.microsoft.com/office/powerpoint/2010/main" val="1089092642"/>
       </p:ext>
     </p:extLst>
   </p:cSld>
@@ -5624,7 +5624,7 @@
           <p:cNvPr id="8" name="wordmark">
             <a:extLst xmlns:a="http://schemas.openxmlformats.org/drawingml/2006/main">
               <a:ext uri="{FF2B5EF4-FFF2-40B4-BE49-F238E27FC236}">
-                <a16:creationId xmlns:a16="http://schemas.microsoft.com/office/drawing/2014/main" id="{419B2061-DDDF-499A-88AE-C530ACAA1887}"/>
+                <a16:creationId xmlns:a16="http://schemas.microsoft.com/office/drawing/2014/main" id="{F128CE38-BC4D-4658-A2FB-938D7192EFEB}"/>
               </a:ext>
             </a:extLst>
           </p:cNvPr>
@@ -5681,7 +5681,7 @@
           <p:cNvPr id="2" name="page">
             <a:extLst xmlns:a="http://schemas.openxmlformats.org/drawingml/2006/main">
               <a:ext uri="{FF2B5EF4-FFF2-40B4-BE49-F238E27FC236}">
-                <a16:creationId xmlns:a16="http://schemas.microsoft.com/office/drawing/2014/main" id="{FC70C586-DC99-472C-BAD4-552500A3A88D}"/>
+                <a16:creationId xmlns:a16="http://schemas.microsoft.com/office/drawing/2014/main" id="{21910729-D4A6-40F0-B5CA-C8FCFF26B713}"/>
               </a:ext>
             </a:extLst>
           </p:cNvPr>
@@ -5738,7 +5738,7 @@
           <p:cNvPr id="3" name="title">
             <a:extLst xmlns:a="http://schemas.openxmlformats.org/drawingml/2006/main">
               <a:ext uri="{FF2B5EF4-FFF2-40B4-BE49-F238E27FC236}">
-                <a16:creationId xmlns:a16="http://schemas.microsoft.com/office/drawing/2014/main" id="{5C9D62A8-2398-4197-B40B-A2858B2AE545}"/>
+                <a16:creationId xmlns:a16="http://schemas.microsoft.com/office/drawing/2014/main" id="{713C49E5-AAD9-4127-ABDE-C839BB23B076}"/>
               </a:ext>
             </a:extLst>
           </p:cNvPr>
@@ -5795,7 +5795,7 @@
           <p:cNvPr id="4" name="subtitle">
             <a:extLst xmlns:a="http://schemas.openxmlformats.org/drawingml/2006/main">
               <a:ext uri="{FF2B5EF4-FFF2-40B4-BE49-F238E27FC236}">
-                <a16:creationId xmlns:a16="http://schemas.microsoft.com/office/drawing/2014/main" id="{7B282E5C-9B62-4BA0-8383-DA06FCB9465A}"/>
+                <a16:creationId xmlns:a16="http://schemas.microsoft.com/office/drawing/2014/main" id="{574DBD55-D35A-4543-A8AD-197AF9AFBE61}"/>
               </a:ext>
             </a:extLst>
           </p:cNvPr>
@@ -6090,7 +6090,7 @@
           <p:cNvPr id="6" name="our-focus">
             <a:extLst xmlns:a="http://schemas.openxmlformats.org/drawingml/2006/main">
               <a:ext uri="{FF2B5EF4-FFF2-40B4-BE49-F238E27FC236}">
-                <a16:creationId xmlns:a16="http://schemas.microsoft.com/office/drawing/2014/main" id="{8F371A41-BE9C-4396-A156-627372264D50}"/>
+                <a16:creationId xmlns:a16="http://schemas.microsoft.com/office/drawing/2014/main" id="{9BDE79C2-26D0-4DED-B4F3-1499F1CFA5BA}"/>
               </a:ext>
             </a:extLst>
           </p:cNvPr>
@@ -6147,7 +6147,7 @@
           <p:cNvPr id="7" name="footer">
             <a:extLst xmlns:a="http://schemas.openxmlformats.org/drawingml/2006/main">
               <a:ext uri="{FF2B5EF4-FFF2-40B4-BE49-F238E27FC236}">
-                <a16:creationId xmlns:a16="http://schemas.microsoft.com/office/drawing/2014/main" id="{79CAEAC6-8C93-4503-B18D-AAE1AAD3FBA9}"/>
+                <a16:creationId xmlns:a16="http://schemas.microsoft.com/office/drawing/2014/main" id="{7BE3D881-0097-4682-B5FD-A0D2B5CC972D}"/>
               </a:ext>
             </a:extLst>
           </p:cNvPr>
@@ -6202,7 +6202,7 @@
     </p:spTree>
     <p:extLst>
       <p:ext uri="{BB962C8B-B14F-4D97-AF65-F5344CB8AC3E}">
-        <p14:creationId xmlns:p14="http://schemas.microsoft.com/office/powerpoint/2010/main" val="1826992471"/>
+        <p14:creationId xmlns:p14="http://schemas.microsoft.com/office/powerpoint/2010/main" val="1573632205"/>
       </p:ext>
     </p:extLst>
   </p:cSld>
@@ -6233,7 +6233,7 @@
           <p:cNvPr id="12" name="wordmark">
             <a:extLst xmlns:a="http://schemas.openxmlformats.org/drawingml/2006/main">
               <a:ext uri="{FF2B5EF4-FFF2-40B4-BE49-F238E27FC236}">
-                <a16:creationId xmlns:a16="http://schemas.microsoft.com/office/drawing/2014/main" id="{78261158-90CB-41A5-93CB-24AB731AF9E7}"/>
+                <a16:creationId xmlns:a16="http://schemas.microsoft.com/office/drawing/2014/main" id="{FD77CB3A-ADE1-42CC-8A08-5538ACF12172}"/>
               </a:ext>
             </a:extLst>
           </p:cNvPr>
@@ -6290,7 +6290,7 @@
           <p:cNvPr id="2" name="page">
             <a:extLst xmlns:a="http://schemas.openxmlformats.org/drawingml/2006/main">
               <a:ext uri="{FF2B5EF4-FFF2-40B4-BE49-F238E27FC236}">
-                <a16:creationId xmlns:a16="http://schemas.microsoft.com/office/drawing/2014/main" id="{4D763EF5-8C94-471C-A6BF-707F16AD9BCB}"/>
+                <a16:creationId xmlns:a16="http://schemas.microsoft.com/office/drawing/2014/main" id="{38B0BFC2-D236-4D36-BD77-31998F9DD923}"/>
               </a:ext>
             </a:extLst>
           </p:cNvPr>
@@ -6347,7 +6347,7 @@
           <p:cNvPr id="3" name="title">
             <a:extLst xmlns:a="http://schemas.openxmlformats.org/drawingml/2006/main">
               <a:ext uri="{FF2B5EF4-FFF2-40B4-BE49-F238E27FC236}">
-                <a16:creationId xmlns:a16="http://schemas.microsoft.com/office/drawing/2014/main" id="{985A3D73-E840-40FC-80FB-23D521458CD9}"/>
+                <a16:creationId xmlns:a16="http://schemas.microsoft.com/office/drawing/2014/main" id="{B09A34E4-DD72-43A2-A331-847E6BE12646}"/>
               </a:ext>
             </a:extLst>
           </p:cNvPr>
@@ -6404,7 +6404,7 @@
           <p:cNvPr id="4" name="subtitle">
             <a:extLst xmlns:a="http://schemas.openxmlformats.org/drawingml/2006/main">
               <a:ext uri="{FF2B5EF4-FFF2-40B4-BE49-F238E27FC236}">
-                <a16:creationId xmlns:a16="http://schemas.microsoft.com/office/drawing/2014/main" id="{B6AF1B28-325A-4855-9F56-C4D7E778909D}"/>
+                <a16:creationId xmlns:a16="http://schemas.microsoft.com/office/drawing/2014/main" id="{888C70C4-B1E9-497D-975D-B71AA08922BD}"/>
               </a:ext>
             </a:extLst>
           </p:cNvPr>
@@ -6461,7 +6461,7 @@
           <p:cNvPr id="5" name="price">
             <a:extLst xmlns:a="http://schemas.openxmlformats.org/drawingml/2006/main">
               <a:ext uri="{FF2B5EF4-FFF2-40B4-BE49-F238E27FC236}">
-                <a16:creationId xmlns:a16="http://schemas.microsoft.com/office/drawing/2014/main" id="{49D3DE58-0A6E-415A-A29A-330505B4128F}"/>
+                <a16:creationId xmlns:a16="http://schemas.microsoft.com/office/drawing/2014/main" id="{F73B52F8-5CAF-4338-BB10-994A730A13A0}"/>
               </a:ext>
             </a:extLst>
           </p:cNvPr>
@@ -6518,7 +6518,7 @@
           <p:cNvPr id="6" name="price-unit">
             <a:extLst xmlns:a="http://schemas.openxmlformats.org/drawingml/2006/main">
               <a:ext uri="{FF2B5EF4-FFF2-40B4-BE49-F238E27FC236}">
-                <a16:creationId xmlns:a16="http://schemas.microsoft.com/office/drawing/2014/main" id="{A164BD4F-914A-48AA-AB04-1A30A486DDF8}"/>
+                <a16:creationId xmlns:a16="http://schemas.microsoft.com/office/drawing/2014/main" id="{CBA2DD68-02AE-4813-B69E-AEBDF5AE6B6E}"/>
               </a:ext>
             </a:extLst>
           </p:cNvPr>
@@ -6575,7 +6575,7 @@
           <p:cNvPr id="7" name="hypothesis-label">
             <a:extLst xmlns:a="http://schemas.openxmlformats.org/drawingml/2006/main">
               <a:ext uri="{FF2B5EF4-FFF2-40B4-BE49-F238E27FC236}">
-                <a16:creationId xmlns:a16="http://schemas.microsoft.com/office/drawing/2014/main" id="{AD0E5656-DB59-4CCB-BCFE-136EEE7E986E}"/>
+                <a16:creationId xmlns:a16="http://schemas.microsoft.com/office/drawing/2014/main" id="{182D9375-B804-4642-BEB8-E5084496D5F8}"/>
               </a:ext>
             </a:extLst>
           </p:cNvPr>
@@ -6632,7 +6632,7 @@
           <p:cNvPr id="8" name="business-benefit">
             <a:extLst xmlns:a="http://schemas.openxmlformats.org/drawingml/2006/main">
               <a:ext uri="{FF2B5EF4-FFF2-40B4-BE49-F238E27FC236}">
-                <a16:creationId xmlns:a16="http://schemas.microsoft.com/office/drawing/2014/main" id="{E90FCBA7-9A00-4584-856F-23801A224B73}"/>
+                <a16:creationId xmlns:a16="http://schemas.microsoft.com/office/drawing/2014/main" id="{9B87607F-54BC-46B8-8CA8-2424CEE45072}"/>
               </a:ext>
             </a:extLst>
           </p:cNvPr>
@@ -6689,7 +6689,7 @@
           <p:cNvPr id="9" name="business-rationale">
             <a:extLst xmlns:a="http://schemas.openxmlformats.org/drawingml/2006/main">
               <a:ext uri="{FF2B5EF4-FFF2-40B4-BE49-F238E27FC236}">
-                <a16:creationId xmlns:a16="http://schemas.microsoft.com/office/drawing/2014/main" id="{32E99BD5-A746-495D-AE7B-25347C68E72D}"/>
+                <a16:creationId xmlns:a16="http://schemas.microsoft.com/office/drawing/2014/main" id="{092A3CF7-22EA-4C35-9F4B-EA393CC34F05}"/>
               </a:ext>
             </a:extLst>
           </p:cNvPr>
@@ -6769,7 +6769,7 @@
           <p:cNvPr id="10" name="cost-discipline">
             <a:extLst xmlns:a="http://schemas.openxmlformats.org/drawingml/2006/main">
               <a:ext uri="{FF2B5EF4-FFF2-40B4-BE49-F238E27FC236}">
-                <a16:creationId xmlns:a16="http://schemas.microsoft.com/office/drawing/2014/main" id="{580C4378-522A-43B5-B348-223955F06C81}"/>
+                <a16:creationId xmlns:a16="http://schemas.microsoft.com/office/drawing/2014/main" id="{8BA615F7-F8E8-483B-BDB0-E93CAD1B4D88}"/>
               </a:ext>
             </a:extLst>
           </p:cNvPr>
@@ -6849,7 +6849,7 @@
           <p:cNvPr id="11" name="footer">
             <a:extLst xmlns:a="http://schemas.openxmlformats.org/drawingml/2006/main">
               <a:ext uri="{FF2B5EF4-FFF2-40B4-BE49-F238E27FC236}">
-                <a16:creationId xmlns:a16="http://schemas.microsoft.com/office/drawing/2014/main" id="{6FB1B272-41B9-4942-817D-1A587E877C74}"/>
+                <a16:creationId xmlns:a16="http://schemas.microsoft.com/office/drawing/2014/main" id="{F93365D2-0372-4673-9B81-9EDED7CFF24C}"/>
               </a:ext>
             </a:extLst>
           </p:cNvPr>
@@ -6904,7 +6904,7 @@
     </p:spTree>
     <p:extLst>
       <p:ext uri="{BB962C8B-B14F-4D97-AF65-F5344CB8AC3E}">
-        <p14:creationId xmlns:p14="http://schemas.microsoft.com/office/powerpoint/2010/main" val="1738913255"/>
+        <p14:creationId xmlns:p14="http://schemas.microsoft.com/office/powerpoint/2010/main" val="2021320905"/>
       </p:ext>
     </p:extLst>
   </p:cSld>
@@ -6935,7 +6935,7 @@
           <p:cNvPr id="13" name="wordmark">
             <a:extLst xmlns:a="http://schemas.openxmlformats.org/drawingml/2006/main">
               <a:ext uri="{FF2B5EF4-FFF2-40B4-BE49-F238E27FC236}">
-                <a16:creationId xmlns:a16="http://schemas.microsoft.com/office/drawing/2014/main" id="{70E4902A-31F2-45F7-AB34-57D50A60C6AC}"/>
+                <a16:creationId xmlns:a16="http://schemas.microsoft.com/office/drawing/2014/main" id="{97A6D38B-2D7B-4B43-B6E9-B6DDF838DEA6}"/>
               </a:ext>
             </a:extLst>
           </p:cNvPr>
@@ -6992,7 +6992,7 @@
           <p:cNvPr id="2" name="page">
             <a:extLst xmlns:a="http://schemas.openxmlformats.org/drawingml/2006/main">
               <a:ext uri="{FF2B5EF4-FFF2-40B4-BE49-F238E27FC236}">
-                <a16:creationId xmlns:a16="http://schemas.microsoft.com/office/drawing/2014/main" id="{A2D6FDFC-F4C5-42BD-A08C-C87FB803CDB3}"/>
+                <a16:creationId xmlns:a16="http://schemas.microsoft.com/office/drawing/2014/main" id="{6D1E56C2-4968-4662-BDA2-958B36BB7744}"/>
               </a:ext>
             </a:extLst>
           </p:cNvPr>
@@ -7049,7 +7049,7 @@
           <p:cNvPr id="3" name="title">
             <a:extLst xmlns:a="http://schemas.openxmlformats.org/drawingml/2006/main">
               <a:ext uri="{FF2B5EF4-FFF2-40B4-BE49-F238E27FC236}">
-                <a16:creationId xmlns:a16="http://schemas.microsoft.com/office/drawing/2014/main" id="{2297366E-2094-4D2B-B47E-6ABB579BB13C}"/>
+                <a16:creationId xmlns:a16="http://schemas.microsoft.com/office/drawing/2014/main" id="{9353AB31-6D47-453F-A102-AEF99C66EAC0}"/>
               </a:ext>
             </a:extLst>
           </p:cNvPr>
@@ -7106,7 +7106,7 @@
           <p:cNvPr id="4" name="subtitle">
             <a:extLst xmlns:a="http://schemas.openxmlformats.org/drawingml/2006/main">
               <a:ext uri="{FF2B5EF4-FFF2-40B4-BE49-F238E27FC236}">
-                <a16:creationId xmlns:a16="http://schemas.microsoft.com/office/drawing/2014/main" id="{3BFBE165-26D4-4213-9C07-97BB0B9A049B}"/>
+                <a16:creationId xmlns:a16="http://schemas.microsoft.com/office/drawing/2014/main" id="{3B2ADD7B-D89B-49DD-8726-7163F12B2BF2}"/>
               </a:ext>
             </a:extLst>
           </p:cNvPr>
@@ -7163,7 +7163,7 @@
           <p:cNvPr id="5" name="interviews-number">
             <a:extLst xmlns:a="http://schemas.openxmlformats.org/drawingml/2006/main">
               <a:ext uri="{FF2B5EF4-FFF2-40B4-BE49-F238E27FC236}">
-                <a16:creationId xmlns:a16="http://schemas.microsoft.com/office/drawing/2014/main" id="{3652DA2B-2710-438E-91E3-01A39823AF4A}"/>
+                <a16:creationId xmlns:a16="http://schemas.microsoft.com/office/drawing/2014/main" id="{BC780617-D8AB-4619-BAED-D4C88C6BCD34}"/>
               </a:ext>
             </a:extLst>
           </p:cNvPr>
@@ -7220,7 +7220,7 @@
           <p:cNvPr id="6" name="interviews-label">
             <a:extLst xmlns:a="http://schemas.openxmlformats.org/drawingml/2006/main">
               <a:ext uri="{FF2B5EF4-FFF2-40B4-BE49-F238E27FC236}">
-                <a16:creationId xmlns:a16="http://schemas.microsoft.com/office/drawing/2014/main" id="{055780AA-2808-4128-80D0-EA3AA285D44A}"/>
+                <a16:creationId xmlns:a16="http://schemas.microsoft.com/office/drawing/2014/main" id="{E906824E-522D-459F-BFF3-362E25BFC423}"/>
               </a:ext>
             </a:extLst>
           </p:cNvPr>
@@ -7277,7 +7277,7 @@
           <p:cNvPr id="7" name="interviews-detail">
             <a:extLst xmlns:a="http://schemas.openxmlformats.org/drawingml/2006/main">
               <a:ext uri="{FF2B5EF4-FFF2-40B4-BE49-F238E27FC236}">
-                <a16:creationId xmlns:a16="http://schemas.microsoft.com/office/drawing/2014/main" id="{2C71AB35-D261-4B62-8E45-0E1955710C1B}"/>
+                <a16:creationId xmlns:a16="http://schemas.microsoft.com/office/drawing/2014/main" id="{A85D9613-D8C6-4C2C-9E5D-13F242A58998}"/>
               </a:ext>
             </a:extLst>
           </p:cNvPr>
@@ -7357,7 +7357,7 @@
           <p:cNvPr id="8" name="pilot-number">
             <a:extLst xmlns:a="http://schemas.openxmlformats.org/drawingml/2006/main">
               <a:ext uri="{FF2B5EF4-FFF2-40B4-BE49-F238E27FC236}">
-                <a16:creationId xmlns:a16="http://schemas.microsoft.com/office/drawing/2014/main" id="{B8CDBAA1-DF4C-49D0-83DF-6D300AAD115F}"/>
+                <a16:creationId xmlns:a16="http://schemas.microsoft.com/office/drawing/2014/main" id="{4F700B15-FC76-42E2-9722-6AC855D9C805}"/>
               </a:ext>
             </a:extLst>
           </p:cNvPr>
@@ -7414,7 +7414,7 @@
           <p:cNvPr id="9" name="pilot-label">
             <a:extLst xmlns:a="http://schemas.openxmlformats.org/drawingml/2006/main">
               <a:ext uri="{FF2B5EF4-FFF2-40B4-BE49-F238E27FC236}">
-                <a16:creationId xmlns:a16="http://schemas.microsoft.com/office/drawing/2014/main" id="{4B4BB3C6-AA36-43B5-B13A-7513569462B3}"/>
+                <a16:creationId xmlns:a16="http://schemas.microsoft.com/office/drawing/2014/main" id="{E5B8EACD-5234-4BCC-8002-0CCFFF5B728A}"/>
               </a:ext>
             </a:extLst>
           </p:cNvPr>
@@ -7471,7 +7471,7 @@
           <p:cNvPr id="10" name="pilot-detail">
             <a:extLst xmlns:a="http://schemas.openxmlformats.org/drawingml/2006/main">
               <a:ext uri="{FF2B5EF4-FFF2-40B4-BE49-F238E27FC236}">
-                <a16:creationId xmlns:a16="http://schemas.microsoft.com/office/drawing/2014/main" id="{85F94838-3A9A-4FC6-9586-5D7280BD13CB}"/>
+                <a16:creationId xmlns:a16="http://schemas.microsoft.com/office/drawing/2014/main" id="{794AF374-4089-4103-83C1-72852B937A6A}"/>
               </a:ext>
             </a:extLst>
           </p:cNvPr>
@@ -7551,7 +7551,7 @@
           <p:cNvPr id="11" name="metric">
             <a:extLst xmlns:a="http://schemas.openxmlformats.org/drawingml/2006/main">
               <a:ext uri="{FF2B5EF4-FFF2-40B4-BE49-F238E27FC236}">
-                <a16:creationId xmlns:a16="http://schemas.microsoft.com/office/drawing/2014/main" id="{932867EA-95A2-4E61-B974-63440F5AF1C9}"/>
+                <a16:creationId xmlns:a16="http://schemas.microsoft.com/office/drawing/2014/main" id="{A844B9D8-8FBE-49BD-AA0C-DB28949AB72F}"/>
               </a:ext>
             </a:extLst>
           </p:cNvPr>
@@ -7608,7 +7608,7 @@
           <p:cNvPr id="12" name="footer">
             <a:extLst xmlns:a="http://schemas.openxmlformats.org/drawingml/2006/main">
               <a:ext uri="{FF2B5EF4-FFF2-40B4-BE49-F238E27FC236}">
-                <a16:creationId xmlns:a16="http://schemas.microsoft.com/office/drawing/2014/main" id="{676C6466-CB3A-4649-A64F-1A3BE7FD9757}"/>
+                <a16:creationId xmlns:a16="http://schemas.microsoft.com/office/drawing/2014/main" id="{408EB4B8-A573-44C8-AC63-BABF2800A975}"/>
               </a:ext>
             </a:extLst>
           </p:cNvPr>
@@ -7663,7 +7663,7 @@
     </p:spTree>
     <p:extLst>
       <p:ext uri="{BB962C8B-B14F-4D97-AF65-F5344CB8AC3E}">
-        <p14:creationId xmlns:p14="http://schemas.microsoft.com/office/powerpoint/2010/main" val="128901145"/>
+        <p14:creationId xmlns:p14="http://schemas.microsoft.com/office/powerpoint/2010/main" val="1031402545"/>
       </p:ext>
     </p:extLst>
   </p:cSld>
@@ -7694,7 +7694,7 @@
           <p:cNvPr id="14" name="wordmark">
             <a:extLst xmlns:a="http://schemas.openxmlformats.org/drawingml/2006/main">
               <a:ext uri="{FF2B5EF4-FFF2-40B4-BE49-F238E27FC236}">
-                <a16:creationId xmlns:a16="http://schemas.microsoft.com/office/drawing/2014/main" id="{48E7B85F-2969-48D9-AF63-BCA71A6FECC8}"/>
+                <a16:creationId xmlns:a16="http://schemas.microsoft.com/office/drawing/2014/main" id="{729D5284-392D-4C50-AD42-99E66838ED02}"/>
               </a:ext>
             </a:extLst>
           </p:cNvPr>
@@ -7751,7 +7751,7 @@
           <p:cNvPr id="2" name="page">
             <a:extLst xmlns:a="http://schemas.openxmlformats.org/drawingml/2006/main">
               <a:ext uri="{FF2B5EF4-FFF2-40B4-BE49-F238E27FC236}">
-                <a16:creationId xmlns:a16="http://schemas.microsoft.com/office/drawing/2014/main" id="{FC8CAA48-6502-421D-914B-CD7546B8F05E}"/>
+                <a16:creationId xmlns:a16="http://schemas.microsoft.com/office/drawing/2014/main" id="{254CE4BC-738B-4B90-B6CD-D244C488DE1C}"/>
               </a:ext>
             </a:extLst>
           </p:cNvPr>
@@ -7808,7 +7808,7 @@
           <p:cNvPr id="3" name="title">
             <a:extLst xmlns:a="http://schemas.openxmlformats.org/drawingml/2006/main">
               <a:ext uri="{FF2B5EF4-FFF2-40B4-BE49-F238E27FC236}">
-                <a16:creationId xmlns:a16="http://schemas.microsoft.com/office/drawing/2014/main" id="{8BF6615B-45F0-40EA-BDEE-BE7BE355099E}"/>
+                <a16:creationId xmlns:a16="http://schemas.microsoft.com/office/drawing/2014/main" id="{6F8C4298-7036-4278-88E5-E1DDEB493476}"/>
               </a:ext>
             </a:extLst>
           </p:cNvPr>
@@ -7865,7 +7865,7 @@
           <p:cNvPr id="4" name="subtitle">
             <a:extLst xmlns:a="http://schemas.openxmlformats.org/drawingml/2006/main">
               <a:ext uri="{FF2B5EF4-FFF2-40B4-BE49-F238E27FC236}">
-                <a16:creationId xmlns:a16="http://schemas.microsoft.com/office/drawing/2014/main" id="{BFB49722-BE9A-4FD3-95EA-76CB6F3A0F15}"/>
+                <a16:creationId xmlns:a16="http://schemas.microsoft.com/office/drawing/2014/main" id="{1F48CE91-FC04-4599-B21C-B916903BEF36}"/>
               </a:ext>
             </a:extLst>
           </p:cNvPr>
@@ -7922,7 +7922,7 @@
           <p:cNvPr id="5" name="next-label">
             <a:extLst xmlns:a="http://schemas.openxmlformats.org/drawingml/2006/main">
               <a:ext uri="{FF2B5EF4-FFF2-40B4-BE49-F238E27FC236}">
-                <a16:creationId xmlns:a16="http://schemas.microsoft.com/office/drawing/2014/main" id="{C320F70D-C64B-47D2-8360-C785BF54904D}"/>
+                <a16:creationId xmlns:a16="http://schemas.microsoft.com/office/drawing/2014/main" id="{B8C68CC3-5818-4FE7-A457-AFF00CB4F36E}"/>
               </a:ext>
             </a:extLst>
           </p:cNvPr>
@@ -7969,7 +7969,7 @@
                 <a:ea typeface="Noto Sans"/>
                 <a:cs typeface="Noto Sans"/>
               </a:rPr>
-              <a:t>Next steps</a:t>
+              <a:t>Demo and next steps</a:t>
             </a:r>
           </a:p>
         </p:txBody>
@@ -7979,7 +7979,7 @@
           <p:cNvPr id="6" name="next-one">
             <a:extLst xmlns:a="http://schemas.openxmlformats.org/drawingml/2006/main">
               <a:ext uri="{FF2B5EF4-FFF2-40B4-BE49-F238E27FC236}">
-                <a16:creationId xmlns:a16="http://schemas.microsoft.com/office/drawing/2014/main" id="{22B5DCEB-A65E-4720-8821-1A78E58C32DD}"/>
+                <a16:creationId xmlns:a16="http://schemas.microsoft.com/office/drawing/2014/main" id="{809C9CDB-0FCC-4995-89DF-258C3164DB6D}"/>
               </a:ext>
             </a:extLst>
           </p:cNvPr>
@@ -8025,8 +8025,9 @@
                 <a:latin typeface="Noto Sans"/>
                 <a:ea typeface="Noto Sans"/>
                 <a:cs typeface="Noto Sans"/>
-              </a:rPr>
-              <a:t>Publish the captioned demo video</a:t>
+                <a:hlinkClick xmlns:r="http://schemas.openxmlformats.org/officeDocument/2006/relationships" r:id="Rdcd73f6c65694d80"/>
+              </a:rPr>
+              <a:t>Watch the public 2:49 demo</a:t>
             </a:r>
           </a:p>
         </p:txBody>
@@ -8036,7 +8037,7 @@
           <p:cNvPr id="7" name="next-two">
             <a:extLst xmlns:a="http://schemas.openxmlformats.org/drawingml/2006/main">
               <a:ext uri="{FF2B5EF4-FFF2-40B4-BE49-F238E27FC236}">
-                <a16:creationId xmlns:a16="http://schemas.microsoft.com/office/drawing/2014/main" id="{40F06627-BD4A-46F6-BA45-7352FAA2772B}"/>
+                <a16:creationId xmlns:a16="http://schemas.microsoft.com/office/drawing/2014/main" id="{01900653-7678-4A3C-8D5A-4542A97EB5EB}"/>
               </a:ext>
             </a:extLst>
           </p:cNvPr>
@@ -8093,7 +8094,7 @@
           <p:cNvPr id="8" name="next-three">
             <a:extLst xmlns:a="http://schemas.openxmlformats.org/drawingml/2006/main">
               <a:ext uri="{FF2B5EF4-FFF2-40B4-BE49-F238E27FC236}">
-                <a16:creationId xmlns:a16="http://schemas.microsoft.com/office/drawing/2014/main" id="{57B67199-21F3-452C-B219-69FF847B5CEC}"/>
+                <a16:creationId xmlns:a16="http://schemas.microsoft.com/office/drawing/2014/main" id="{4683DEF2-FEA7-471E-A8A1-6FC8D105B260}"/>
               </a:ext>
             </a:extLst>
           </p:cNvPr>
@@ -8150,7 +8151,7 @@
           <p:cNvPr id="9" name="contribution-label">
             <a:extLst xmlns:a="http://schemas.openxmlformats.org/drawingml/2006/main">
               <a:ext uri="{FF2B5EF4-FFF2-40B4-BE49-F238E27FC236}">
-                <a16:creationId xmlns:a16="http://schemas.microsoft.com/office/drawing/2014/main" id="{6B2FBC6C-42F2-421E-B0F5-FD4F4AB3B078}"/>
+                <a16:creationId xmlns:a16="http://schemas.microsoft.com/office/drawing/2014/main" id="{2AA8DD40-D09D-45D3-B184-B70238652B1D}"/>
               </a:ext>
             </a:extLst>
           </p:cNvPr>
@@ -8207,7 +8208,7 @@
           <p:cNvPr id="10" name="contribution-name">
             <a:extLst xmlns:a="http://schemas.openxmlformats.org/drawingml/2006/main">
               <a:ext uri="{FF2B5EF4-FFF2-40B4-BE49-F238E27FC236}">
-                <a16:creationId xmlns:a16="http://schemas.microsoft.com/office/drawing/2014/main" id="{0438820F-F387-4B99-A296-139CCB3C81AC}"/>
+                <a16:creationId xmlns:a16="http://schemas.microsoft.com/office/drawing/2014/main" id="{AF3EF428-C006-41AB-8D41-68A5B24E823B}"/>
               </a:ext>
             </a:extLst>
           </p:cNvPr>
@@ -8253,7 +8254,7 @@
                 <a:latin typeface="Noto Sans"/>
                 <a:ea typeface="Noto Sans"/>
                 <a:cs typeface="Noto Sans"/>
-                <a:hlinkClick xmlns:r="http://schemas.openxmlformats.org/officeDocument/2006/relationships" r:id="R50bc4f3de3624a28"/>
+                <a:hlinkClick xmlns:r="http://schemas.openxmlformats.org/officeDocument/2006/relationships" r:id="Rada79a93e47a42ac"/>
               </a:rPr>
               <a:t>@kindhandoff/guard</a:t>
             </a:r>
@@ -8265,7 +8266,7 @@
           <p:cNvPr id="11" name="contribution-role">
             <a:extLst xmlns:a="http://schemas.openxmlformats.org/drawingml/2006/main">
               <a:ext uri="{FF2B5EF4-FFF2-40B4-BE49-F238E27FC236}">
-                <a16:creationId xmlns:a16="http://schemas.microsoft.com/office/drawing/2014/main" id="{4425D530-03B2-4F5E-8D08-B5CBD7CE00BE}"/>
+                <a16:creationId xmlns:a16="http://schemas.microsoft.com/office/drawing/2014/main" id="{580A06AE-4871-4E78-8E0E-AD2C57A1E58A}"/>
               </a:ext>
             </a:extLst>
           </p:cNvPr>
@@ -8368,7 +8369,7 @@
           <p:cNvPr id="12" name="repo-link">
             <a:extLst xmlns:a="http://schemas.openxmlformats.org/drawingml/2006/main">
               <a:ext uri="{FF2B5EF4-FFF2-40B4-BE49-F238E27FC236}">
-                <a16:creationId xmlns:a16="http://schemas.microsoft.com/office/drawing/2014/main" id="{8E349F2C-5653-4956-944B-F4EB79A7ED71}"/>
+                <a16:creationId xmlns:a16="http://schemas.microsoft.com/office/drawing/2014/main" id="{EDCE25A1-ED02-4DA8-9B25-6991598D61A7}"/>
               </a:ext>
             </a:extLst>
           </p:cNvPr>
@@ -8414,7 +8415,7 @@
                 <a:latin typeface="Noto Sans"/>
                 <a:ea typeface="Noto Sans"/>
                 <a:cs typeface="Noto Sans"/>
-                <a:hlinkClick xmlns:r="http://schemas.openxmlformats.org/officeDocument/2006/relationships" r:id="Rfba57f31fe2042e1"/>
+                <a:hlinkClick xmlns:r="http://schemas.openxmlformats.org/officeDocument/2006/relationships" r:id="Rbdd64eef39de4017"/>
               </a:rPr>
               <a:t>github.com/shi1720/Amazon-Developer-Hackathon</a:t>
             </a:r>
@@ -8426,7 +8427,7 @@
           <p:cNvPr id="13" name="hosted-url">
             <a:extLst xmlns:a="http://schemas.openxmlformats.org/drawingml/2006/main">
               <a:ext uri="{FF2B5EF4-FFF2-40B4-BE49-F238E27FC236}">
-                <a16:creationId xmlns:a16="http://schemas.microsoft.com/office/drawing/2014/main" id="{367048E4-045D-4685-AB21-52AEF46BFC0D}"/>
+                <a16:creationId xmlns:a16="http://schemas.microsoft.com/office/drawing/2014/main" id="{C316A054-D149-48D8-AEF0-7B8EC26B51C5}"/>
               </a:ext>
             </a:extLst>
           </p:cNvPr>
@@ -8472,7 +8473,7 @@
                 <a:latin typeface="Noto Sans"/>
                 <a:ea typeface="Noto Sans"/>
                 <a:cs typeface="Noto Sans"/>
-                <a:hlinkClick xmlns:r="http://schemas.openxmlformats.org/officeDocument/2006/relationships" r:id="R182ada68d73843a7"/>
+                <a:hlinkClick xmlns:r="http://schemas.openxmlformats.org/officeDocument/2006/relationships" r:id="Rd39270319c1e43d2"/>
               </a:rPr>
               <a:t>Verified public app: kindhandoff.web.app</a:t>
             </a:r>
@@ -8482,7 +8483,7 @@
     </p:spTree>
     <p:extLst>
       <p:ext uri="{BB962C8B-B14F-4D97-AF65-F5344CB8AC3E}">
-        <p14:creationId xmlns:p14="http://schemas.microsoft.com/office/powerpoint/2010/main" val="714123412"/>
+        <p14:creationId xmlns:p14="http://schemas.microsoft.com/office/powerpoint/2010/main" val="700910041"/>
       </p:ext>
     </p:extLst>
   </p:cSld>

</xml_diff>

<commit_message>
Record confirmed hackathon submission and final kit
</commit_message>
<xml_diff>
--- a/docs/deliverables/KindHandoff-Pitch.pptx
+++ b/docs/deliverables/KindHandoff-Pitch.pptx
@@ -2,20 +2,20 @@
 <file path=ppt/presentation.xml><?xml version="1.0" encoding="utf-8"?>
 <p:presentation xmlns:p="http://schemas.openxmlformats.org/presentationml/2006/main">
   <p:sldMasterIdLst>
-    <p:sldMasterId xmlns:r="http://schemas.openxmlformats.org/officeDocument/2006/relationships" id="2147483648" r:id="R09f1dd50ca0f499e"/>
+    <p:sldMasterId xmlns:r="http://schemas.openxmlformats.org/officeDocument/2006/relationships" id="2147483648" r:id="Rd14de4f3bd344fab"/>
   </p:sldMasterIdLst>
   <p:notesMasterIdLst>
-    <p:notesMasterId xmlns:r="http://schemas.openxmlformats.org/officeDocument/2006/relationships" r:id="Rd5d1116002a64289"/>
+    <p:notesMasterId xmlns:r="http://schemas.openxmlformats.org/officeDocument/2006/relationships" r:id="Rf0fa3ac9ceeb4afe"/>
   </p:notesMasterIdLst>
   <p:sldIdLst>
-    <p:sldId xmlns:r="http://schemas.openxmlformats.org/officeDocument/2006/relationships" id="256" r:id="Re681d2b403b3464a"/>
-    <p:sldId xmlns:r="http://schemas.openxmlformats.org/officeDocument/2006/relationships" id="257" r:id="Rc07d67d5fef74b40"/>
-    <p:sldId xmlns:r="http://schemas.openxmlformats.org/officeDocument/2006/relationships" id="258" r:id="Rcd77fb081b1a401d"/>
-    <p:sldId xmlns:r="http://schemas.openxmlformats.org/officeDocument/2006/relationships" id="259" r:id="R485d0b7a69f1432d"/>
-    <p:sldId xmlns:r="http://schemas.openxmlformats.org/officeDocument/2006/relationships" id="260" r:id="Ra079b6859af24470"/>
-    <p:sldId xmlns:r="http://schemas.openxmlformats.org/officeDocument/2006/relationships" id="261" r:id="Rec16b7d7e41240fc"/>
-    <p:sldId xmlns:r="http://schemas.openxmlformats.org/officeDocument/2006/relationships" id="262" r:id="R96abf2e542b047b3"/>
-    <p:sldId xmlns:r="http://schemas.openxmlformats.org/officeDocument/2006/relationships" id="263" r:id="R105afa8d48a04e91"/>
+    <p:sldId xmlns:r="http://schemas.openxmlformats.org/officeDocument/2006/relationships" id="256" r:id="R10ef20effa594051"/>
+    <p:sldId xmlns:r="http://schemas.openxmlformats.org/officeDocument/2006/relationships" id="257" r:id="R6c2fde68b26b48d8"/>
+    <p:sldId xmlns:r="http://schemas.openxmlformats.org/officeDocument/2006/relationships" id="258" r:id="R092801c1f0a04b6e"/>
+    <p:sldId xmlns:r="http://schemas.openxmlformats.org/officeDocument/2006/relationships" id="259" r:id="R2a3f448794ec4f94"/>
+    <p:sldId xmlns:r="http://schemas.openxmlformats.org/officeDocument/2006/relationships" id="260" r:id="R5b7c2818777c4831"/>
+    <p:sldId xmlns:r="http://schemas.openxmlformats.org/officeDocument/2006/relationships" id="261" r:id="Rdac0c677f3ed461c"/>
+    <p:sldId xmlns:r="http://schemas.openxmlformats.org/officeDocument/2006/relationships" id="262" r:id="Rfabaf83fd2af4e2a"/>
+    <p:sldId xmlns:r="http://schemas.openxmlformats.org/officeDocument/2006/relationships" id="263" r:id="Rcc22fe7ae3564156"/>
   </p:sldIdLst>
   <p:sldSz cx="12192000" cy="6858000"/>
   <p:notesSz cx="6858000" cy="9144000"/>
@@ -939,7 +939,7 @@
           <a:lstStyle xmlns:a="http://schemas.openxmlformats.org/drawingml/2006/main"/>
           <a:p xmlns:a="http://schemas.openxmlformats.org/drawingml/2006/main">
             <a:r>
-              <a:t>Creator: Shivam Gupta. Public MIT main repository: https://github.com/shi1720/Amazon-Developer-Hackathon. Firebase application: https://kindhandoff.web.app. Public workflow verification is documented in the repository evidence. Public English captioned demo: https://youtu.be/t7e00FzIk2M . Signed-out playback and the public transcript were verified by the implementation lead. The additional Open Source contribution is @kindhandoff/guard, public and MIT licensed: https://github.com/shi1720/kindhandoff-guard. Contribution: https://github.com/shi1720/kindhandoff-guard/commit/04a15ea016e552e3c031b9ec371af2df6a1de105. The library covers state transitions, coverage accounting, and candidate ranking. App code owns dependency readiness, exact identity authorization, and content-version acknowledgments. Next steps include household research and live Alexa+ onboarding where access permits. The Devpost project remains a draft, not submitted.</a:t>
+              <a:t>Creator: Shivam Gupta. Public MIT main repository: https://github.com/shi1720/Amazon-Developer-Hackathon. Firebase application: https://kindhandoff.web.app. Public workflow verification is documented in the repository evidence. Public English captioned demo: https://youtu.be/t7e00FzIk2M . Signed-out playback and the public transcript were verified by the implementation lead. The additional Open Source contribution is @kindhandoff/guard, public and MIT licensed: https://github.com/shi1720/kindhandoff-guard. Contribution: https://github.com/shi1720/kindhandoff-guard/commit/04a15ea016e552e3c031b9ec371af2df6a1de105. The library covers state transitions, coverage accounting, and candidate ranking. App code owns dependency readiness, exact identity authorization, and content-version acknowledgments. Next steps include household research and live Alexa+ onboarding where access permits. The Devpost entry was submitted to the Build, Ship, Shape: Amazon Developer Hackathon; confirmation was verified on 16 September 2026.</a:t>
             </a:r>
           </a:p>
         </p:txBody>
@@ -1007,7 +1007,7 @@
   </p:cSld>
   <p:clrMap bg1="lt1" tx1="dk1" bg2="lt2" tx2="dk2" accent1="accent1" accent2="accent2" accent3="accent3" accent4="accent4" accent5="accent5" accent6="accent6" hlink="hlink" folHlink="folHlink"/>
   <p:sldLayoutIdLst>
-    <p:sldLayoutId xmlns:r="http://schemas.openxmlformats.org/officeDocument/2006/relationships" id="2147483649" r:id="R5c04550d38be42ae"/>
+    <p:sldLayoutId xmlns:r="http://schemas.openxmlformats.org/officeDocument/2006/relationships" id="2147483649" r:id="Rb50a34cb914f48ff"/>
   </p:sldLayoutIdLst>
   <p:txStyles>
     <p:titleStyle>
@@ -1558,7 +1558,7 @@
           <p:cNvPr id="15" name="wordmark">
             <a:extLst xmlns:a="http://schemas.openxmlformats.org/drawingml/2006/main">
               <a:ext uri="{FF2B5EF4-FFF2-40B4-BE49-F238E27FC236}">
-                <a16:creationId xmlns:a16="http://schemas.microsoft.com/office/drawing/2014/main" id="{6C1214D0-EF66-4263-8647-E827702EE382}"/>
+                <a16:creationId xmlns:a16="http://schemas.microsoft.com/office/drawing/2014/main" id="{DB8696B9-7030-42BB-8FFB-F711A4D3104B}"/>
               </a:ext>
             </a:extLst>
           </p:cNvPr>
@@ -1615,7 +1615,7 @@
           <p:cNvPr id="2" name="page">
             <a:extLst xmlns:a="http://schemas.openxmlformats.org/drawingml/2006/main">
               <a:ext uri="{FF2B5EF4-FFF2-40B4-BE49-F238E27FC236}">
-                <a16:creationId xmlns:a16="http://schemas.microsoft.com/office/drawing/2014/main" id="{42170147-A523-4DEA-A9C7-5D6DEC2201AC}"/>
+                <a16:creationId xmlns:a16="http://schemas.microsoft.com/office/drawing/2014/main" id="{C50AB564-75B5-44FB-B717-D9C7DBB576F0}"/>
               </a:ext>
             </a:extLst>
           </p:cNvPr>
@@ -1672,7 +1672,7 @@
           <p:cNvPr id="3" name="cover-title">
             <a:extLst xmlns:a="http://schemas.openxmlformats.org/drawingml/2006/main">
               <a:ext uri="{FF2B5EF4-FFF2-40B4-BE49-F238E27FC236}">
-                <a16:creationId xmlns:a16="http://schemas.microsoft.com/office/drawing/2014/main" id="{4E253170-0644-47C3-9EB5-0E6A85AB387C}"/>
+                <a16:creationId xmlns:a16="http://schemas.microsoft.com/office/drawing/2014/main" id="{243C496B-2CA3-47E9-BABF-44D230EE774D}"/>
               </a:ext>
             </a:extLst>
           </p:cNvPr>
@@ -1752,7 +1752,7 @@
           <p:cNvPr id="4" name="cover-problem">
             <a:extLst xmlns:a="http://schemas.openxmlformats.org/drawingml/2006/main">
               <a:ext uri="{FF2B5EF4-FFF2-40B4-BE49-F238E27FC236}">
-                <a16:creationId xmlns:a16="http://schemas.microsoft.com/office/drawing/2014/main" id="{984B8A4E-F56E-4356-AEF2-71E545268518}"/>
+                <a16:creationId xmlns:a16="http://schemas.microsoft.com/office/drawing/2014/main" id="{828126FC-417F-42DD-ABE3-58313FFBE8C3}"/>
               </a:ext>
             </a:extLst>
           </p:cNvPr>
@@ -1832,7 +1832,7 @@
           <p:cNvPr id="5" name="creator">
             <a:extLst xmlns:a="http://schemas.openxmlformats.org/drawingml/2006/main">
               <a:ext uri="{FF2B5EF4-FFF2-40B4-BE49-F238E27FC236}">
-                <a16:creationId xmlns:a16="http://schemas.microsoft.com/office/drawing/2014/main" id="{2EC0DA58-2196-4E56-9465-ED35D8259E64}"/>
+                <a16:creationId xmlns:a16="http://schemas.microsoft.com/office/drawing/2014/main" id="{A6A0AB97-51CA-4F07-A43A-DE862EA77448}"/>
               </a:ext>
             </a:extLst>
           </p:cNvPr>
@@ -1889,7 +1889,7 @@
           <p:cNvPr id="6" name="bag-node">
             <a:extLst xmlns:a="http://schemas.openxmlformats.org/drawingml/2006/main">
               <a:ext uri="{FF2B5EF4-FFF2-40B4-BE49-F238E27FC236}">
-                <a16:creationId xmlns:a16="http://schemas.microsoft.com/office/drawing/2014/main" id="{B2E66E14-39A6-4B80-9F15-A84C4FBF6AF4}"/>
+                <a16:creationId xmlns:a16="http://schemas.microsoft.com/office/drawing/2014/main" id="{7664F5FE-6253-420B-9BE9-4492B89B9F99}"/>
               </a:ext>
             </a:extLst>
           </p:cNvPr>
@@ -1920,7 +1920,7 @@
           <p:cNvPr id="7" name="bag-time">
             <a:extLst xmlns:a="http://schemas.openxmlformats.org/drawingml/2006/main">
               <a:ext uri="{FF2B5EF4-FFF2-40B4-BE49-F238E27FC236}">
-                <a16:creationId xmlns:a16="http://schemas.microsoft.com/office/drawing/2014/main" id="{DC98B147-4135-40F5-8B8F-57F7C4F0BD50}"/>
+                <a16:creationId xmlns:a16="http://schemas.microsoft.com/office/drawing/2014/main" id="{EBE14F0A-EEDD-4226-943D-22F28525BBAC}"/>
               </a:ext>
             </a:extLst>
           </p:cNvPr>
@@ -1977,7 +1977,7 @@
           <p:cNvPr id="8" name="bag-task">
             <a:extLst xmlns:a="http://schemas.openxmlformats.org/drawingml/2006/main">
               <a:ext uri="{FF2B5EF4-FFF2-40B4-BE49-F238E27FC236}">
-                <a16:creationId xmlns:a16="http://schemas.microsoft.com/office/drawing/2014/main" id="{C14DA6AF-D6CD-414C-B85C-47225F357413}"/>
+                <a16:creationId xmlns:a16="http://schemas.microsoft.com/office/drawing/2014/main" id="{D27B4E34-E386-4CD7-88E4-83B3DBE3A8F7}"/>
               </a:ext>
             </a:extLst>
           </p:cNvPr>
@@ -2034,7 +2034,7 @@
           <p:cNvPr id="9" name="ride-node">
             <a:extLst xmlns:a="http://schemas.openxmlformats.org/drawingml/2006/main">
               <a:ext uri="{FF2B5EF4-FFF2-40B4-BE49-F238E27FC236}">
-                <a16:creationId xmlns:a16="http://schemas.microsoft.com/office/drawing/2014/main" id="{46BFDB56-AC48-4759-A5C4-071750FB6AB3}"/>
+                <a16:creationId xmlns:a16="http://schemas.microsoft.com/office/drawing/2014/main" id="{C29ACC6E-70B9-47ED-8BE6-6145C3252110}"/>
               </a:ext>
             </a:extLst>
           </p:cNvPr>
@@ -2065,7 +2065,7 @@
           <p:cNvPr id="10" name="ride-time">
             <a:extLst xmlns:a="http://schemas.openxmlformats.org/drawingml/2006/main">
               <a:ext uri="{FF2B5EF4-FFF2-40B4-BE49-F238E27FC236}">
-                <a16:creationId xmlns:a16="http://schemas.microsoft.com/office/drawing/2014/main" id="{AF9C4B6E-EC44-4BC1-BB00-48A4D59E4F7A}"/>
+                <a16:creationId xmlns:a16="http://schemas.microsoft.com/office/drawing/2014/main" id="{3EC7C663-A04C-4F3B-A321-43AF8DF9486C}"/>
               </a:ext>
             </a:extLst>
           </p:cNvPr>
@@ -2122,7 +2122,7 @@
           <p:cNvPr id="11" name="ride-task">
             <a:extLst xmlns:a="http://schemas.openxmlformats.org/drawingml/2006/main">
               <a:ext uri="{FF2B5EF4-FFF2-40B4-BE49-F238E27FC236}">
-                <a16:creationId xmlns:a16="http://schemas.microsoft.com/office/drawing/2014/main" id="{E737B459-0ED4-467F-8728-A343F870EF07}"/>
+                <a16:creationId xmlns:a16="http://schemas.microsoft.com/office/drawing/2014/main" id="{56CF6B8C-CDD7-4EB2-AF6E-C2DE75399482}"/>
               </a:ext>
             </a:extLst>
           </p:cNvPr>
@@ -2205,7 +2205,7 @@
           <p:cNvPr id="13" name="prerequisite-label">
             <a:extLst xmlns:a="http://schemas.openxmlformats.org/drawingml/2006/main">
               <a:ext uri="{FF2B5EF4-FFF2-40B4-BE49-F238E27FC236}">
-                <a16:creationId xmlns:a16="http://schemas.microsoft.com/office/drawing/2014/main" id="{E0296D0A-69A3-4B17-9839-6E4E31937ADC}"/>
+                <a16:creationId xmlns:a16="http://schemas.microsoft.com/office/drawing/2014/main" id="{360EA430-A3B5-41E5-BE0E-69F9DB878DBB}"/>
               </a:ext>
             </a:extLst>
           </p:cNvPr>
@@ -2262,7 +2262,7 @@
           <p:cNvPr id="14" name="footer">
             <a:extLst xmlns:a="http://schemas.openxmlformats.org/drawingml/2006/main">
               <a:ext uri="{FF2B5EF4-FFF2-40B4-BE49-F238E27FC236}">
-                <a16:creationId xmlns:a16="http://schemas.microsoft.com/office/drawing/2014/main" id="{EE439423-B127-4B8A-8270-C8C9EAB18AB9}"/>
+                <a16:creationId xmlns:a16="http://schemas.microsoft.com/office/drawing/2014/main" id="{5AB82969-A656-497F-9262-A3E4A60E6556}"/>
               </a:ext>
             </a:extLst>
           </p:cNvPr>
@@ -2317,7 +2317,7 @@
     </p:spTree>
     <p:extLst>
       <p:ext uri="{BB962C8B-B14F-4D97-AF65-F5344CB8AC3E}">
-        <p14:creationId xmlns:p14="http://schemas.microsoft.com/office/powerpoint/2010/main" val="2035614859"/>
+        <p14:creationId xmlns:p14="http://schemas.microsoft.com/office/powerpoint/2010/main" val="778569628"/>
       </p:ext>
     </p:extLst>
   </p:cSld>
@@ -2348,7 +2348,7 @@
           <p:cNvPr id="7" name="wordmark">
             <a:extLst xmlns:a="http://schemas.openxmlformats.org/drawingml/2006/main">
               <a:ext uri="{FF2B5EF4-FFF2-40B4-BE49-F238E27FC236}">
-                <a16:creationId xmlns:a16="http://schemas.microsoft.com/office/drawing/2014/main" id="{AD7B69FB-3856-498E-8D8E-C7C576B0AA60}"/>
+                <a16:creationId xmlns:a16="http://schemas.microsoft.com/office/drawing/2014/main" id="{C2E37259-7714-4EE0-88A9-2EB5A9ED9DD5}"/>
               </a:ext>
             </a:extLst>
           </p:cNvPr>
@@ -2405,7 +2405,7 @@
           <p:cNvPr id="2" name="page">
             <a:extLst xmlns:a="http://schemas.openxmlformats.org/drawingml/2006/main">
               <a:ext uri="{FF2B5EF4-FFF2-40B4-BE49-F238E27FC236}">
-                <a16:creationId xmlns:a16="http://schemas.microsoft.com/office/drawing/2014/main" id="{83634013-51FA-4910-883F-3C82374573CA}"/>
+                <a16:creationId xmlns:a16="http://schemas.microsoft.com/office/drawing/2014/main" id="{F87FD237-868A-40DB-9766-92956D64A760}"/>
               </a:ext>
             </a:extLst>
           </p:cNvPr>
@@ -2462,7 +2462,7 @@
           <p:cNvPr id="3" name="title">
             <a:extLst xmlns:a="http://schemas.openxmlformats.org/drawingml/2006/main">
               <a:ext uri="{FF2B5EF4-FFF2-40B4-BE49-F238E27FC236}">
-                <a16:creationId xmlns:a16="http://schemas.microsoft.com/office/drawing/2014/main" id="{B566CCDF-B344-4102-ADAE-6EA357E5B063}"/>
+                <a16:creationId xmlns:a16="http://schemas.microsoft.com/office/drawing/2014/main" id="{2AC1F065-4ECD-4F87-8878-E7E9943A2D29}"/>
               </a:ext>
             </a:extLst>
           </p:cNvPr>
@@ -2519,7 +2519,7 @@
           <p:cNvPr id="4" name="subtitle">
             <a:extLst xmlns:a="http://schemas.openxmlformats.org/drawingml/2006/main">
               <a:ext uri="{FF2B5EF4-FFF2-40B4-BE49-F238E27FC236}">
-                <a16:creationId xmlns:a16="http://schemas.microsoft.com/office/drawing/2014/main" id="{531C0528-69A2-477E-8B2C-198C809EF14C}"/>
+                <a16:creationId xmlns:a16="http://schemas.microsoft.com/office/drawing/2014/main" id="{EB6A8F69-017E-4DA8-AEA4-BE3207986D55}"/>
               </a:ext>
             </a:extLst>
           </p:cNvPr>
@@ -2945,7 +2945,7 @@
           <p:cNvPr id="6" name="footer">
             <a:extLst xmlns:a="http://schemas.openxmlformats.org/drawingml/2006/main">
               <a:ext uri="{FF2B5EF4-FFF2-40B4-BE49-F238E27FC236}">
-                <a16:creationId xmlns:a16="http://schemas.microsoft.com/office/drawing/2014/main" id="{FD14DE01-5D6E-4BA8-96EE-E4A89EEC55A2}"/>
+                <a16:creationId xmlns:a16="http://schemas.microsoft.com/office/drawing/2014/main" id="{D194F151-E3C8-43BE-9DD0-A6F25EF32E2A}"/>
               </a:ext>
             </a:extLst>
           </p:cNvPr>
@@ -3000,7 +3000,7 @@
     </p:spTree>
     <p:extLst>
       <p:ext uri="{BB962C8B-B14F-4D97-AF65-F5344CB8AC3E}">
-        <p14:creationId xmlns:p14="http://schemas.microsoft.com/office/powerpoint/2010/main" val="725860867"/>
+        <p14:creationId xmlns:p14="http://schemas.microsoft.com/office/powerpoint/2010/main" val="1917082132"/>
       </p:ext>
     </p:extLst>
   </p:cSld>
@@ -3031,7 +3031,7 @@
           <p:cNvPr id="26" name="wordmark">
             <a:extLst xmlns:a="http://schemas.openxmlformats.org/drawingml/2006/main">
               <a:ext uri="{FF2B5EF4-FFF2-40B4-BE49-F238E27FC236}">
-                <a16:creationId xmlns:a16="http://schemas.microsoft.com/office/drawing/2014/main" id="{84DDAD64-8F57-4A02-BCD5-98ABAA40DDC6}"/>
+                <a16:creationId xmlns:a16="http://schemas.microsoft.com/office/drawing/2014/main" id="{F6D46674-CF06-4362-BD44-49DF87EA5FCF}"/>
               </a:ext>
             </a:extLst>
           </p:cNvPr>
@@ -3088,7 +3088,7 @@
           <p:cNvPr id="2" name="page">
             <a:extLst xmlns:a="http://schemas.openxmlformats.org/drawingml/2006/main">
               <a:ext uri="{FF2B5EF4-FFF2-40B4-BE49-F238E27FC236}">
-                <a16:creationId xmlns:a16="http://schemas.microsoft.com/office/drawing/2014/main" id="{91DD01B2-F775-46A5-9635-B2EB33FDA006}"/>
+                <a16:creationId xmlns:a16="http://schemas.microsoft.com/office/drawing/2014/main" id="{5E9239CC-9CA7-4D0C-A050-3241F95BCE9F}"/>
               </a:ext>
             </a:extLst>
           </p:cNvPr>
@@ -3145,7 +3145,7 @@
           <p:cNvPr id="3" name="title">
             <a:extLst xmlns:a="http://schemas.openxmlformats.org/drawingml/2006/main">
               <a:ext uri="{FF2B5EF4-FFF2-40B4-BE49-F238E27FC236}">
-                <a16:creationId xmlns:a16="http://schemas.microsoft.com/office/drawing/2014/main" id="{7A68739A-F21C-4294-B705-76D5B58F7AB6}"/>
+                <a16:creationId xmlns:a16="http://schemas.microsoft.com/office/drawing/2014/main" id="{C260F3F7-3B6F-4EB2-BB9F-69CCEE54BAEC}"/>
               </a:ext>
             </a:extLst>
           </p:cNvPr>
@@ -3202,7 +3202,7 @@
           <p:cNvPr id="4" name="subtitle">
             <a:extLst xmlns:a="http://schemas.openxmlformats.org/drawingml/2006/main">
               <a:ext uri="{FF2B5EF4-FFF2-40B4-BE49-F238E27FC236}">
-                <a16:creationId xmlns:a16="http://schemas.microsoft.com/office/drawing/2014/main" id="{AAE2165A-66FC-4EB3-B405-1919021C4BE5}"/>
+                <a16:creationId xmlns:a16="http://schemas.microsoft.com/office/drawing/2014/main" id="{6285FE44-1EB3-4D19-B0E0-31D8487274BA}"/>
               </a:ext>
             </a:extLst>
           </p:cNvPr>
@@ -3259,7 +3259,7 @@
           <p:cNvPr id="5" name="state-0">
             <a:extLst xmlns:a="http://schemas.openxmlformats.org/drawingml/2006/main">
               <a:ext uri="{FF2B5EF4-FFF2-40B4-BE49-F238E27FC236}">
-                <a16:creationId xmlns:a16="http://schemas.microsoft.com/office/drawing/2014/main" id="{41007E19-F7FD-40E0-830B-5BFFA610FCE0}"/>
+                <a16:creationId xmlns:a16="http://schemas.microsoft.com/office/drawing/2014/main" id="{411D68B9-5375-46F6-BCC8-3828ABC0C311}"/>
               </a:ext>
             </a:extLst>
           </p:cNvPr>
@@ -3290,7 +3290,7 @@
           <p:cNvPr id="6" name="step-0">
             <a:extLst xmlns:a="http://schemas.openxmlformats.org/drawingml/2006/main">
               <a:ext uri="{FF2B5EF4-FFF2-40B4-BE49-F238E27FC236}">
-                <a16:creationId xmlns:a16="http://schemas.microsoft.com/office/drawing/2014/main" id="{CA57AECB-AAE4-4D9C-8220-3F9F83370DBD}"/>
+                <a16:creationId xmlns:a16="http://schemas.microsoft.com/office/drawing/2014/main" id="{B45D8D78-4FEE-42F2-AD72-74D7304444BA}"/>
               </a:ext>
             </a:extLst>
           </p:cNvPr>
@@ -3347,7 +3347,7 @@
           <p:cNvPr id="7" name="state-name-0">
             <a:extLst xmlns:a="http://schemas.openxmlformats.org/drawingml/2006/main">
               <a:ext uri="{FF2B5EF4-FFF2-40B4-BE49-F238E27FC236}">
-                <a16:creationId xmlns:a16="http://schemas.microsoft.com/office/drawing/2014/main" id="{EB35BBB4-D740-4964-A59E-8266B10FC444}"/>
+                <a16:creationId xmlns:a16="http://schemas.microsoft.com/office/drawing/2014/main" id="{478986CE-A4AC-4E4D-97B5-47E7723C2BE6}"/>
               </a:ext>
             </a:extLst>
           </p:cNvPr>
@@ -3404,7 +3404,7 @@
           <p:cNvPr id="8" name="state-detail-0">
             <a:extLst xmlns:a="http://schemas.openxmlformats.org/drawingml/2006/main">
               <a:ext uri="{FF2B5EF4-FFF2-40B4-BE49-F238E27FC236}">
-                <a16:creationId xmlns:a16="http://schemas.microsoft.com/office/drawing/2014/main" id="{BB62EDB4-F920-410A-8FEE-F40064D08BBC}"/>
+                <a16:creationId xmlns:a16="http://schemas.microsoft.com/office/drawing/2014/main" id="{B79CD9E6-7D58-4C5B-B02A-81C375B1B495}"/>
               </a:ext>
             </a:extLst>
           </p:cNvPr>
@@ -3461,7 +3461,7 @@
           <p:cNvPr id="9" name="state-1">
             <a:extLst xmlns:a="http://schemas.openxmlformats.org/drawingml/2006/main">
               <a:ext uri="{FF2B5EF4-FFF2-40B4-BE49-F238E27FC236}">
-                <a16:creationId xmlns:a16="http://schemas.microsoft.com/office/drawing/2014/main" id="{FEBA964A-F4CB-4618-BAA9-86BAA6AD1D97}"/>
+                <a16:creationId xmlns:a16="http://schemas.microsoft.com/office/drawing/2014/main" id="{3A1440DD-2F38-4A07-A62A-07E3CA01DE3B}"/>
               </a:ext>
             </a:extLst>
           </p:cNvPr>
@@ -3492,7 +3492,7 @@
           <p:cNvPr id="10" name="step-1">
             <a:extLst xmlns:a="http://schemas.openxmlformats.org/drawingml/2006/main">
               <a:ext uri="{FF2B5EF4-FFF2-40B4-BE49-F238E27FC236}">
-                <a16:creationId xmlns:a16="http://schemas.microsoft.com/office/drawing/2014/main" id="{67A162AB-D7AB-4786-AB72-A37AB735B8CF}"/>
+                <a16:creationId xmlns:a16="http://schemas.microsoft.com/office/drawing/2014/main" id="{CA69D3F6-3B4E-45A0-A5C1-0DFE2B877F06}"/>
               </a:ext>
             </a:extLst>
           </p:cNvPr>
@@ -3549,7 +3549,7 @@
           <p:cNvPr id="11" name="state-name-1">
             <a:extLst xmlns:a="http://schemas.openxmlformats.org/drawingml/2006/main">
               <a:ext uri="{FF2B5EF4-FFF2-40B4-BE49-F238E27FC236}">
-                <a16:creationId xmlns:a16="http://schemas.microsoft.com/office/drawing/2014/main" id="{D1865057-9DE0-48FC-A9F6-137FBC53C94B}"/>
+                <a16:creationId xmlns:a16="http://schemas.microsoft.com/office/drawing/2014/main" id="{BFAE7095-BA76-4CE3-BE58-BD9D70E64BC9}"/>
               </a:ext>
             </a:extLst>
           </p:cNvPr>
@@ -3606,7 +3606,7 @@
           <p:cNvPr id="12" name="state-detail-1">
             <a:extLst xmlns:a="http://schemas.openxmlformats.org/drawingml/2006/main">
               <a:ext uri="{FF2B5EF4-FFF2-40B4-BE49-F238E27FC236}">
-                <a16:creationId xmlns:a16="http://schemas.microsoft.com/office/drawing/2014/main" id="{AA6D69A0-575C-485D-9058-1A53933B436C}"/>
+                <a16:creationId xmlns:a16="http://schemas.microsoft.com/office/drawing/2014/main" id="{CDF9F1BF-3C34-49A2-B443-FB7FC37B3EA9}"/>
               </a:ext>
             </a:extLst>
           </p:cNvPr>
@@ -3663,7 +3663,7 @@
           <p:cNvPr id="13" name="state-2">
             <a:extLst xmlns:a="http://schemas.openxmlformats.org/drawingml/2006/main">
               <a:ext uri="{FF2B5EF4-FFF2-40B4-BE49-F238E27FC236}">
-                <a16:creationId xmlns:a16="http://schemas.microsoft.com/office/drawing/2014/main" id="{87568A39-E17A-4D8A-A1FE-B9B4E13575E3}"/>
+                <a16:creationId xmlns:a16="http://schemas.microsoft.com/office/drawing/2014/main" id="{02294D45-6DFA-47A5-AAC3-4A3F1777DF65}"/>
               </a:ext>
             </a:extLst>
           </p:cNvPr>
@@ -3694,7 +3694,7 @@
           <p:cNvPr id="14" name="step-2">
             <a:extLst xmlns:a="http://schemas.openxmlformats.org/drawingml/2006/main">
               <a:ext uri="{FF2B5EF4-FFF2-40B4-BE49-F238E27FC236}">
-                <a16:creationId xmlns:a16="http://schemas.microsoft.com/office/drawing/2014/main" id="{2A84BD49-97A7-4D55-B4CB-319BC3D8B4C9}"/>
+                <a16:creationId xmlns:a16="http://schemas.microsoft.com/office/drawing/2014/main" id="{5E08332E-E07C-46D9-A8DD-0497112932D3}"/>
               </a:ext>
             </a:extLst>
           </p:cNvPr>
@@ -3751,7 +3751,7 @@
           <p:cNvPr id="15" name="state-name-2">
             <a:extLst xmlns:a="http://schemas.openxmlformats.org/drawingml/2006/main">
               <a:ext uri="{FF2B5EF4-FFF2-40B4-BE49-F238E27FC236}">
-                <a16:creationId xmlns:a16="http://schemas.microsoft.com/office/drawing/2014/main" id="{D2BD80B3-6779-48E5-BE07-054FF4E9621C}"/>
+                <a16:creationId xmlns:a16="http://schemas.microsoft.com/office/drawing/2014/main" id="{6B11F588-E51E-4576-B62B-5AF11C2677C0}"/>
               </a:ext>
             </a:extLst>
           </p:cNvPr>
@@ -3808,7 +3808,7 @@
           <p:cNvPr id="16" name="state-detail-2">
             <a:extLst xmlns:a="http://schemas.openxmlformats.org/drawingml/2006/main">
               <a:ext uri="{FF2B5EF4-FFF2-40B4-BE49-F238E27FC236}">
-                <a16:creationId xmlns:a16="http://schemas.microsoft.com/office/drawing/2014/main" id="{EB40F648-C097-4FA0-9513-E7305FA7ABE7}"/>
+                <a16:creationId xmlns:a16="http://schemas.microsoft.com/office/drawing/2014/main" id="{4E20FC88-283D-4CA1-A721-A3DBC7403FC6}"/>
               </a:ext>
             </a:extLst>
           </p:cNvPr>
@@ -3865,7 +3865,7 @@
           <p:cNvPr id="17" name="state-3">
             <a:extLst xmlns:a="http://schemas.openxmlformats.org/drawingml/2006/main">
               <a:ext uri="{FF2B5EF4-FFF2-40B4-BE49-F238E27FC236}">
-                <a16:creationId xmlns:a16="http://schemas.microsoft.com/office/drawing/2014/main" id="{70657936-F82F-456A-9463-62618DD79219}"/>
+                <a16:creationId xmlns:a16="http://schemas.microsoft.com/office/drawing/2014/main" id="{6AC7410F-A354-4789-B7BE-ABC14ACDC58C}"/>
               </a:ext>
             </a:extLst>
           </p:cNvPr>
@@ -3898,7 +3898,7 @@
           <p:cNvPr id="18" name="step-3">
             <a:extLst xmlns:a="http://schemas.openxmlformats.org/drawingml/2006/main">
               <a:ext uri="{FF2B5EF4-FFF2-40B4-BE49-F238E27FC236}">
-                <a16:creationId xmlns:a16="http://schemas.microsoft.com/office/drawing/2014/main" id="{285E41A2-AC47-4324-BA26-55B802782DE4}"/>
+                <a16:creationId xmlns:a16="http://schemas.microsoft.com/office/drawing/2014/main" id="{A0DC2FEB-78DF-4BFC-94A2-3769D61DBDC0}"/>
               </a:ext>
             </a:extLst>
           </p:cNvPr>
@@ -3955,7 +3955,7 @@
           <p:cNvPr id="19" name="state-name-3">
             <a:extLst xmlns:a="http://schemas.openxmlformats.org/drawingml/2006/main">
               <a:ext uri="{FF2B5EF4-FFF2-40B4-BE49-F238E27FC236}">
-                <a16:creationId xmlns:a16="http://schemas.microsoft.com/office/drawing/2014/main" id="{2B7A2CB1-C6A1-49F1-8B57-55D85756D314}"/>
+                <a16:creationId xmlns:a16="http://schemas.microsoft.com/office/drawing/2014/main" id="{56F2043C-EC72-48DE-8022-88C149845854}"/>
               </a:ext>
             </a:extLst>
           </p:cNvPr>
@@ -4012,7 +4012,7 @@
           <p:cNvPr id="20" name="state-detail-3">
             <a:extLst xmlns:a="http://schemas.openxmlformats.org/drawingml/2006/main">
               <a:ext uri="{FF2B5EF4-FFF2-40B4-BE49-F238E27FC236}">
-                <a16:creationId xmlns:a16="http://schemas.microsoft.com/office/drawing/2014/main" id="{1572031C-1C6C-4281-A286-0071A324BB6F}"/>
+                <a16:creationId xmlns:a16="http://schemas.microsoft.com/office/drawing/2014/main" id="{001FF84E-7AE6-47F6-ABF7-95D81E48EC68}"/>
               </a:ext>
             </a:extLst>
           </p:cNvPr>
@@ -4147,7 +4147,7 @@
           <p:cNvPr id="24" name="waiting-note">
             <a:extLst xmlns:a="http://schemas.openxmlformats.org/drawingml/2006/main">
               <a:ext uri="{FF2B5EF4-FFF2-40B4-BE49-F238E27FC236}">
-                <a16:creationId xmlns:a16="http://schemas.microsoft.com/office/drawing/2014/main" id="{F9EB8600-BD21-4C8F-A3D7-D49FEA70B672}"/>
+                <a16:creationId xmlns:a16="http://schemas.microsoft.com/office/drawing/2014/main" id="{912524A8-7050-4277-8B15-16ADF23AA791}"/>
               </a:ext>
             </a:extLst>
           </p:cNvPr>
@@ -4204,7 +4204,7 @@
           <p:cNvPr id="25" name="footer">
             <a:extLst xmlns:a="http://schemas.openxmlformats.org/drawingml/2006/main">
               <a:ext uri="{FF2B5EF4-FFF2-40B4-BE49-F238E27FC236}">
-                <a16:creationId xmlns:a16="http://schemas.microsoft.com/office/drawing/2014/main" id="{2CB99D7E-ADAC-4FCD-8D1C-482CDE90E945}"/>
+                <a16:creationId xmlns:a16="http://schemas.microsoft.com/office/drawing/2014/main" id="{ADCC2FAF-5746-432D-BE12-BB21AD7BD171}"/>
               </a:ext>
             </a:extLst>
           </p:cNvPr>
@@ -4259,7 +4259,7 @@
     </p:spTree>
     <p:extLst>
       <p:ext uri="{BB962C8B-B14F-4D97-AF65-F5344CB8AC3E}">
-        <p14:creationId xmlns:p14="http://schemas.microsoft.com/office/powerpoint/2010/main" val="2048311375"/>
+        <p14:creationId xmlns:p14="http://schemas.microsoft.com/office/powerpoint/2010/main" val="853854941"/>
       </p:ext>
     </p:extLst>
   </p:cSld>
@@ -4290,7 +4290,7 @@
           <p:cNvPr id="26" name="wordmark">
             <a:extLst xmlns:a="http://schemas.openxmlformats.org/drawingml/2006/main">
               <a:ext uri="{FF2B5EF4-FFF2-40B4-BE49-F238E27FC236}">
-                <a16:creationId xmlns:a16="http://schemas.microsoft.com/office/drawing/2014/main" id="{F8B238FB-5076-4342-ACC9-CD4575CC651C}"/>
+                <a16:creationId xmlns:a16="http://schemas.microsoft.com/office/drawing/2014/main" id="{17AF78C5-CE6A-4B89-9ECC-6B30E6108011}"/>
               </a:ext>
             </a:extLst>
           </p:cNvPr>
@@ -4347,7 +4347,7 @@
           <p:cNvPr id="2" name="page">
             <a:extLst xmlns:a="http://schemas.openxmlformats.org/drawingml/2006/main">
               <a:ext uri="{FF2B5EF4-FFF2-40B4-BE49-F238E27FC236}">
-                <a16:creationId xmlns:a16="http://schemas.microsoft.com/office/drawing/2014/main" id="{9D321146-3D95-45BB-A02D-03B4D213411C}"/>
+                <a16:creationId xmlns:a16="http://schemas.microsoft.com/office/drawing/2014/main" id="{D1885DEC-05B2-4EA3-B0D4-F5D3B9FE096C}"/>
               </a:ext>
             </a:extLst>
           </p:cNvPr>
@@ -4404,7 +4404,7 @@
           <p:cNvPr id="3" name="title">
             <a:extLst xmlns:a="http://schemas.openxmlformats.org/drawingml/2006/main">
               <a:ext uri="{FF2B5EF4-FFF2-40B4-BE49-F238E27FC236}">
-                <a16:creationId xmlns:a16="http://schemas.microsoft.com/office/drawing/2014/main" id="{29B837B8-8B84-42E2-8166-E9220F70958B}"/>
+                <a16:creationId xmlns:a16="http://schemas.microsoft.com/office/drawing/2014/main" id="{AD027AAF-C8A8-42A8-BCBE-FD3B23FD6244}"/>
               </a:ext>
             </a:extLst>
           </p:cNvPr>
@@ -4461,7 +4461,7 @@
           <p:cNvPr id="4" name="subtitle">
             <a:extLst xmlns:a="http://schemas.openxmlformats.org/drawingml/2006/main">
               <a:ext uri="{FF2B5EF4-FFF2-40B4-BE49-F238E27FC236}">
-                <a16:creationId xmlns:a16="http://schemas.microsoft.com/office/drawing/2014/main" id="{6B4BCBCB-77C8-405C-8CF8-3B9E671C3C8B}"/>
+                <a16:creationId xmlns:a16="http://schemas.microsoft.com/office/drawing/2014/main" id="{4C651BEB-453A-4938-B54B-979502C23112}"/>
               </a:ext>
             </a:extLst>
           </p:cNvPr>
@@ -4518,7 +4518,7 @@
           <p:cNvPr id="5" name="architecture-title-0">
             <a:extLst xmlns:a="http://schemas.openxmlformats.org/drawingml/2006/main">
               <a:ext uri="{FF2B5EF4-FFF2-40B4-BE49-F238E27FC236}">
-                <a16:creationId xmlns:a16="http://schemas.microsoft.com/office/drawing/2014/main" id="{C6E9FCD8-0A87-4D22-8F58-A4DF0908B2CD}"/>
+                <a16:creationId xmlns:a16="http://schemas.microsoft.com/office/drawing/2014/main" id="{13EAD3D3-C645-4425-BF42-75BB2AF041F5}"/>
               </a:ext>
             </a:extLst>
           </p:cNvPr>
@@ -4575,7 +4575,7 @@
           <p:cNvPr id="6" name="architecture-node-0">
             <a:extLst xmlns:a="http://schemas.openxmlformats.org/drawingml/2006/main">
               <a:ext uri="{FF2B5EF4-FFF2-40B4-BE49-F238E27FC236}">
-                <a16:creationId xmlns:a16="http://schemas.microsoft.com/office/drawing/2014/main" id="{55889C1D-D384-4631-9E65-6A47650F1E6E}"/>
+                <a16:creationId xmlns:a16="http://schemas.microsoft.com/office/drawing/2014/main" id="{E3E42744-DBC2-4CFD-9513-64CC2AB3353F}"/>
               </a:ext>
             </a:extLst>
           </p:cNvPr>
@@ -4608,7 +4608,7 @@
           <p:cNvPr id="7" name="architecture-a-0">
             <a:extLst xmlns:a="http://schemas.openxmlformats.org/drawingml/2006/main">
               <a:ext uri="{FF2B5EF4-FFF2-40B4-BE49-F238E27FC236}">
-                <a16:creationId xmlns:a16="http://schemas.microsoft.com/office/drawing/2014/main" id="{624296DA-AD2F-418B-9FBB-1A189F0C334A}"/>
+                <a16:creationId xmlns:a16="http://schemas.microsoft.com/office/drawing/2014/main" id="{3DE0BB9C-380F-4DBC-9DEE-D4C389FEAAD3}"/>
               </a:ext>
             </a:extLst>
           </p:cNvPr>
@@ -4665,7 +4665,7 @@
           <p:cNvPr id="8" name="architecture-b-0">
             <a:extLst xmlns:a="http://schemas.openxmlformats.org/drawingml/2006/main">
               <a:ext uri="{FF2B5EF4-FFF2-40B4-BE49-F238E27FC236}">
-                <a16:creationId xmlns:a16="http://schemas.microsoft.com/office/drawing/2014/main" id="{BB148FAC-154D-4B85-8B3E-6346A8F6D8B2}"/>
+                <a16:creationId xmlns:a16="http://schemas.microsoft.com/office/drawing/2014/main" id="{3615F8C7-F6A9-45FA-8B73-52EB444095C4}"/>
               </a:ext>
             </a:extLst>
           </p:cNvPr>
@@ -4745,7 +4745,7 @@
           <p:cNvPr id="9" name="architecture-title-1">
             <a:extLst xmlns:a="http://schemas.openxmlformats.org/drawingml/2006/main">
               <a:ext uri="{FF2B5EF4-FFF2-40B4-BE49-F238E27FC236}">
-                <a16:creationId xmlns:a16="http://schemas.microsoft.com/office/drawing/2014/main" id="{7BD81F31-0A9C-4789-911A-7A12A35E0071}"/>
+                <a16:creationId xmlns:a16="http://schemas.microsoft.com/office/drawing/2014/main" id="{E12C8230-1220-476C-AB94-DC21FCBA6490}"/>
               </a:ext>
             </a:extLst>
           </p:cNvPr>
@@ -4802,7 +4802,7 @@
           <p:cNvPr id="10" name="architecture-node-1">
             <a:extLst xmlns:a="http://schemas.openxmlformats.org/drawingml/2006/main">
               <a:ext uri="{FF2B5EF4-FFF2-40B4-BE49-F238E27FC236}">
-                <a16:creationId xmlns:a16="http://schemas.microsoft.com/office/drawing/2014/main" id="{04898307-F0C9-41D8-A4BE-93DCEC6CB61E}"/>
+                <a16:creationId xmlns:a16="http://schemas.microsoft.com/office/drawing/2014/main" id="{2A7EDC58-EDD7-439E-9206-A641F1075082}"/>
               </a:ext>
             </a:extLst>
           </p:cNvPr>
@@ -4835,7 +4835,7 @@
           <p:cNvPr id="11" name="architecture-a-1">
             <a:extLst xmlns:a="http://schemas.openxmlformats.org/drawingml/2006/main">
               <a:ext uri="{FF2B5EF4-FFF2-40B4-BE49-F238E27FC236}">
-                <a16:creationId xmlns:a16="http://schemas.microsoft.com/office/drawing/2014/main" id="{0A8D71A5-A691-4B42-909A-0C50E6BF4509}"/>
+                <a16:creationId xmlns:a16="http://schemas.microsoft.com/office/drawing/2014/main" id="{36285D06-07BD-4C60-A82D-3DC2559D4694}"/>
               </a:ext>
             </a:extLst>
           </p:cNvPr>
@@ -4892,7 +4892,7 @@
           <p:cNvPr id="12" name="architecture-b-1">
             <a:extLst xmlns:a="http://schemas.openxmlformats.org/drawingml/2006/main">
               <a:ext uri="{FF2B5EF4-FFF2-40B4-BE49-F238E27FC236}">
-                <a16:creationId xmlns:a16="http://schemas.microsoft.com/office/drawing/2014/main" id="{873A2D15-A498-44A8-8266-B85C805FFC2F}"/>
+                <a16:creationId xmlns:a16="http://schemas.microsoft.com/office/drawing/2014/main" id="{B86563AF-B4D0-433E-B141-C271D59478F9}"/>
               </a:ext>
             </a:extLst>
           </p:cNvPr>
@@ -4972,7 +4972,7 @@
           <p:cNvPr id="13" name="architecture-title-2">
             <a:extLst xmlns:a="http://schemas.openxmlformats.org/drawingml/2006/main">
               <a:ext uri="{FF2B5EF4-FFF2-40B4-BE49-F238E27FC236}">
-                <a16:creationId xmlns:a16="http://schemas.microsoft.com/office/drawing/2014/main" id="{C8E11428-77D6-4A87-9247-DDC4A27F5625}"/>
+                <a16:creationId xmlns:a16="http://schemas.microsoft.com/office/drawing/2014/main" id="{FC05E874-FA0A-45F2-A3B1-7398C0517C6D}"/>
               </a:ext>
             </a:extLst>
           </p:cNvPr>
@@ -5029,7 +5029,7 @@
           <p:cNvPr id="14" name="architecture-node-2">
             <a:extLst xmlns:a="http://schemas.openxmlformats.org/drawingml/2006/main">
               <a:ext uri="{FF2B5EF4-FFF2-40B4-BE49-F238E27FC236}">
-                <a16:creationId xmlns:a16="http://schemas.microsoft.com/office/drawing/2014/main" id="{9BF1A729-38AF-45F2-A2FC-2F1A5053940E}"/>
+                <a16:creationId xmlns:a16="http://schemas.microsoft.com/office/drawing/2014/main" id="{E44F0E01-B712-4EC9-9984-B5800924AD1C}"/>
               </a:ext>
             </a:extLst>
           </p:cNvPr>
@@ -5062,7 +5062,7 @@
           <p:cNvPr id="15" name="architecture-a-2">
             <a:extLst xmlns:a="http://schemas.openxmlformats.org/drawingml/2006/main">
               <a:ext uri="{FF2B5EF4-FFF2-40B4-BE49-F238E27FC236}">
-                <a16:creationId xmlns:a16="http://schemas.microsoft.com/office/drawing/2014/main" id="{0E337A7D-B9E7-4357-8DB7-E457533120FB}"/>
+                <a16:creationId xmlns:a16="http://schemas.microsoft.com/office/drawing/2014/main" id="{762FC23E-13DE-4E60-9CFA-393C1EC67569}"/>
               </a:ext>
             </a:extLst>
           </p:cNvPr>
@@ -5119,7 +5119,7 @@
           <p:cNvPr id="16" name="architecture-b-2">
             <a:extLst xmlns:a="http://schemas.openxmlformats.org/drawingml/2006/main">
               <a:ext uri="{FF2B5EF4-FFF2-40B4-BE49-F238E27FC236}">
-                <a16:creationId xmlns:a16="http://schemas.microsoft.com/office/drawing/2014/main" id="{93D92462-F5B8-4CF3-81A4-7051CAC78367}"/>
+                <a16:creationId xmlns:a16="http://schemas.microsoft.com/office/drawing/2014/main" id="{78C79C47-0393-4B77-A3CC-DB9A6DBA0698}"/>
               </a:ext>
             </a:extLst>
           </p:cNvPr>
@@ -5176,7 +5176,7 @@
           <p:cNvPr id="17" name="architecture-title-3">
             <a:extLst xmlns:a="http://schemas.openxmlformats.org/drawingml/2006/main">
               <a:ext uri="{FF2B5EF4-FFF2-40B4-BE49-F238E27FC236}">
-                <a16:creationId xmlns:a16="http://schemas.microsoft.com/office/drawing/2014/main" id="{BA8B85E7-F26A-43E1-BD89-05F0CA7C48D0}"/>
+                <a16:creationId xmlns:a16="http://schemas.microsoft.com/office/drawing/2014/main" id="{6C9394D0-2B49-4310-9C28-375F011C51B5}"/>
               </a:ext>
             </a:extLst>
           </p:cNvPr>
@@ -5233,7 +5233,7 @@
           <p:cNvPr id="18" name="architecture-node-3">
             <a:extLst xmlns:a="http://schemas.openxmlformats.org/drawingml/2006/main">
               <a:ext uri="{FF2B5EF4-FFF2-40B4-BE49-F238E27FC236}">
-                <a16:creationId xmlns:a16="http://schemas.microsoft.com/office/drawing/2014/main" id="{637573FC-84C9-4B73-9C9C-006A77E0188D}"/>
+                <a16:creationId xmlns:a16="http://schemas.microsoft.com/office/drawing/2014/main" id="{728BDFFF-D662-4C9D-B066-EB6EDA161A5D}"/>
               </a:ext>
             </a:extLst>
           </p:cNvPr>
@@ -5266,7 +5266,7 @@
           <p:cNvPr id="19" name="architecture-a-3">
             <a:extLst xmlns:a="http://schemas.openxmlformats.org/drawingml/2006/main">
               <a:ext uri="{FF2B5EF4-FFF2-40B4-BE49-F238E27FC236}">
-                <a16:creationId xmlns:a16="http://schemas.microsoft.com/office/drawing/2014/main" id="{7749F1C6-382C-43EE-8A44-52F60D03C35D}"/>
+                <a16:creationId xmlns:a16="http://schemas.microsoft.com/office/drawing/2014/main" id="{55A06379-0591-43D6-81CB-2AD354A8A59C}"/>
               </a:ext>
             </a:extLst>
           </p:cNvPr>
@@ -5323,7 +5323,7 @@
           <p:cNvPr id="20" name="architecture-b-3">
             <a:extLst xmlns:a="http://schemas.openxmlformats.org/drawingml/2006/main">
               <a:ext uri="{FF2B5EF4-FFF2-40B4-BE49-F238E27FC236}">
-                <a16:creationId xmlns:a16="http://schemas.microsoft.com/office/drawing/2014/main" id="{6BA2F42E-00F2-4530-99D6-3CB90A3D61B2}"/>
+                <a16:creationId xmlns:a16="http://schemas.microsoft.com/office/drawing/2014/main" id="{B3A34F5A-D3ED-4108-93C0-82D42DC6AAC5}"/>
               </a:ext>
             </a:extLst>
           </p:cNvPr>
@@ -5481,7 +5481,7 @@
           <p:cNvPr id="24" name="auth-note">
             <a:extLst xmlns:a="http://schemas.openxmlformats.org/drawingml/2006/main">
               <a:ext uri="{FF2B5EF4-FFF2-40B4-BE49-F238E27FC236}">
-                <a16:creationId xmlns:a16="http://schemas.microsoft.com/office/drawing/2014/main" id="{CA7BD35E-AA38-44BB-A60D-CF3A69F51D86}"/>
+                <a16:creationId xmlns:a16="http://schemas.microsoft.com/office/drawing/2014/main" id="{94AC8561-EC68-4B9C-8F94-E7FA9935335B}"/>
               </a:ext>
             </a:extLst>
           </p:cNvPr>
@@ -5538,7 +5538,7 @@
           <p:cNvPr id="25" name="footer">
             <a:extLst xmlns:a="http://schemas.openxmlformats.org/drawingml/2006/main">
               <a:ext uri="{FF2B5EF4-FFF2-40B4-BE49-F238E27FC236}">
-                <a16:creationId xmlns:a16="http://schemas.microsoft.com/office/drawing/2014/main" id="{D1C2BC23-6621-4AF1-9873-33C90EB7C5C9}"/>
+                <a16:creationId xmlns:a16="http://schemas.microsoft.com/office/drawing/2014/main" id="{EDE85DBE-2A82-49F9-99AA-38092E4A245A}"/>
               </a:ext>
             </a:extLst>
           </p:cNvPr>
@@ -5593,7 +5593,7 @@
     </p:spTree>
     <p:extLst>
       <p:ext uri="{BB962C8B-B14F-4D97-AF65-F5344CB8AC3E}">
-        <p14:creationId xmlns:p14="http://schemas.microsoft.com/office/powerpoint/2010/main" val="1089092642"/>
+        <p14:creationId xmlns:p14="http://schemas.microsoft.com/office/powerpoint/2010/main" val="259581855"/>
       </p:ext>
     </p:extLst>
   </p:cSld>
@@ -5624,7 +5624,7 @@
           <p:cNvPr id="8" name="wordmark">
             <a:extLst xmlns:a="http://schemas.openxmlformats.org/drawingml/2006/main">
               <a:ext uri="{FF2B5EF4-FFF2-40B4-BE49-F238E27FC236}">
-                <a16:creationId xmlns:a16="http://schemas.microsoft.com/office/drawing/2014/main" id="{F128CE38-BC4D-4658-A2FB-938D7192EFEB}"/>
+                <a16:creationId xmlns:a16="http://schemas.microsoft.com/office/drawing/2014/main" id="{806DDE89-1032-454D-AE14-A3082360CD57}"/>
               </a:ext>
             </a:extLst>
           </p:cNvPr>
@@ -5681,7 +5681,7 @@
           <p:cNvPr id="2" name="page">
             <a:extLst xmlns:a="http://schemas.openxmlformats.org/drawingml/2006/main">
               <a:ext uri="{FF2B5EF4-FFF2-40B4-BE49-F238E27FC236}">
-                <a16:creationId xmlns:a16="http://schemas.microsoft.com/office/drawing/2014/main" id="{21910729-D4A6-40F0-B5CA-C8FCFF26B713}"/>
+                <a16:creationId xmlns:a16="http://schemas.microsoft.com/office/drawing/2014/main" id="{BEAF1F9A-3E95-414A-913C-7E39920FDF6D}"/>
               </a:ext>
             </a:extLst>
           </p:cNvPr>
@@ -5738,7 +5738,7 @@
           <p:cNvPr id="3" name="title">
             <a:extLst xmlns:a="http://schemas.openxmlformats.org/drawingml/2006/main">
               <a:ext uri="{FF2B5EF4-FFF2-40B4-BE49-F238E27FC236}">
-                <a16:creationId xmlns:a16="http://schemas.microsoft.com/office/drawing/2014/main" id="{713C49E5-AAD9-4127-ABDE-C839BB23B076}"/>
+                <a16:creationId xmlns:a16="http://schemas.microsoft.com/office/drawing/2014/main" id="{C4609458-613F-479E-9A8F-F71AD1C75976}"/>
               </a:ext>
             </a:extLst>
           </p:cNvPr>
@@ -5795,7 +5795,7 @@
           <p:cNvPr id="4" name="subtitle">
             <a:extLst xmlns:a="http://schemas.openxmlformats.org/drawingml/2006/main">
               <a:ext uri="{FF2B5EF4-FFF2-40B4-BE49-F238E27FC236}">
-                <a16:creationId xmlns:a16="http://schemas.microsoft.com/office/drawing/2014/main" id="{574DBD55-D35A-4543-A8AD-197AF9AFBE61}"/>
+                <a16:creationId xmlns:a16="http://schemas.microsoft.com/office/drawing/2014/main" id="{91237964-57C7-4D1F-8738-06F14D5CA204}"/>
               </a:ext>
             </a:extLst>
           </p:cNvPr>
@@ -6090,7 +6090,7 @@
           <p:cNvPr id="6" name="our-focus">
             <a:extLst xmlns:a="http://schemas.openxmlformats.org/drawingml/2006/main">
               <a:ext uri="{FF2B5EF4-FFF2-40B4-BE49-F238E27FC236}">
-                <a16:creationId xmlns:a16="http://schemas.microsoft.com/office/drawing/2014/main" id="{9BDE79C2-26D0-4DED-B4F3-1499F1CFA5BA}"/>
+                <a16:creationId xmlns:a16="http://schemas.microsoft.com/office/drawing/2014/main" id="{D8C01E70-29B0-4A12-8940-05974ED8D815}"/>
               </a:ext>
             </a:extLst>
           </p:cNvPr>
@@ -6147,7 +6147,7 @@
           <p:cNvPr id="7" name="footer">
             <a:extLst xmlns:a="http://schemas.openxmlformats.org/drawingml/2006/main">
               <a:ext uri="{FF2B5EF4-FFF2-40B4-BE49-F238E27FC236}">
-                <a16:creationId xmlns:a16="http://schemas.microsoft.com/office/drawing/2014/main" id="{7BE3D881-0097-4682-B5FD-A0D2B5CC972D}"/>
+                <a16:creationId xmlns:a16="http://schemas.microsoft.com/office/drawing/2014/main" id="{A84A0C53-8485-465F-A54A-8DD713C420CF}"/>
               </a:ext>
             </a:extLst>
           </p:cNvPr>
@@ -6202,7 +6202,7 @@
     </p:spTree>
     <p:extLst>
       <p:ext uri="{BB962C8B-B14F-4D97-AF65-F5344CB8AC3E}">
-        <p14:creationId xmlns:p14="http://schemas.microsoft.com/office/powerpoint/2010/main" val="1573632205"/>
+        <p14:creationId xmlns:p14="http://schemas.microsoft.com/office/powerpoint/2010/main" val="1442718416"/>
       </p:ext>
     </p:extLst>
   </p:cSld>
@@ -6233,7 +6233,7 @@
           <p:cNvPr id="12" name="wordmark">
             <a:extLst xmlns:a="http://schemas.openxmlformats.org/drawingml/2006/main">
               <a:ext uri="{FF2B5EF4-FFF2-40B4-BE49-F238E27FC236}">
-                <a16:creationId xmlns:a16="http://schemas.microsoft.com/office/drawing/2014/main" id="{FD77CB3A-ADE1-42CC-8A08-5538ACF12172}"/>
+                <a16:creationId xmlns:a16="http://schemas.microsoft.com/office/drawing/2014/main" id="{10468E9B-CF12-41D5-A9EB-A7F56A81645B}"/>
               </a:ext>
             </a:extLst>
           </p:cNvPr>
@@ -6290,7 +6290,7 @@
           <p:cNvPr id="2" name="page">
             <a:extLst xmlns:a="http://schemas.openxmlformats.org/drawingml/2006/main">
               <a:ext uri="{FF2B5EF4-FFF2-40B4-BE49-F238E27FC236}">
-                <a16:creationId xmlns:a16="http://schemas.microsoft.com/office/drawing/2014/main" id="{38B0BFC2-D236-4D36-BD77-31998F9DD923}"/>
+                <a16:creationId xmlns:a16="http://schemas.microsoft.com/office/drawing/2014/main" id="{5DDE15FD-8BE1-459B-80B1-B6B14B82CED7}"/>
               </a:ext>
             </a:extLst>
           </p:cNvPr>
@@ -6347,7 +6347,7 @@
           <p:cNvPr id="3" name="title">
             <a:extLst xmlns:a="http://schemas.openxmlformats.org/drawingml/2006/main">
               <a:ext uri="{FF2B5EF4-FFF2-40B4-BE49-F238E27FC236}">
-                <a16:creationId xmlns:a16="http://schemas.microsoft.com/office/drawing/2014/main" id="{B09A34E4-DD72-43A2-A331-847E6BE12646}"/>
+                <a16:creationId xmlns:a16="http://schemas.microsoft.com/office/drawing/2014/main" id="{E064BF2C-7C6D-4CA4-B57E-C2141AF7BE3F}"/>
               </a:ext>
             </a:extLst>
           </p:cNvPr>
@@ -6404,7 +6404,7 @@
           <p:cNvPr id="4" name="subtitle">
             <a:extLst xmlns:a="http://schemas.openxmlformats.org/drawingml/2006/main">
               <a:ext uri="{FF2B5EF4-FFF2-40B4-BE49-F238E27FC236}">
-                <a16:creationId xmlns:a16="http://schemas.microsoft.com/office/drawing/2014/main" id="{888C70C4-B1E9-497D-975D-B71AA08922BD}"/>
+                <a16:creationId xmlns:a16="http://schemas.microsoft.com/office/drawing/2014/main" id="{7DE5EBC1-95B9-4EE5-98B5-4687DFE8C5E2}"/>
               </a:ext>
             </a:extLst>
           </p:cNvPr>
@@ -6461,7 +6461,7 @@
           <p:cNvPr id="5" name="price">
             <a:extLst xmlns:a="http://schemas.openxmlformats.org/drawingml/2006/main">
               <a:ext uri="{FF2B5EF4-FFF2-40B4-BE49-F238E27FC236}">
-                <a16:creationId xmlns:a16="http://schemas.microsoft.com/office/drawing/2014/main" id="{F73B52F8-5CAF-4338-BB10-994A730A13A0}"/>
+                <a16:creationId xmlns:a16="http://schemas.microsoft.com/office/drawing/2014/main" id="{CECE0B03-DB29-4841-B3DF-F9ADB7B323C1}"/>
               </a:ext>
             </a:extLst>
           </p:cNvPr>
@@ -6518,7 +6518,7 @@
           <p:cNvPr id="6" name="price-unit">
             <a:extLst xmlns:a="http://schemas.openxmlformats.org/drawingml/2006/main">
               <a:ext uri="{FF2B5EF4-FFF2-40B4-BE49-F238E27FC236}">
-                <a16:creationId xmlns:a16="http://schemas.microsoft.com/office/drawing/2014/main" id="{CBA2DD68-02AE-4813-B69E-AEBDF5AE6B6E}"/>
+                <a16:creationId xmlns:a16="http://schemas.microsoft.com/office/drawing/2014/main" id="{02D269CC-1B8D-4106-A6AD-B277BC0CDAC6}"/>
               </a:ext>
             </a:extLst>
           </p:cNvPr>
@@ -6575,7 +6575,7 @@
           <p:cNvPr id="7" name="hypothesis-label">
             <a:extLst xmlns:a="http://schemas.openxmlformats.org/drawingml/2006/main">
               <a:ext uri="{FF2B5EF4-FFF2-40B4-BE49-F238E27FC236}">
-                <a16:creationId xmlns:a16="http://schemas.microsoft.com/office/drawing/2014/main" id="{182D9375-B804-4642-BEB8-E5084496D5F8}"/>
+                <a16:creationId xmlns:a16="http://schemas.microsoft.com/office/drawing/2014/main" id="{C1EA4F4E-B4D2-4EDF-83A1-2BF797795A02}"/>
               </a:ext>
             </a:extLst>
           </p:cNvPr>
@@ -6632,7 +6632,7 @@
           <p:cNvPr id="8" name="business-benefit">
             <a:extLst xmlns:a="http://schemas.openxmlformats.org/drawingml/2006/main">
               <a:ext uri="{FF2B5EF4-FFF2-40B4-BE49-F238E27FC236}">
-                <a16:creationId xmlns:a16="http://schemas.microsoft.com/office/drawing/2014/main" id="{9B87607F-54BC-46B8-8CA8-2424CEE45072}"/>
+                <a16:creationId xmlns:a16="http://schemas.microsoft.com/office/drawing/2014/main" id="{320E8834-B74C-4D8B-B732-9910621B9625}"/>
               </a:ext>
             </a:extLst>
           </p:cNvPr>
@@ -6689,7 +6689,7 @@
           <p:cNvPr id="9" name="business-rationale">
             <a:extLst xmlns:a="http://schemas.openxmlformats.org/drawingml/2006/main">
               <a:ext uri="{FF2B5EF4-FFF2-40B4-BE49-F238E27FC236}">
-                <a16:creationId xmlns:a16="http://schemas.microsoft.com/office/drawing/2014/main" id="{092A3CF7-22EA-4C35-9F4B-EA393CC34F05}"/>
+                <a16:creationId xmlns:a16="http://schemas.microsoft.com/office/drawing/2014/main" id="{7B3CF57A-4187-4395-8BA4-B2D4E1AA7940}"/>
               </a:ext>
             </a:extLst>
           </p:cNvPr>
@@ -6769,7 +6769,7 @@
           <p:cNvPr id="10" name="cost-discipline">
             <a:extLst xmlns:a="http://schemas.openxmlformats.org/drawingml/2006/main">
               <a:ext uri="{FF2B5EF4-FFF2-40B4-BE49-F238E27FC236}">
-                <a16:creationId xmlns:a16="http://schemas.microsoft.com/office/drawing/2014/main" id="{8BA615F7-F8E8-483B-BDB0-E93CAD1B4D88}"/>
+                <a16:creationId xmlns:a16="http://schemas.microsoft.com/office/drawing/2014/main" id="{296C98E0-3F67-4B15-B969-5AEACDB06550}"/>
               </a:ext>
             </a:extLst>
           </p:cNvPr>
@@ -6849,7 +6849,7 @@
           <p:cNvPr id="11" name="footer">
             <a:extLst xmlns:a="http://schemas.openxmlformats.org/drawingml/2006/main">
               <a:ext uri="{FF2B5EF4-FFF2-40B4-BE49-F238E27FC236}">
-                <a16:creationId xmlns:a16="http://schemas.microsoft.com/office/drawing/2014/main" id="{F93365D2-0372-4673-9B81-9EDED7CFF24C}"/>
+                <a16:creationId xmlns:a16="http://schemas.microsoft.com/office/drawing/2014/main" id="{916FCA1D-51FC-4704-A747-DCD3A056A7C9}"/>
               </a:ext>
             </a:extLst>
           </p:cNvPr>
@@ -6904,7 +6904,7 @@
     </p:spTree>
     <p:extLst>
       <p:ext uri="{BB962C8B-B14F-4D97-AF65-F5344CB8AC3E}">
-        <p14:creationId xmlns:p14="http://schemas.microsoft.com/office/powerpoint/2010/main" val="2021320905"/>
+        <p14:creationId xmlns:p14="http://schemas.microsoft.com/office/powerpoint/2010/main" val="2124090439"/>
       </p:ext>
     </p:extLst>
   </p:cSld>
@@ -6935,7 +6935,7 @@
           <p:cNvPr id="13" name="wordmark">
             <a:extLst xmlns:a="http://schemas.openxmlformats.org/drawingml/2006/main">
               <a:ext uri="{FF2B5EF4-FFF2-40B4-BE49-F238E27FC236}">
-                <a16:creationId xmlns:a16="http://schemas.microsoft.com/office/drawing/2014/main" id="{97A6D38B-2D7B-4B43-B6E9-B6DDF838DEA6}"/>
+                <a16:creationId xmlns:a16="http://schemas.microsoft.com/office/drawing/2014/main" id="{C280DCC9-9013-4120-97DF-8DCD352F0B02}"/>
               </a:ext>
             </a:extLst>
           </p:cNvPr>
@@ -6992,7 +6992,7 @@
           <p:cNvPr id="2" name="page">
             <a:extLst xmlns:a="http://schemas.openxmlformats.org/drawingml/2006/main">
               <a:ext uri="{FF2B5EF4-FFF2-40B4-BE49-F238E27FC236}">
-                <a16:creationId xmlns:a16="http://schemas.microsoft.com/office/drawing/2014/main" id="{6D1E56C2-4968-4662-BDA2-958B36BB7744}"/>
+                <a16:creationId xmlns:a16="http://schemas.microsoft.com/office/drawing/2014/main" id="{FC420BEA-623A-4B75-A4CE-56C4DE5D00A6}"/>
               </a:ext>
             </a:extLst>
           </p:cNvPr>
@@ -7049,7 +7049,7 @@
           <p:cNvPr id="3" name="title">
             <a:extLst xmlns:a="http://schemas.openxmlformats.org/drawingml/2006/main">
               <a:ext uri="{FF2B5EF4-FFF2-40B4-BE49-F238E27FC236}">
-                <a16:creationId xmlns:a16="http://schemas.microsoft.com/office/drawing/2014/main" id="{9353AB31-6D47-453F-A102-AEF99C66EAC0}"/>
+                <a16:creationId xmlns:a16="http://schemas.microsoft.com/office/drawing/2014/main" id="{240753B6-DA76-48EC-AC67-D33218373E87}"/>
               </a:ext>
             </a:extLst>
           </p:cNvPr>
@@ -7106,7 +7106,7 @@
           <p:cNvPr id="4" name="subtitle">
             <a:extLst xmlns:a="http://schemas.openxmlformats.org/drawingml/2006/main">
               <a:ext uri="{FF2B5EF4-FFF2-40B4-BE49-F238E27FC236}">
-                <a16:creationId xmlns:a16="http://schemas.microsoft.com/office/drawing/2014/main" id="{3B2ADD7B-D89B-49DD-8726-7163F12B2BF2}"/>
+                <a16:creationId xmlns:a16="http://schemas.microsoft.com/office/drawing/2014/main" id="{F305FF91-F45A-4B41-9D93-0BBBDBB8188C}"/>
               </a:ext>
             </a:extLst>
           </p:cNvPr>
@@ -7163,7 +7163,7 @@
           <p:cNvPr id="5" name="interviews-number">
             <a:extLst xmlns:a="http://schemas.openxmlformats.org/drawingml/2006/main">
               <a:ext uri="{FF2B5EF4-FFF2-40B4-BE49-F238E27FC236}">
-                <a16:creationId xmlns:a16="http://schemas.microsoft.com/office/drawing/2014/main" id="{BC780617-D8AB-4619-BAED-D4C88C6BCD34}"/>
+                <a16:creationId xmlns:a16="http://schemas.microsoft.com/office/drawing/2014/main" id="{4E465315-33B5-44A5-AE85-A7F56F353A2D}"/>
               </a:ext>
             </a:extLst>
           </p:cNvPr>
@@ -7220,7 +7220,7 @@
           <p:cNvPr id="6" name="interviews-label">
             <a:extLst xmlns:a="http://schemas.openxmlformats.org/drawingml/2006/main">
               <a:ext uri="{FF2B5EF4-FFF2-40B4-BE49-F238E27FC236}">
-                <a16:creationId xmlns:a16="http://schemas.microsoft.com/office/drawing/2014/main" id="{E906824E-522D-459F-BFF3-362E25BFC423}"/>
+                <a16:creationId xmlns:a16="http://schemas.microsoft.com/office/drawing/2014/main" id="{5FDA538A-B48B-4DEB-A759-62E4756DC891}"/>
               </a:ext>
             </a:extLst>
           </p:cNvPr>
@@ -7277,7 +7277,7 @@
           <p:cNvPr id="7" name="interviews-detail">
             <a:extLst xmlns:a="http://schemas.openxmlformats.org/drawingml/2006/main">
               <a:ext uri="{FF2B5EF4-FFF2-40B4-BE49-F238E27FC236}">
-                <a16:creationId xmlns:a16="http://schemas.microsoft.com/office/drawing/2014/main" id="{A85D9613-D8C6-4C2C-9E5D-13F242A58998}"/>
+                <a16:creationId xmlns:a16="http://schemas.microsoft.com/office/drawing/2014/main" id="{A1905CFE-6E0D-49C5-ADC0-087D1EFC4B00}"/>
               </a:ext>
             </a:extLst>
           </p:cNvPr>
@@ -7357,7 +7357,7 @@
           <p:cNvPr id="8" name="pilot-number">
             <a:extLst xmlns:a="http://schemas.openxmlformats.org/drawingml/2006/main">
               <a:ext uri="{FF2B5EF4-FFF2-40B4-BE49-F238E27FC236}">
-                <a16:creationId xmlns:a16="http://schemas.microsoft.com/office/drawing/2014/main" id="{4F700B15-FC76-42E2-9722-6AC855D9C805}"/>
+                <a16:creationId xmlns:a16="http://schemas.microsoft.com/office/drawing/2014/main" id="{A6E5043B-70ED-4E30-883F-170275750E13}"/>
               </a:ext>
             </a:extLst>
           </p:cNvPr>
@@ -7414,7 +7414,7 @@
           <p:cNvPr id="9" name="pilot-label">
             <a:extLst xmlns:a="http://schemas.openxmlformats.org/drawingml/2006/main">
               <a:ext uri="{FF2B5EF4-FFF2-40B4-BE49-F238E27FC236}">
-                <a16:creationId xmlns:a16="http://schemas.microsoft.com/office/drawing/2014/main" id="{E5B8EACD-5234-4BCC-8002-0CCFFF5B728A}"/>
+                <a16:creationId xmlns:a16="http://schemas.microsoft.com/office/drawing/2014/main" id="{9C888AA5-C541-4C52-8AE9-1B823A99D3D6}"/>
               </a:ext>
             </a:extLst>
           </p:cNvPr>
@@ -7471,7 +7471,7 @@
           <p:cNvPr id="10" name="pilot-detail">
             <a:extLst xmlns:a="http://schemas.openxmlformats.org/drawingml/2006/main">
               <a:ext uri="{FF2B5EF4-FFF2-40B4-BE49-F238E27FC236}">
-                <a16:creationId xmlns:a16="http://schemas.microsoft.com/office/drawing/2014/main" id="{794AF374-4089-4103-83C1-72852B937A6A}"/>
+                <a16:creationId xmlns:a16="http://schemas.microsoft.com/office/drawing/2014/main" id="{1A60F247-9FFC-4DBA-801C-E22382CA0DC7}"/>
               </a:ext>
             </a:extLst>
           </p:cNvPr>
@@ -7551,7 +7551,7 @@
           <p:cNvPr id="11" name="metric">
             <a:extLst xmlns:a="http://schemas.openxmlformats.org/drawingml/2006/main">
               <a:ext uri="{FF2B5EF4-FFF2-40B4-BE49-F238E27FC236}">
-                <a16:creationId xmlns:a16="http://schemas.microsoft.com/office/drawing/2014/main" id="{A844B9D8-8FBE-49BD-AA0C-DB28949AB72F}"/>
+                <a16:creationId xmlns:a16="http://schemas.microsoft.com/office/drawing/2014/main" id="{FE8FDE73-D4DE-4283-932F-59999E9F8D4B}"/>
               </a:ext>
             </a:extLst>
           </p:cNvPr>
@@ -7608,7 +7608,7 @@
           <p:cNvPr id="12" name="footer">
             <a:extLst xmlns:a="http://schemas.openxmlformats.org/drawingml/2006/main">
               <a:ext uri="{FF2B5EF4-FFF2-40B4-BE49-F238E27FC236}">
-                <a16:creationId xmlns:a16="http://schemas.microsoft.com/office/drawing/2014/main" id="{408EB4B8-A573-44C8-AC63-BABF2800A975}"/>
+                <a16:creationId xmlns:a16="http://schemas.microsoft.com/office/drawing/2014/main" id="{EF8272C2-FDA4-4E9D-B6D6-CF98B0784E21}"/>
               </a:ext>
             </a:extLst>
           </p:cNvPr>
@@ -7663,7 +7663,7 @@
     </p:spTree>
     <p:extLst>
       <p:ext uri="{BB962C8B-B14F-4D97-AF65-F5344CB8AC3E}">
-        <p14:creationId xmlns:p14="http://schemas.microsoft.com/office/powerpoint/2010/main" val="1031402545"/>
+        <p14:creationId xmlns:p14="http://schemas.microsoft.com/office/powerpoint/2010/main" val="1252115138"/>
       </p:ext>
     </p:extLst>
   </p:cSld>
@@ -7694,7 +7694,7 @@
           <p:cNvPr id="14" name="wordmark">
             <a:extLst xmlns:a="http://schemas.openxmlformats.org/drawingml/2006/main">
               <a:ext uri="{FF2B5EF4-FFF2-40B4-BE49-F238E27FC236}">
-                <a16:creationId xmlns:a16="http://schemas.microsoft.com/office/drawing/2014/main" id="{729D5284-392D-4C50-AD42-99E66838ED02}"/>
+                <a16:creationId xmlns:a16="http://schemas.microsoft.com/office/drawing/2014/main" id="{5200F918-6B20-4F5E-8AF3-D0B30CFC90BB}"/>
               </a:ext>
             </a:extLst>
           </p:cNvPr>
@@ -7751,7 +7751,7 @@
           <p:cNvPr id="2" name="page">
             <a:extLst xmlns:a="http://schemas.openxmlformats.org/drawingml/2006/main">
               <a:ext uri="{FF2B5EF4-FFF2-40B4-BE49-F238E27FC236}">
-                <a16:creationId xmlns:a16="http://schemas.microsoft.com/office/drawing/2014/main" id="{254CE4BC-738B-4B90-B6CD-D244C488DE1C}"/>
+                <a16:creationId xmlns:a16="http://schemas.microsoft.com/office/drawing/2014/main" id="{722D0AEA-D14A-4A45-A3B6-DFF75BC42FFF}"/>
               </a:ext>
             </a:extLst>
           </p:cNvPr>
@@ -7808,7 +7808,7 @@
           <p:cNvPr id="3" name="title">
             <a:extLst xmlns:a="http://schemas.openxmlformats.org/drawingml/2006/main">
               <a:ext uri="{FF2B5EF4-FFF2-40B4-BE49-F238E27FC236}">
-                <a16:creationId xmlns:a16="http://schemas.microsoft.com/office/drawing/2014/main" id="{6F8C4298-7036-4278-88E5-E1DDEB493476}"/>
+                <a16:creationId xmlns:a16="http://schemas.microsoft.com/office/drawing/2014/main" id="{6B866A17-8DAB-4C51-AF5F-A0BDAC1DBA7D}"/>
               </a:ext>
             </a:extLst>
           </p:cNvPr>
@@ -7865,7 +7865,7 @@
           <p:cNvPr id="4" name="subtitle">
             <a:extLst xmlns:a="http://schemas.openxmlformats.org/drawingml/2006/main">
               <a:ext uri="{FF2B5EF4-FFF2-40B4-BE49-F238E27FC236}">
-                <a16:creationId xmlns:a16="http://schemas.microsoft.com/office/drawing/2014/main" id="{1F48CE91-FC04-4599-B21C-B916903BEF36}"/>
+                <a16:creationId xmlns:a16="http://schemas.microsoft.com/office/drawing/2014/main" id="{F80A127F-301E-462D-A914-FB37A2A8B0E4}"/>
               </a:ext>
             </a:extLst>
           </p:cNvPr>
@@ -7922,7 +7922,7 @@
           <p:cNvPr id="5" name="next-label">
             <a:extLst xmlns:a="http://schemas.openxmlformats.org/drawingml/2006/main">
               <a:ext uri="{FF2B5EF4-FFF2-40B4-BE49-F238E27FC236}">
-                <a16:creationId xmlns:a16="http://schemas.microsoft.com/office/drawing/2014/main" id="{B8C68CC3-5818-4FE7-A457-AFF00CB4F36E}"/>
+                <a16:creationId xmlns:a16="http://schemas.microsoft.com/office/drawing/2014/main" id="{936348EE-11A4-4A97-AC13-88D07B34D01D}"/>
               </a:ext>
             </a:extLst>
           </p:cNvPr>
@@ -7979,7 +7979,7 @@
           <p:cNvPr id="6" name="next-one">
             <a:extLst xmlns:a="http://schemas.openxmlformats.org/drawingml/2006/main">
               <a:ext uri="{FF2B5EF4-FFF2-40B4-BE49-F238E27FC236}">
-                <a16:creationId xmlns:a16="http://schemas.microsoft.com/office/drawing/2014/main" id="{809C9CDB-0FCC-4995-89DF-258C3164DB6D}"/>
+                <a16:creationId xmlns:a16="http://schemas.microsoft.com/office/drawing/2014/main" id="{EC099F24-4298-449C-BDB9-CB7B5AE2A7B6}"/>
               </a:ext>
             </a:extLst>
           </p:cNvPr>
@@ -8025,7 +8025,7 @@
                 <a:latin typeface="Noto Sans"/>
                 <a:ea typeface="Noto Sans"/>
                 <a:cs typeface="Noto Sans"/>
-                <a:hlinkClick xmlns:r="http://schemas.openxmlformats.org/officeDocument/2006/relationships" r:id="Rdcd73f6c65694d80"/>
+                <a:hlinkClick xmlns:r="http://schemas.openxmlformats.org/officeDocument/2006/relationships" r:id="Rb7b4c90566ac4654"/>
               </a:rPr>
               <a:t>Watch the public 2:49 demo</a:t>
             </a:r>
@@ -8037,7 +8037,7 @@
           <p:cNvPr id="7" name="next-two">
             <a:extLst xmlns:a="http://schemas.openxmlformats.org/drawingml/2006/main">
               <a:ext uri="{FF2B5EF4-FFF2-40B4-BE49-F238E27FC236}">
-                <a16:creationId xmlns:a16="http://schemas.microsoft.com/office/drawing/2014/main" id="{01900653-7678-4A3C-8D5A-4542A97EB5EB}"/>
+                <a16:creationId xmlns:a16="http://schemas.microsoft.com/office/drawing/2014/main" id="{78049227-69E6-4497-AA1F-E53053E1AB44}"/>
               </a:ext>
             </a:extLst>
           </p:cNvPr>
@@ -8094,7 +8094,7 @@
           <p:cNvPr id="8" name="next-three">
             <a:extLst xmlns:a="http://schemas.openxmlformats.org/drawingml/2006/main">
               <a:ext uri="{FF2B5EF4-FFF2-40B4-BE49-F238E27FC236}">
-                <a16:creationId xmlns:a16="http://schemas.microsoft.com/office/drawing/2014/main" id="{4683DEF2-FEA7-471E-A8A1-6FC8D105B260}"/>
+                <a16:creationId xmlns:a16="http://schemas.microsoft.com/office/drawing/2014/main" id="{CDF2DAC9-5B8A-4675-98D8-0082141E2C48}"/>
               </a:ext>
             </a:extLst>
           </p:cNvPr>
@@ -8151,7 +8151,7 @@
           <p:cNvPr id="9" name="contribution-label">
             <a:extLst xmlns:a="http://schemas.openxmlformats.org/drawingml/2006/main">
               <a:ext uri="{FF2B5EF4-FFF2-40B4-BE49-F238E27FC236}">
-                <a16:creationId xmlns:a16="http://schemas.microsoft.com/office/drawing/2014/main" id="{2AA8DD40-D09D-45D3-B184-B70238652B1D}"/>
+                <a16:creationId xmlns:a16="http://schemas.microsoft.com/office/drawing/2014/main" id="{57FDB631-6321-4F4C-ADF2-98D5B04F8E99}"/>
               </a:ext>
             </a:extLst>
           </p:cNvPr>
@@ -8208,7 +8208,7 @@
           <p:cNvPr id="10" name="contribution-name">
             <a:extLst xmlns:a="http://schemas.openxmlformats.org/drawingml/2006/main">
               <a:ext uri="{FF2B5EF4-FFF2-40B4-BE49-F238E27FC236}">
-                <a16:creationId xmlns:a16="http://schemas.microsoft.com/office/drawing/2014/main" id="{AF3EF428-C006-41AB-8D41-68A5B24E823B}"/>
+                <a16:creationId xmlns:a16="http://schemas.microsoft.com/office/drawing/2014/main" id="{F1328697-5E30-40AA-A4C9-7EEFC6D4F741}"/>
               </a:ext>
             </a:extLst>
           </p:cNvPr>
@@ -8254,7 +8254,7 @@
                 <a:latin typeface="Noto Sans"/>
                 <a:ea typeface="Noto Sans"/>
                 <a:cs typeface="Noto Sans"/>
-                <a:hlinkClick xmlns:r="http://schemas.openxmlformats.org/officeDocument/2006/relationships" r:id="Rada79a93e47a42ac"/>
+                <a:hlinkClick xmlns:r="http://schemas.openxmlformats.org/officeDocument/2006/relationships" r:id="R6269c65f580e4328"/>
               </a:rPr>
               <a:t>@kindhandoff/guard</a:t>
             </a:r>
@@ -8266,7 +8266,7 @@
           <p:cNvPr id="11" name="contribution-role">
             <a:extLst xmlns:a="http://schemas.openxmlformats.org/drawingml/2006/main">
               <a:ext uri="{FF2B5EF4-FFF2-40B4-BE49-F238E27FC236}">
-                <a16:creationId xmlns:a16="http://schemas.microsoft.com/office/drawing/2014/main" id="{580A06AE-4871-4E78-8E0E-AD2C57A1E58A}"/>
+                <a16:creationId xmlns:a16="http://schemas.microsoft.com/office/drawing/2014/main" id="{2351D231-CC11-4BB7-A256-260F98B0C188}"/>
               </a:ext>
             </a:extLst>
           </p:cNvPr>
@@ -8369,7 +8369,7 @@
           <p:cNvPr id="12" name="repo-link">
             <a:extLst xmlns:a="http://schemas.openxmlformats.org/drawingml/2006/main">
               <a:ext uri="{FF2B5EF4-FFF2-40B4-BE49-F238E27FC236}">
-                <a16:creationId xmlns:a16="http://schemas.microsoft.com/office/drawing/2014/main" id="{EDCE25A1-ED02-4DA8-9B25-6991598D61A7}"/>
+                <a16:creationId xmlns:a16="http://schemas.microsoft.com/office/drawing/2014/main" id="{F6677AC9-5D50-4B66-B5AA-8B6542098B71}"/>
               </a:ext>
             </a:extLst>
           </p:cNvPr>
@@ -8415,7 +8415,7 @@
                 <a:latin typeface="Noto Sans"/>
                 <a:ea typeface="Noto Sans"/>
                 <a:cs typeface="Noto Sans"/>
-                <a:hlinkClick xmlns:r="http://schemas.openxmlformats.org/officeDocument/2006/relationships" r:id="Rbdd64eef39de4017"/>
+                <a:hlinkClick xmlns:r="http://schemas.openxmlformats.org/officeDocument/2006/relationships" r:id="R94aed7722e9248dd"/>
               </a:rPr>
               <a:t>github.com/shi1720/Amazon-Developer-Hackathon</a:t>
             </a:r>
@@ -8427,7 +8427,7 @@
           <p:cNvPr id="13" name="hosted-url">
             <a:extLst xmlns:a="http://schemas.openxmlformats.org/drawingml/2006/main">
               <a:ext uri="{FF2B5EF4-FFF2-40B4-BE49-F238E27FC236}">
-                <a16:creationId xmlns:a16="http://schemas.microsoft.com/office/drawing/2014/main" id="{C316A054-D149-48D8-AEF0-7B8EC26B51C5}"/>
+                <a16:creationId xmlns:a16="http://schemas.microsoft.com/office/drawing/2014/main" id="{B67D6419-ED9E-489C-AC32-A4F1F406CB0B}"/>
               </a:ext>
             </a:extLst>
           </p:cNvPr>
@@ -8473,7 +8473,7 @@
                 <a:latin typeface="Noto Sans"/>
                 <a:ea typeface="Noto Sans"/>
                 <a:cs typeface="Noto Sans"/>
-                <a:hlinkClick xmlns:r="http://schemas.openxmlformats.org/officeDocument/2006/relationships" r:id="Rd39270319c1e43d2"/>
+                <a:hlinkClick xmlns:r="http://schemas.openxmlformats.org/officeDocument/2006/relationships" r:id="R5521f5c1d94d4c9e"/>
               </a:rPr>
               <a:t>Verified public app: kindhandoff.web.app</a:t>
             </a:r>
@@ -8483,7 +8483,7 @@
     </p:spTree>
     <p:extLst>
       <p:ext uri="{BB962C8B-B14F-4D97-AF65-F5344CB8AC3E}">
-        <p14:creationId xmlns:p14="http://schemas.microsoft.com/office/powerpoint/2010/main" val="700910041"/>
+        <p14:creationId xmlns:p14="http://schemas.microsoft.com/office/powerpoint/2010/main" val="130003046"/>
       </p:ext>
     </p:extLst>
   </p:cSld>

</xml_diff>